<commit_message>
Presentation at 15 minutes covering Stage 7 and the feedback; pytest output at 68 tests
</commit_message>
<xml_diff>
--- a/presentation/Research_Agent_Presentation.pptx
+++ b/presentation/Research_Agent_Presentation.pptx
@@ -511,7 +511,7 @@
           <a:p>
             <a:r>
               <a:rPr lang="en-US" dirty="0"/>
-              <a:t>Hello, and thanks for watching. This is my individual project for the Intelligent Agents module. Earlier in the module our group designed a research agent on paper; my job here was to build it. It takes a research question and turns it into an evidence brief that a researcher can check line by line. I'll cover what the design asked for, how I built it, show it running, then testing, what went wrong, and where it still falls short. The code, tests, logs and README are all in the GitHub repository on the slide.</a:t>
+              <a:t>Hello, and thanks for watching. This is my individual project for the Intelligent Agents module. Earlier in the module our group designed a research agent on paper. My job here was to build it, test it, and then, once that design had been marked, act on the feedback. The system takes a research question and turns it into an evidence brief that a researcher can check line by line. Over the next fifteen minutes I'll cover what the design asked for, how I built it, show it running on a real question, go through the testing, what went wrong along the way, what I changed after the tutor's feedback, and where it still falls short. The code, the tests, the logs and the README are all in the GitHub repository on the slide.</a:t>
             </a:r>
             <a:endParaRPr lang="en-US" dirty="0"/>
           </a:p>
@@ -599,9 +599,9 @@
           <a:p>
             <a:r>
               <a:rPr lang="en-US" dirty="0"/>
-              <a:t>To finish, a fair comparison with the design. Where it matters, the implementation matches: the three agents, the orchestrator, the four data classes and the decision enum, both review points, both autonomy limits, Crossref checking that flags but never drops, and the brief with notes, themes, gaps, limitations and references.
-It departs in three places. I added a second retry trigger after scoring, because a search can return twenty perfect abstracts of which only one answers the question, and a count-based threshold can't see that. I added a shared retry policy the design never mentioned, because the services forced it. And I kept the previous query on each sub-question so the brief can show both.
-The limits are real. One source, abstracts only, twenty per query. The Lite model is a more generous judge, forty-two papers kept against twenty-six on the same question, so the cut-off probably needs tuning per model. And one retry took a thin sub-question from one paper to three, not five. Next would be a DataCite lookup for arXiv DOIs, a second source, and full text where it's open. Everything is in the repository, and the README explains how to run it. Thank you for listening.</a:t>
+              <a:t>To finish, a fair comparison with the design, and what changed after the feedback. Where it matters, the implementation matches: the three agents, the orchestrator, the four data classes and the decision enum, both review points, both autonomy limits, Crossref checking that flags but never drops, and the brief with notes, themes, gaps, limitations and references. Three small departures: a second retry trigger after scoring, because a search can return twenty perfect abstracts of which only one answers the question; a shared retry policy the design never mentioned, because the services forced it; and the previous query kept on each sub-question so the brief can show both.
+The feedback had three points, and each has an answer. The model choice is now justified with the provider's own figures - a million-token context against prompts of twelve thousand, structured output supported, five hundred requests a day on the free tier, thirty cents per million input tokens, and the benchmark scores, with the caveat that none of them measures abstract screening. The test targets are stated honestly, as I said: what is measured, what is not, and what a gold set would have to look like. And the third point was built: two sources for every search, failover between them, seventy-eight papers becoming a hundred and seventeen on the same question.
+The limits are real. Abstracts only, twenty per query per source. The Lite model is a more generous judge than the full Flash model, forty-two papers kept against twenty-six on the same question, so the cut-off needs calibrating per model. A paper published under two DOIs is still not merged. And without a key, Semantic Scholar's public pool refuses more than it answers. Next would be a DataCite lookup for the preprints, a labelled set so recall and precision can finally be measured, and full text where it is open. Everything is in the repository, and the README explains how to run it. Thank you for listening.</a:t>
             </a:r>
             <a:endParaRPr lang="en-US" dirty="0"/>
           </a:p>
@@ -690,7 +690,8 @@
             <a:r>
               <a:rPr lang="en-US" dirty="0"/>
               <a:t>The starting point was our Group D design proposal. A research question goes in, a traceable evidence brief comes out. The design pinned down quite a lot before any code existed: three specialised agents and a coordinator that is deliberately not an agent; two human reviews, first of the plan and then of the evidence; every DOI checked against Crossref before it can be cited; limited autonomy, meaning one automatic retry of a query per sub-question and one scope revision per run; and a brief that has to say what it could not cover.
-All of that comes from one fear. Ask a language model for literature and it will give you plausible papers that don't exist. So in this system the model never writes a reference. It breaks questions down, scores relevance and summarises abstracts, and that's all. Anything with an exact answer, de-duplication, DOI checks, the reference list, is plain code. My task was to build that, test it, and show it working.</a:t>
+All of that comes from one fear. Ask a language model for literature and it will give you plausible papers that don't exist. So in this system the model never writes a reference. It breaks questions down, scores relevance and summarises abstracts, and that's all. Anything with an exact answer - de-duplication, DOI checks, the reference list - is plain code.
+My task was to build that, test it, and show it working. The design itself was marked at the end of September, with three points of feedback: justify the choice of model, set measurable quality targets, and use more than one literature source with automatic failover. Those three points shaped the last stage of the build, and I'll come back to each of them.</a:t>
             </a:r>
             <a:endParaRPr lang="en-US" dirty="0"/>
           </a:p>
@@ -778,8 +779,8 @@
           <a:p>
             <a:r>
               <a:rPr lang="en-US" dirty="0"/>
-              <a:t>The architecture follows the class diagram from our proposal. The researcher talks to one boundary class, which handles both reviews. Behind it, the orchestrator runs the steps in a fixed order, enforces the limits, and does the exact work itself. Under it are the three agents. The Planning Agent uses the language model to turn the question into sub-questions and queries, and to rewrite a query when a search comes up short. The Retrieval Agent has no model at all: it searches OpenAlex and decides, by counting, whether it got enough usable records. The Evaluation and Synthesis Agent uses the model for judgement: scoring each paper's relevance with a reason, and later writing notes, themes and gaps from whatever was approved.
-What passes between them are the four classes from the diagram, as Pydantic models. Every reply from the model is parsed against a schema; if it doesn't fit, the error goes back once for repair, and if that fails the run stops. I'd rather it stopped than carried on with a broken object. The numbers on the right are the autonomy limits from the design, and they live in one configuration file.</a:t>
+              <a:t>The architecture follows the class diagram from our proposal. The researcher talks to one boundary class, which handles both reviews. Behind it, the orchestrator runs the steps in a fixed order, enforces the limits, and does the exact work itself. Under it are the three agents. The Planning Agent uses the language model to turn the question into sub-questions and queries, and to rewrite a query when a search comes up short. The Retrieval Agent has no model at all: it searches two sources, OpenAlex and Semantic Scholar, for every sub-question, merges what comes back, and decides, by counting, whether it got enough usable records. If one source is down or rate-limited it carries on with the other and remembers that for the brief. The Evaluation and Synthesis Agent uses the model for judgement: scoring each paper's relevance with a reason, and later writing notes, themes and gaps from whatever was approved.
+What passes between them are the four classes from the diagram, as Pydantic models. Every reply from the model is parsed against a schema; if it doesn't fit, the error goes back once for repair, and if that fails the run stops. I'd rather it stopped than carried on with a broken object. The numbers on the right are the autonomy limits from the design. They live in one configuration file, together with the model name and the list of sources, so none of them is buried in an agent.</a:t>
             </a:r>
             <a:endParaRPr lang="en-US" dirty="0"/>
           </a:p>
@@ -867,8 +868,8 @@
           <a:p>
             <a:r>
               <a:rPr lang="en-US" dirty="0"/>
-              <a:t>Here's one run from start to finish. The question is planned into three to five sub-questions with search queries, and that plan goes to the researcher at Review 1: approve, or say what to change and get a new one. Nothing has been searched yet, so that loop can repeat freely. Each sub-question is then searched on OpenAlex, results are de-duplicated by DOI, every DOI is looked up in Crossref, and each paper is scored one to five from its abstract with a one-sentence reason. Review 2 shows every paper above the cut-off and offers three choices: approve, drop papers by number, or reject the scope and go back to planning, which is allowed once. After approval the agent writes a note per paper, then themes and gaps, and the orchestrator adds a limitations section computed from the run and a reference list built from the records.
-One piece of automatic behaviour sits in the middle. If a search falls short, too few abstracts or too few relevant papers after scoring, the Planning Agent rewrites the query once and is told why the search fell short. It never gets a second attempt.</a:t>
+              <a:t>Here's one run from start to finish. The question is planned into three to five sub-questions with search queries, and that plan goes to the researcher at Review 1: approve, or say what to change and get a new one. Nothing has been searched yet, so that loop can repeat freely. Each sub-question is then searched on both sources, twenty records from each. The results are merged and de-duplicated by DOI, every DOI is looked up in Crossref, and each paper is scored one to five from its abstract with a one-sentence reason. Review 2 shows every paper above the cut-off and offers three choices: approve, drop papers by number, or reject the scope and go back to planning, which is allowed once. After approval the agent writes a note per paper, then themes and gaps, and the orchestrator adds a limitations section computed from the run and a reference list built from the records.
+Two pieces of automatic behaviour sit in the middle. If a search falls short - too few abstracts, or too few relevant papers after scoring - the Planning Agent rewrites the query once and is told why the search fell short. It never gets a second attempt. And if a source fails after its retries, the Retrieval Agent skips it for that query, tries it again on the next one, and the brief records how many searches each source answered. Only if every source fails does the run stop, because then there is nothing honest to continue with.</a:t>
             </a:r>
             <a:endParaRPr lang="en-US" dirty="0"/>
           </a:p>
@@ -956,7 +957,7 @@
           <a:p>
             <a:r>
               <a:rPr lang="en-US" dirty="0"/>
-              <a:t>This is the first review point in a live run, on the question 'What approaches reduce hallucination in LLM-based autonomous agents'. The Planning Agent has returned an interpretation and four sub-questions, each with a query, and the program is waiting for me. The researcher sees exactly what will be searched before it happens. Revising costs nothing here because no quota has been spent; when I tested it, I asked to merge two sub-questions into one about evaluation, and the next plan came back with exactly three, merged as asked. And any constraints the user gives are re-sent with every prompt rather than left to the model's memory, so they can't quietly drop out.</a:t>
+              <a:t>This is the first review point in a live run, on the question 'What approaches reduce hallucination in LLM-based autonomous agents'. The Planning Agent has returned an interpretation and four sub-questions, each with a query, and the program is waiting for me. The researcher sees exactly what will be searched before it happens. Revising costs nothing here because no quota has been spent; when I tested it, I asked to merge two sub-questions into one about evaluation, and the next plan came back with exactly three, merged as asked. And any constraints the user gives are re-sent with every prompt rather than left to the model's memory, so they can't quietly drop out. The plan you see here is the one the rest of the demo runs on.</a:t>
             </a:r>
             <a:endParaRPr lang="en-US" dirty="0"/>
           </a:p>
@@ -1044,8 +1045,9 @@
           <a:p>
             <a:r>
               <a:rPr lang="en-US" dirty="0"/>
-              <a:t>After approval, the log shows the middle of the pipeline. Eighty records came back across the four sub-questions; sixty-five were unique. Forty-six DOIs were found in Crossref; the other nineteen are mostly arXiv preprints, which register with DataCite instead, so they're flagged but kept. Then one scoring line per paper: score, keep or drop, DOI, reason. Twenty-six papers ended up above the cut-off.
-The lower panel is the retry doing its job. Sub-question 4, on benchmarks, produced twelve new papers with abstracts but only one relevant; the query had pulled in general surveys. The orchestrator asked for one reformulation, passing the rejection reasons along. The new query found thirteen more records, two of them relevant, so that sub-question finished with three papers instead of one. That's an honest result: one retry is a safety net, not a cure, and the brief says so.</a:t>
+              <a:t>This is the log from the run on the thirtieth of September, after the second source was added. Each sub-question went to both sources. OpenAlex answered all five searches, a hundred records. Semantic Scholar, which I use without a key, refused three of the five with 'too many requests'. Each time, the retry policy tried four times over about forty-five seconds, gave up, and the Retrieval Agent logged the failure and carried on with OpenAlex. It answered the other two searches, forty records. That is the failover the feedback asked for, working for real rather than staged: the run didn't die, and the brief says which sub-questions were covered by one source only.
+A hundred and forty records came back; a hundred and seventeen were unique. Seventy-eight DOIs were found in Crossref; the rest are mostly arXiv preprints, which register with DataCite instead, so they're flagged but kept. Then one scoring line per paper: score, keep or drop, DOI, reason. Seventy-seven papers ended up above the cut-off.
+The lower panel is the retry doing its job. Sub-question 4, on evaluation, produced eight new records with only two relevant; the query had pulled in general surveys and a conference preface. The orchestrator asked for one reformulation, passing the rejection reasons along. This time both sources answered the new query: thirty-three new records, twenty of them relevant, so that sub-question finished with twenty-two papers instead of two. On the single-source system, the same retry had lifted it from one paper to three. That difference is what a second source is for.</a:t>
             </a:r>
             <a:endParaRPr lang="en-US" dirty="0"/>
           </a:p>
@@ -1134,7 +1136,7 @@
             <a:r>
               <a:rPr lang="en-US" dirty="0"/>
               <a:t>Review 2 lists every paper that passed, grouped and numbered, with score and reason, and notes where a query was reformulated. From here I can approve, drop papers by number, or reject the scope. In the functional tests I did all three: dropping two papers removed and re-numbered them and the brief recorded the removal; rejecting the scope sent the run back to planning with my feedback, and a second reject was refused because that budget was used.
-After approval the twenty-six papers were summarised in four calls and the themes and gaps took one more. On the right are pieces of the brief. The note for paper five says RAG-based legal research tools still hallucinate seventeen to thirty-three percent of the time; I checked, and those figures are in the paper's abstract. Each theme cites paper numbers, and the schema rejects a theme that cites a number not in the list. The limitations are computed by the orchestrator, and the reference list comes straight from the records' metadata. The model never writes a citation.</a:t>
+After approval the seventy-seven papers were summarised in ten calls and the themes and gaps took one more. On the right are pieces of the brief. The note for paper seventy-six describes a practitioner audit built on forty-five recorded incidents; I checked, and that figure is in the paper's abstract - and that paper came from Semantic Scholar only, so the single-source system would never have seen it. Each theme cites paper numbers, and the schema rejects a theme that cites a number not in the list. The limitations are computed by the orchestrator, not written by the model, and since this stage they include what each source contributed and where failover was used. The reference list comes straight from the records' metadata. The model never writes a citation.</a:t>
             </a:r>
             <a:endParaRPr lang="en-US" dirty="0"/>
           </a:p>
@@ -1222,7 +1224,8 @@
           <a:p>
             <a:r>
               <a:rPr lang="en-US" dirty="0"/>
-              <a:t>Testing happened at three levels. Fifty-six unit tests run without any network, against recorded replies from the three services; they cover the data models, abstract reconstruction, de-duplication and DOI checks, schema validation and repair, both review loops, the threshold and retry caps, the cut-off, batching, the rule that a theme can't cite a paper that isn't there, the retry policies, and the brief layout. Nine functional tests were run live, each with the command, the expected result and what actually happened: no API key, drop, revise, reject scope and be refused the second time, a full run, the threshold retry, transient errors, the daily quota stop, and malformed JSON repair. All nine pass. And a remediation log with eleven entries records every problem I hit, its cause, the change, and how I checked it. That log is the next slide.</a:t>
+              <a:t>Testing happened at three levels. Sixty-eight unit tests run without any network, against recorded replies from the four services; they cover the data models, abstract reconstruction, de-duplication and DOI checks, schema validation and repair, both review loops, the threshold and retry caps, the cut-off, batching, the rule that a theme can't cite a paper that isn't there, the retry policies, the brief layout, and, since the last stage, the second source, the merging of results and the failover between sources. Eleven functional tests were run live, each with the command, the expected result and what actually happened: no API key, drop, revise, reject scope and be refused the second time, a full run, the threshold retry, transient errors, the daily quota stop, malformed JSON repair, the two-source run with real failover, and a forced non-transient failure that must not be retried. All eleven pass. And a remediation log with eleven entries records every problem I hit, its cause, the change, and how I checked it. That log is the next slide.
+The feedback also asked what the tests measure. Honestly: de-duplication and citation accuracy are measured - structurally, in that a fabricated citation cannot reach the brief - and grounding was spot-checked. Recall and precision are not measured, because there is no labelled dataset for the question, and I'd rather say that than invent a number. The README sets out what a real evaluation would need.</a:t>
             </a:r>
             <a:endParaRPr lang="en-US" dirty="0"/>
           </a:p>
@@ -1310,8 +1313,8 @@
           <a:p>
             <a:r>
               <a:rPr lang="en-US" dirty="0"/>
-              <a:t>Nearly every problem came from outside the code, and each one left a mark on it. The very first Gemini call returned a 404: the model I'd set up with had been retired between design and build. The name was already in configuration, so the fix was one line. A few days later a run died on a 503, and the next on a read timeout; that produced the transient-error retry, with 'busy' errors retried and 'wrong' errors failing at once so a bad key can't hide behind retries. Then came 429s. Once I logged the quota name it turned out the free tier for that model allows twenty requests a day, retries included, so the client now stops immediately on a daily quota, and I switched to a Flash-Lite model with five hundred a day, again one line. On the 23rd OpenAlex started refusing requests: their access model had changed and keyless use is now capped, so a free key went into configuration and the retry logic moved into one shared policy for OpenAlex and Crossref. And a typo: I typed 'approv' at Review 1 and it was taken as feedback and re-planned. Now a short unrecognised input is simply asked again.
-None of this needed a rewrite. One configuration module and one small client per service meant each fix was a line or two. The repository holds thirteen commits across September, roughly one per stage.</a:t>
+              <a:t>Nearly every problem came from outside the code, and each one left a mark on it. The very first Gemini call returned a 404: the model I'd set up with had been retired between design and build. The name was already in configuration, so the fix was one line. A few days later a run died on a 503, and the next on a read timeout; that produced the transient-error retry, with 'busy' errors retried and 'wrong' errors failing at once so a bad key can't hide behind retries. Then came 429s. Once I logged the quota name it turned out the free tier for that model allows twenty requests a day, retries included, so the client now stops immediately on a daily quota, and I switched to a Flash-Lite model with five hundred a day - again one line. On the twenty-third OpenAlex started refusing requests: their access model had changed and keyless use is now capped, so a free key went into configuration and the retry logic moved into one shared policy for all the scholarly APIs. And a typo: I typed 'approv' at Review 1 and it was taken as feedback and re-planned. Now a short unrecognised input is simply asked again.
+None of this needed a rewrite. One configuration module and one small client per service meant each fix was a line or two, and it is also what made adding a second source a single new client module. The repository's commit history runs from the ninth to the thirtieth of September, roughly one commit per stage, so every one of these changes can be found.</a:t>
             </a:r>
             <a:endParaRPr lang="en-US" dirty="0"/>
           </a:p>
@@ -1998,7 +2001,7 @@
         <p:spPr>
           <a:xfrm>
             <a:off x="457200" y="1554480"/>
-            <a:ext cx="2651760" cy="2651760"/>
+            <a:ext cx="2651760" cy="2743200"/>
           </a:xfrm>
           <a:prstGeom prst="rect">
             <a:avLst/>
@@ -2018,7 +2021,7 @@
               <a:buChar char="•"/>
             </a:pPr>
             <a:r>
-              <a:rPr lang="en-US" sz="1150" dirty="0">
+              <a:rPr lang="en-US" sz="1000" dirty="0">
                 <a:solidFill>
                   <a:srgbClr val="FFFFFF"/>
                 </a:solidFill>
@@ -2028,7 +2031,7 @@
               </a:rPr>
               <a:t>Three agents, orchestrator, the four data classes and Decision enum from Diagram 1</a:t>
             </a:r>
-            <a:endParaRPr lang="en-US" sz="1150" dirty="0"/>
+            <a:endParaRPr lang="en-US" sz="1000" dirty="0"/>
           </a:p>
           <a:p>
             <a:pPr marL="342900" indent="-342900">
@@ -2039,7 +2042,7 @@
               <a:buChar char="•"/>
             </a:pPr>
             <a:r>
-              <a:rPr lang="en-US" sz="1150" dirty="0">
+              <a:rPr lang="en-US" sz="1000" dirty="0">
                 <a:solidFill>
                   <a:srgbClr val="FFFFFF"/>
                 </a:solidFill>
@@ -2049,7 +2052,7 @@
               </a:rPr>
               <a:t>Both review points, both autonomy caps</a:t>
             </a:r>
-            <a:endParaRPr lang="en-US" sz="1150" dirty="0"/>
+            <a:endParaRPr lang="en-US" sz="1000" dirty="0"/>
           </a:p>
           <a:p>
             <a:pPr marL="342900" indent="-342900">
@@ -2060,7 +2063,7 @@
               <a:buChar char="•"/>
             </a:pPr>
             <a:r>
-              <a:rPr lang="en-US" sz="1150" dirty="0">
+              <a:rPr lang="en-US" sz="1000" dirty="0">
                 <a:solidFill>
                   <a:srgbClr val="FFFFFF"/>
                 </a:solidFill>
@@ -2070,7 +2073,7 @@
               </a:rPr>
               <a:t>Crossref verification; flagged, never dropped</a:t>
             </a:r>
-            <a:endParaRPr lang="en-US" sz="1150" dirty="0"/>
+            <a:endParaRPr lang="en-US" sz="1000" dirty="0"/>
           </a:p>
           <a:p>
             <a:pPr marL="342900" indent="-342900">
@@ -2081,7 +2084,7 @@
               <a:buChar char="•"/>
             </a:pPr>
             <a:r>
-              <a:rPr lang="en-US" sz="1150" dirty="0">
+              <a:rPr lang="en-US" sz="1000" dirty="0">
                 <a:solidFill>
                   <a:srgbClr val="FFFFFF"/>
                 </a:solidFill>
@@ -2091,69 +2094,8 @@
               </a:rPr>
               <a:t>Brief with notes, themes, gaps, limitations, references</a:t>
             </a:r>
-            <a:endParaRPr lang="en-US" sz="1150" dirty="0"/>
-          </a:p>
-        </p:txBody>
-      </p:sp>
-      <p:sp>
-        <p:nvSpPr>
-          <p:cNvPr id="5" name="Text 3"/>
-          <p:cNvSpPr txBox="1"/>
-          <p:nvPr/>
-        </p:nvSpPr>
-        <p:spPr>
-          <a:xfrm>
-            <a:off x="3246120" y="1143000"/>
-            <a:ext cx="2651760" cy="365760"/>
-          </a:xfrm>
-          <a:prstGeom prst="rect">
-            <a:avLst/>
-          </a:prstGeom>
-          <a:noFill/>
-          <a:ln/>
-        </p:spPr>
-        <p:txBody>
-          <a:bodyPr wrap="square" lIns="0" tIns="0" rIns="0" bIns="0" rtlCol="0" anchor="ctr"/>
-          <a:lstStyle/>
-          <a:p>
-            <a:pPr indent="0" marL="0">
-              <a:buNone/>
-            </a:pPr>
-            <a:r>
-              <a:rPr lang="en-US" sz="1300" b="1" dirty="0">
-                <a:solidFill>
-                  <a:srgbClr val="D9963A"/>
-                </a:solidFill>
-                <a:latin typeface="Calibri" pitchFamily="34" charset="0"/>
-                <a:ea typeface="Calibri" pitchFamily="34" charset="-122"/>
-                <a:cs typeface="Calibri" pitchFamily="34" charset="-120"/>
-              </a:rPr>
-              <a:t>Where it departed, and why</a:t>
-            </a:r>
-            <a:endParaRPr lang="en-US" sz="1300" dirty="0"/>
-          </a:p>
-        </p:txBody>
-      </p:sp>
-      <p:sp>
-        <p:nvSpPr>
-          <p:cNvPr id="6" name="Text 4"/>
-          <p:cNvSpPr txBox="1"/>
-          <p:nvPr/>
-        </p:nvSpPr>
-        <p:spPr>
-          <a:xfrm>
-            <a:off x="3246120" y="1554480"/>
-            <a:ext cx="2651760" cy="2651760"/>
-          </a:xfrm>
-          <a:prstGeom prst="rect">
-            <a:avLst/>
-          </a:prstGeom>
-          <a:noFill/>
-          <a:ln/>
-        </p:spPr>
-        <p:txBody>
-          <a:bodyPr wrap="square" lIns="0" tIns="0" rIns="0" bIns="0" rtlCol="0" anchor="t"/>
-          <a:lstStyle/>
+            <a:endParaRPr lang="en-US" sz="1000" dirty="0"/>
+          </a:p>
           <a:p>
             <a:pPr marL="342900" indent="-342900">
               <a:spcAft>
@@ -2163,7 +2105,7 @@
               <a:buChar char="•"/>
             </a:pPr>
             <a:r>
-              <a:rPr lang="en-US" sz="1150" dirty="0">
+              <a:rPr lang="en-US" sz="1000" dirty="0">
                 <a:solidFill>
                   <a:srgbClr val="FFFFFF"/>
                 </a:solidFill>
@@ -2171,10 +2113,71 @@
                 <a:ea typeface="Calibri" pitchFamily="34" charset="-122"/>
                 <a:cs typeface="Calibri" pitchFamily="34" charset="-120"/>
               </a:rPr>
-              <a:t>A second retry trigger after scoring - a search can return 20 abstracts and 1 relevant paper</a:t>
-            </a:r>
-            <a:endParaRPr lang="en-US" sz="1150" dirty="0"/>
-          </a:p>
+              <a:t>Three small departures: a second retry trigger after scoring; a shared retry policy; previous_query kept on SubQuestion</a:t>
+            </a:r>
+            <a:endParaRPr lang="en-US" sz="1000" dirty="0"/>
+          </a:p>
+        </p:txBody>
+      </p:sp>
+      <p:sp>
+        <p:nvSpPr>
+          <p:cNvPr id="5" name="Text 3"/>
+          <p:cNvSpPr txBox="1"/>
+          <p:nvPr/>
+        </p:nvSpPr>
+        <p:spPr>
+          <a:xfrm>
+            <a:off x="3246120" y="1143000"/>
+            <a:ext cx="2651760" cy="365760"/>
+          </a:xfrm>
+          <a:prstGeom prst="rect">
+            <a:avLst/>
+          </a:prstGeom>
+          <a:noFill/>
+          <a:ln/>
+        </p:spPr>
+        <p:txBody>
+          <a:bodyPr wrap="square" lIns="0" tIns="0" rIns="0" bIns="0" rtlCol="0" anchor="ctr"/>
+          <a:lstStyle/>
+          <a:p>
+            <a:pPr indent="0" marL="0">
+              <a:buNone/>
+            </a:pPr>
+            <a:r>
+              <a:rPr lang="en-US" sz="1300" b="1" dirty="0">
+                <a:solidFill>
+                  <a:srgbClr val="D9963A"/>
+                </a:solidFill>
+                <a:latin typeface="Calibri" pitchFamily="34" charset="0"/>
+                <a:ea typeface="Calibri" pitchFamily="34" charset="-122"/>
+                <a:cs typeface="Calibri" pitchFamily="34" charset="-120"/>
+              </a:rPr>
+              <a:t>Changed after the feedback (29 Sept)</a:t>
+            </a:r>
+            <a:endParaRPr lang="en-US" sz="1300" dirty="0"/>
+          </a:p>
+        </p:txBody>
+      </p:sp>
+      <p:sp>
+        <p:nvSpPr>
+          <p:cNvPr id="6" name="Text 4"/>
+          <p:cNvSpPr txBox="1"/>
+          <p:nvPr/>
+        </p:nvSpPr>
+        <p:spPr>
+          <a:xfrm>
+            <a:off x="3246120" y="1554480"/>
+            <a:ext cx="2651760" cy="2743200"/>
+          </a:xfrm>
+          <a:prstGeom prst="rect">
+            <a:avLst/>
+          </a:prstGeom>
+          <a:noFill/>
+          <a:ln/>
+        </p:spPr>
+        <p:txBody>
+          <a:bodyPr wrap="square" lIns="0" tIns="0" rIns="0" bIns="0" rtlCol="0" anchor="t"/>
+          <a:lstStyle/>
           <a:p>
             <a:pPr marL="342900" indent="-342900">
               <a:spcAft>
@@ -2184,7 +2187,7 @@
               <a:buChar char="•"/>
             </a:pPr>
             <a:r>
-              <a:rPr lang="en-US" sz="1150" dirty="0">
+              <a:rPr lang="en-US" sz="1000" dirty="0">
                 <a:solidFill>
                   <a:srgbClr val="FFFFFF"/>
                 </a:solidFill>
@@ -2192,9 +2195,9 @@
                 <a:ea typeface="Calibri" pitchFamily="34" charset="-122"/>
                 <a:cs typeface="Calibri" pitchFamily="34" charset="-120"/>
               </a:rPr>
-              <a:t>A shared HTTP retry policy the design never mentioned - the services forced it</a:t>
-            </a:r>
-            <a:endParaRPr lang="en-US" sz="1150" dirty="0"/>
+              <a:t>Model choice justified from the provider's figures: 1M-token context vs 12k-token prompts, structured output, 500 requests/day free, $0.30 per M input tokens, benchmarks - none of which measures abstract screening</a:t>
+            </a:r>
+            <a:endParaRPr lang="en-US" sz="1000" dirty="0"/>
           </a:p>
           <a:p>
             <a:pPr marL="342900" indent="-342900">
@@ -2205,7 +2208,7 @@
               <a:buChar char="•"/>
             </a:pPr>
             <a:r>
-              <a:rPr lang="en-US" sz="1150" dirty="0">
+              <a:rPr lang="en-US" sz="1000" dirty="0">
                 <a:solidFill>
                   <a:srgbClr val="FFFFFF"/>
                 </a:solidFill>
@@ -2213,71 +2216,10 @@
                 <a:ea typeface="Calibri" pitchFamily="34" charset="-122"/>
                 <a:cs typeface="Calibri" pitchFamily="34" charset="-120"/>
               </a:rPr>
-              <a:t>previous_query kept on SubQuestion so the brief can show both queries</a:t>
-            </a:r>
-            <a:endParaRPr lang="en-US" sz="1150" dirty="0"/>
-          </a:p>
-        </p:txBody>
-      </p:sp>
-      <p:sp>
-        <p:nvSpPr>
-          <p:cNvPr id="7" name="Text 5"/>
-          <p:cNvSpPr txBox="1"/>
-          <p:nvPr/>
-        </p:nvSpPr>
-        <p:spPr>
-          <a:xfrm>
-            <a:off x="6035040" y="1143000"/>
-            <a:ext cx="2651760" cy="365760"/>
-          </a:xfrm>
-          <a:prstGeom prst="rect">
-            <a:avLst/>
-          </a:prstGeom>
-          <a:noFill/>
-          <a:ln/>
-        </p:spPr>
-        <p:txBody>
-          <a:bodyPr wrap="square" lIns="0" tIns="0" rIns="0" bIns="0" rtlCol="0" anchor="ctr"/>
-          <a:lstStyle/>
-          <a:p>
-            <a:pPr indent="0" marL="0">
-              <a:buNone/>
-            </a:pPr>
-            <a:r>
-              <a:rPr lang="en-US" sz="1300" b="1" dirty="0">
-                <a:solidFill>
-                  <a:srgbClr val="D9963A"/>
-                </a:solidFill>
-                <a:latin typeface="Calibri" pitchFamily="34" charset="0"/>
-                <a:ea typeface="Calibri" pitchFamily="34" charset="-122"/>
-                <a:cs typeface="Calibri" pitchFamily="34" charset="-120"/>
-              </a:rPr>
-              <a:t>Limits and next steps</a:t>
-            </a:r>
-            <a:endParaRPr lang="en-US" sz="1300" dirty="0"/>
-          </a:p>
-        </p:txBody>
-      </p:sp>
-      <p:sp>
-        <p:nvSpPr>
-          <p:cNvPr id="8" name="Text 6"/>
-          <p:cNvSpPr txBox="1"/>
-          <p:nvPr/>
-        </p:nvSpPr>
-        <p:spPr>
-          <a:xfrm>
-            <a:off x="6035040" y="1554480"/>
-            <a:ext cx="2651760" cy="2651760"/>
-          </a:xfrm>
-          <a:prstGeom prst="rect">
-            <a:avLst/>
-          </a:prstGeom>
-          <a:noFill/>
-          <a:ln/>
-        </p:spPr>
-        <p:txBody>
-          <a:bodyPr wrap="square" lIns="0" tIns="0" rIns="0" bIns="0" rtlCol="0" anchor="t"/>
-          <a:lstStyle/>
+              <a:t>Test targets stated honestly: de-duplication and citation accuracy measured; recall and precision not - no gold set - with what one would need</a:t>
+            </a:r>
+            <a:endParaRPr lang="en-US" sz="1000" dirty="0"/>
+          </a:p>
           <a:p>
             <a:pPr marL="342900" indent="-342900">
               <a:spcAft>
@@ -2287,7 +2229,7 @@
               <a:buChar char="•"/>
             </a:pPr>
             <a:r>
-              <a:rPr lang="en-US" sz="1150" dirty="0">
+              <a:rPr lang="en-US" sz="1000" dirty="0">
                 <a:solidFill>
                   <a:srgbClr val="FFFFFF"/>
                 </a:solidFill>
@@ -2295,10 +2237,71 @@
                 <a:ea typeface="Calibri" pitchFamily="34" charset="-122"/>
                 <a:cs typeface="Calibri" pitchFamily="34" charset="-120"/>
               </a:rPr>
-              <a:t>One source, abstracts only, 20 per query</a:t>
-            </a:r>
-            <a:endParaRPr lang="en-US" sz="1150" dirty="0"/>
-          </a:p>
+              <a:t>Built: two sources for every search, automatic failover; 78 -&gt; 117 papers on the same question</a:t>
+            </a:r>
+            <a:endParaRPr lang="en-US" sz="1000" dirty="0"/>
+          </a:p>
+        </p:txBody>
+      </p:sp>
+      <p:sp>
+        <p:nvSpPr>
+          <p:cNvPr id="7" name="Text 5"/>
+          <p:cNvSpPr txBox="1"/>
+          <p:nvPr/>
+        </p:nvSpPr>
+        <p:spPr>
+          <a:xfrm>
+            <a:off x="6035040" y="1143000"/>
+            <a:ext cx="2651760" cy="365760"/>
+          </a:xfrm>
+          <a:prstGeom prst="rect">
+            <a:avLst/>
+          </a:prstGeom>
+          <a:noFill/>
+          <a:ln/>
+        </p:spPr>
+        <p:txBody>
+          <a:bodyPr wrap="square" lIns="0" tIns="0" rIns="0" bIns="0" rtlCol="0" anchor="ctr"/>
+          <a:lstStyle/>
+          <a:p>
+            <a:pPr indent="0" marL="0">
+              <a:buNone/>
+            </a:pPr>
+            <a:r>
+              <a:rPr lang="en-US" sz="1300" b="1" dirty="0">
+                <a:solidFill>
+                  <a:srgbClr val="D9963A"/>
+                </a:solidFill>
+                <a:latin typeface="Calibri" pitchFamily="34" charset="0"/>
+                <a:ea typeface="Calibri" pitchFamily="34" charset="-122"/>
+                <a:cs typeface="Calibri" pitchFamily="34" charset="-120"/>
+              </a:rPr>
+              <a:t>Limits and next steps</a:t>
+            </a:r>
+            <a:endParaRPr lang="en-US" sz="1300" dirty="0"/>
+          </a:p>
+        </p:txBody>
+      </p:sp>
+      <p:sp>
+        <p:nvSpPr>
+          <p:cNvPr id="8" name="Text 6"/>
+          <p:cNvSpPr txBox="1"/>
+          <p:nvPr/>
+        </p:nvSpPr>
+        <p:spPr>
+          <a:xfrm>
+            <a:off x="6035040" y="1554480"/>
+            <a:ext cx="2651760" cy="2743200"/>
+          </a:xfrm>
+          <a:prstGeom prst="rect">
+            <a:avLst/>
+          </a:prstGeom>
+          <a:noFill/>
+          <a:ln/>
+        </p:spPr>
+        <p:txBody>
+          <a:bodyPr wrap="square" lIns="0" tIns="0" rIns="0" bIns="0" rtlCol="0" anchor="t"/>
+          <a:lstStyle/>
           <a:p>
             <a:pPr marL="342900" indent="-342900">
               <a:spcAft>
@@ -2308,7 +2311,7 @@
               <a:buChar char="•"/>
             </a:pPr>
             <a:r>
-              <a:rPr lang="en-US" sz="1150" dirty="0">
+              <a:rPr lang="en-US" sz="1000" dirty="0">
                 <a:solidFill>
                   <a:srgbClr val="FFFFFF"/>
                 </a:solidFill>
@@ -2316,9 +2319,9 @@
                 <a:ea typeface="Calibri" pitchFamily="34" charset="-122"/>
                 <a:cs typeface="Calibri" pitchFamily="34" charset="-120"/>
               </a:rPr>
-              <a:t>The Lite model keeps more papers (42 vs 26) - the cut-off may need tuning per model</a:t>
-            </a:r>
-            <a:endParaRPr lang="en-US" sz="1150" dirty="0"/>
+              <a:t>Abstracts only, 20 per query per source</a:t>
+            </a:r>
+            <a:endParaRPr lang="en-US" sz="1000" dirty="0"/>
           </a:p>
           <a:p>
             <a:pPr marL="342900" indent="-342900">
@@ -2329,7 +2332,7 @@
               <a:buChar char="•"/>
             </a:pPr>
             <a:r>
-              <a:rPr lang="en-US" sz="1150" dirty="0">
+              <a:rPr lang="en-US" sz="1000" dirty="0">
                 <a:solidFill>
                   <a:srgbClr val="FFFFFF"/>
                 </a:solidFill>
@@ -2337,9 +2340,9 @@
                 <a:ea typeface="Calibri" pitchFamily="34" charset="-122"/>
                 <a:cs typeface="Calibri" pitchFamily="34" charset="-120"/>
               </a:rPr>
-              <a:t>One retry lifted a thin sub-question from 1 to 3 papers, not 5</a:t>
-            </a:r>
-            <a:endParaRPr lang="en-US" sz="1150" dirty="0"/>
+              <a:t>Lite keeps more papers than Flash (42 vs 26) - calibrate the cut-off per model</a:t>
+            </a:r>
+            <a:endParaRPr lang="en-US" sz="1000" dirty="0"/>
           </a:p>
           <a:p>
             <a:pPr marL="342900" indent="-342900">
@@ -2350,7 +2353,7 @@
               <a:buChar char="•"/>
             </a:pPr>
             <a:r>
-              <a:rPr lang="en-US" sz="1150" dirty="0">
+              <a:rPr lang="en-US" sz="1000" dirty="0">
                 <a:solidFill>
                   <a:srgbClr val="FFFFFF"/>
                 </a:solidFill>
@@ -2358,9 +2361,30 @@
                 <a:ea typeface="Calibri" pitchFamily="34" charset="-122"/>
                 <a:cs typeface="Calibri" pitchFamily="34" charset="-120"/>
               </a:rPr>
-              <a:t>Next: DataCite lookup, a second source, full-text where open</a:t>
-            </a:r>
-            <a:endParaRPr lang="en-US" sz="1150" dirty="0"/>
+              <a:t>A paper under two DOIs is not merged; Semantic Scholar's keyless pool refuses more than it answers</a:t>
+            </a:r>
+            <a:endParaRPr lang="en-US" sz="1000" dirty="0"/>
+          </a:p>
+          <a:p>
+            <a:pPr marL="342900" indent="-342900">
+              <a:spcAft>
+                <a:spcPts val="600"/>
+              </a:spcAft>
+              <a:buSzPct val="100000"/>
+              <a:buChar char="•"/>
+            </a:pPr>
+            <a:r>
+              <a:rPr lang="en-US" sz="1000" dirty="0">
+                <a:solidFill>
+                  <a:srgbClr val="FFFFFF"/>
+                </a:solidFill>
+                <a:latin typeface="Calibri" pitchFamily="34" charset="0"/>
+                <a:ea typeface="Calibri" pitchFamily="34" charset="-122"/>
+                <a:cs typeface="Calibri" pitchFamily="34" charset="-120"/>
+              </a:rPr>
+              <a:t>Next: DataCite lookup, a labelled set for recall and precision, full text where open</a:t>
+            </a:r>
+            <a:endParaRPr lang="en-US" sz="1000" dirty="0"/>
           </a:p>
         </p:txBody>
       </p:sp>
@@ -3161,8 +3185,8 @@
         </p:nvSpPr>
         <p:spPr>
           <a:xfrm>
-            <a:off x="4663440" y="3977640"/>
-            <a:ext cx="3840480" cy="502920"/>
+            <a:off x="4663440" y="3931920"/>
+            <a:ext cx="3840480" cy="685800"/>
           </a:xfrm>
           <a:prstGeom prst="rect">
             <a:avLst/>
@@ -3178,7 +3202,7 @@
               <a:buNone/>
             </a:pPr>
             <a:r>
-              <a:rPr lang="en-US" sz="1200" i="1" dirty="0">
+              <a:rPr lang="en-US" sz="1150" i="1" dirty="0">
                 <a:solidFill>
                   <a:srgbClr val="8A5A17"/>
                 </a:solidFill>
@@ -3186,9 +3210,9 @@
                 <a:ea typeface="Calibri" pitchFamily="34" charset="-122"/>
                 <a:cs typeface="Calibri" pitchFamily="34" charset="-120"/>
               </a:rPr>
-              <a:t>My task: build the proposed system on my own, test it, and show it running.</a:t>
-            </a:r>
-            <a:endParaRPr lang="en-US" sz="1200" dirty="0"/>
+              <a:t>My task: build the proposed system on my own, test it, show it running - and, once the design was marked (29 Sept), act on its three points of feedback.</a:t>
+            </a:r>
+            <a:endParaRPr lang="en-US" sz="1150" dirty="0"/>
           </a:p>
         </p:txBody>
       </p:sp>
@@ -3621,7 +3645,7 @@
               <a:buNone/>
             </a:pPr>
             <a:r>
-              <a:rPr lang="en-US" sz="1200" b="1" dirty="0">
+              <a:rPr lang="en-US" sz="1050" b="1" dirty="0">
                 <a:solidFill>
                   <a:srgbClr val="FFFFFF"/>
                 </a:solidFill>
@@ -3629,16 +3653,16 @@
                 <a:ea typeface="Calibri" pitchFamily="34" charset="-122"/>
                 <a:cs typeface="Calibri" pitchFamily="34" charset="-120"/>
               </a:rPr>
-              <a:t>Retrieval Agent</a:t>
-            </a:r>
-            <a:endParaRPr lang="en-US" sz="1200" dirty="0"/>
+              <a:t>Retrieval Agent - no LLM</a:t>
+            </a:r>
+            <a:endParaRPr lang="en-US" sz="1050" dirty="0"/>
           </a:p>
           <a:p>
             <a:pPr algn="ctr" indent="0" marL="0">
               <a:buNone/>
             </a:pPr>
             <a:r>
-              <a:rPr lang="en-US" sz="1200" b="1" dirty="0">
+              <a:rPr lang="en-US" sz="1050" b="1" dirty="0">
                 <a:solidFill>
                   <a:srgbClr val="FFFFFF"/>
                 </a:solidFill>
@@ -3646,9 +3670,9 @@
                 <a:ea typeface="Calibri" pitchFamily="34" charset="-122"/>
                 <a:cs typeface="Calibri" pitchFamily="34" charset="-120"/>
               </a:rPr>
-              <a:t>no LLM</a:t>
-            </a:r>
-            <a:endParaRPr lang="en-US" sz="1200" dirty="0"/>
+              <a:t>OpenAlex + Semantic Scholar</a:t>
+            </a:r>
+            <a:endParaRPr lang="en-US" sz="1050" dirty="0"/>
           </a:p>
         </p:txBody>
       </p:sp>
@@ -3898,7 +3922,7 @@
         <p:spPr>
           <a:xfrm>
             <a:off x="457200" y="3611880"/>
-            <a:ext cx="6583680" cy="1097280"/>
+            <a:ext cx="6583680" cy="1143000"/>
           </a:xfrm>
           <a:prstGeom prst="rect">
             <a:avLst/>
@@ -3918,7 +3942,7 @@
               <a:buChar char="•"/>
             </a:pPr>
             <a:r>
-              <a:rPr lang="en-US" sz="1150" dirty="0">
+              <a:rPr lang="en-US" sz="1100" dirty="0">
                 <a:solidFill>
                   <a:srgbClr val="1F3A3D"/>
                 </a:solidFill>
@@ -3928,7 +3952,7 @@
               </a:rPr>
               <a:t>Decomposing, scoring and summarising are judgement tasks - the model does those</a:t>
             </a:r>
-            <a:endParaRPr lang="en-US" sz="1150" dirty="0"/>
+            <a:endParaRPr lang="en-US" sz="1100" dirty="0"/>
           </a:p>
           <a:p>
             <a:pPr marL="342900" indent="-342900">
@@ -3939,7 +3963,7 @@
               <a:buChar char="•"/>
             </a:pPr>
             <a:r>
-              <a:rPr lang="en-US" sz="1150" dirty="0">
+              <a:rPr lang="en-US" sz="1100" dirty="0">
                 <a:solidFill>
                   <a:srgbClr val="1F3A3D"/>
                 </a:solidFill>
@@ -3949,7 +3973,7 @@
               </a:rPr>
               <a:t>Counting, de-duplicating, verifying DOIs, applying cut-offs - plain code does those</a:t>
             </a:r>
-            <a:endParaRPr lang="en-US" sz="1150" dirty="0"/>
+            <a:endParaRPr lang="en-US" sz="1100" dirty="0"/>
           </a:p>
           <a:p>
             <a:pPr marL="342900" indent="-342900">
@@ -3960,7 +3984,7 @@
               <a:buChar char="•"/>
             </a:pPr>
             <a:r>
-              <a:rPr lang="en-US" sz="1150" dirty="0">
+              <a:rPr lang="en-US" sz="1100" dirty="0">
                 <a:solidFill>
                   <a:srgbClr val="1F3A3D"/>
                 </a:solidFill>
@@ -3970,7 +3994,28 @@
               </a:rPr>
               <a:t>Every model reply is validated against a schema; one repair retry, then the run stops</a:t>
             </a:r>
-            <a:endParaRPr lang="en-US" sz="1150" dirty="0"/>
+            <a:endParaRPr lang="en-US" sz="1100" dirty="0"/>
+          </a:p>
+          <a:p>
+            <a:pPr marL="342900" indent="-342900">
+              <a:spcAft>
+                <a:spcPts val="500"/>
+              </a:spcAft>
+              <a:buSzPct val="100000"/>
+              <a:buChar char="•"/>
+            </a:pPr>
+            <a:r>
+              <a:rPr lang="en-US" sz="1100" dirty="0">
+                <a:solidFill>
+                  <a:srgbClr val="1F3A3D"/>
+                </a:solidFill>
+                <a:latin typeface="Calibri" pitchFamily="34" charset="0"/>
+                <a:ea typeface="Calibri" pitchFamily="34" charset="-122"/>
+                <a:cs typeface="Calibri" pitchFamily="34" charset="-120"/>
+              </a:rPr>
+              <a:t>Limits, model name and the list of sources live in one configuration file</a:t>
+            </a:r>
+            <a:endParaRPr lang="en-US" sz="1100" dirty="0"/>
           </a:p>
         </p:txBody>
       </p:sp>
@@ -4725,7 +4770,7 @@
                 <a:ea typeface="Calibri" pitchFamily="34" charset="-122"/>
                 <a:cs typeface="Calibri" pitchFamily="34" charset="-120"/>
               </a:rPr>
-              <a:t>OpenAlex, 20 records per sub-question</a:t>
+              <a:t>OpenAlex + Semantic Scholar, 20 records each; failover</a:t>
             </a:r>
             <a:endParaRPr lang="en-US" sz="950" dirty="0"/>
           </a:p>
@@ -5211,7 +5256,7 @@
                 <a:ea typeface="Calibri" pitchFamily="34" charset="-122"/>
                 <a:cs typeface="Calibri" pitchFamily="34" charset="-120"/>
               </a:rPr>
-              <a:t>If a search falls short</a:t>
+              <a:t>If a search falls short - or a source fails</a:t>
             </a:r>
             <a:endParaRPr lang="en-US" sz="1250" dirty="0"/>
           </a:p>
@@ -5226,7 +5271,7 @@
         <p:spPr>
           <a:xfrm>
             <a:off x="640080" y="3456432"/>
-            <a:ext cx="3657600" cy="1097280"/>
+            <a:ext cx="3657600" cy="1143000"/>
           </a:xfrm>
           <a:prstGeom prst="rect">
             <a:avLst/>
@@ -5246,7 +5291,7 @@
               <a:buChar char="•"/>
             </a:pPr>
             <a:r>
-              <a:rPr lang="en-US" sz="1050" dirty="0">
+              <a:rPr lang="en-US" sz="1000" dirty="0">
                 <a:solidFill>
                   <a:srgbClr val="1F3A3D"/>
                 </a:solidFill>
@@ -5254,9 +5299,9 @@
                 <a:ea typeface="Calibri" pitchFamily="34" charset="-122"/>
                 <a:cs typeface="Calibri" pitchFamily="34" charset="-120"/>
               </a:rPr>
-              <a:t>Fewer than 5 usable records, or fewer than 5 relevant after scoring</a:t>
-            </a:r>
-            <a:endParaRPr lang="en-US" sz="1050" dirty="0"/>
+              <a:t>Fewer than 5 usable records, or fewer than 5 relevant after scoring: the Planning Agent rewrites the query once, with the rejection reasons - never twice</a:t>
+            </a:r>
+            <a:endParaRPr lang="en-US" sz="1000" dirty="0"/>
           </a:p>
           <a:p>
             <a:pPr marL="342900" indent="-342900">
@@ -5267,7 +5312,7 @@
               <a:buChar char="•"/>
             </a:pPr>
             <a:r>
-              <a:rPr lang="en-US" sz="1050" dirty="0">
+              <a:rPr lang="en-US" sz="1000" dirty="0">
                 <a:solidFill>
                   <a:srgbClr val="1F3A3D"/>
                 </a:solidFill>
@@ -5275,30 +5320,9 @@
                 <a:ea typeface="Calibri" pitchFamily="34" charset="-122"/>
                 <a:cs typeface="Calibri" pitchFamily="34" charset="-120"/>
               </a:rPr>
-              <a:t>The Planning Agent rewrites the query once, with the rejection reasons</a:t>
-            </a:r>
-            <a:endParaRPr lang="en-US" sz="1050" dirty="0"/>
-          </a:p>
-          <a:p>
-            <a:pPr marL="342900" indent="-342900">
-              <a:spcAft>
-                <a:spcPts val="500"/>
-              </a:spcAft>
-              <a:buSzPct val="100000"/>
-              <a:buChar char="•"/>
-            </a:pPr>
-            <a:r>
-              <a:rPr lang="en-US" sz="1050" dirty="0">
-                <a:solidFill>
-                  <a:srgbClr val="1F3A3D"/>
-                </a:solidFill>
-                <a:latin typeface="Calibri" pitchFamily="34" charset="0"/>
-                <a:ea typeface="Calibri" pitchFamily="34" charset="-122"/>
-                <a:cs typeface="Calibri" pitchFamily="34" charset="-120"/>
-              </a:rPr>
-              <a:t>Never a second attempt - the researcher decides at Review 2</a:t>
-            </a:r>
-            <a:endParaRPr lang="en-US" sz="1050" dirty="0"/>
+              <a:t>A source that fails after its retries is skipped for that query and tried again on the next; the brief records it</a:t>
+            </a:r>
+            <a:endParaRPr lang="en-US" sz="1000" dirty="0"/>
           </a:p>
         </p:txBody>
       </p:sp>
@@ -5992,7 +6016,7 @@
                 <a:ea typeface="Cambria" pitchFamily="34" charset="-122"/>
                 <a:cs typeface="Cambria" pitchFamily="34" charset="-120"/>
               </a:rPr>
-              <a:t>Demo 2 - retrieve, verify, score, retry once</a:t>
+              <a:t>Demo 2 - two sources, verify, score, retry once</a:t>
             </a:r>
             <a:endParaRPr lang="en-US" sz="3000" dirty="0"/>
           </a:p>
@@ -6030,12 +6054,12 @@
         </p:nvSpPr>
         <p:spPr>
           <a:xfrm>
-            <a:off x="457200" y="2880360"/>
-            <a:ext cx="5669280" cy="1325880"/>
+            <a:off x="457200" y="2788920"/>
+            <a:ext cx="5669280" cy="1481328"/>
           </a:xfrm>
           <a:prstGeom prst="roundRect">
             <a:avLst>
-              <a:gd name="adj" fmla="val 4138"/>
+              <a:gd name="adj" fmla="val 3704"/>
             </a:avLst>
           </a:prstGeom>
           <a:solidFill>
@@ -6057,8 +6081,8 @@
         </p:nvSpPr>
         <p:spPr>
           <a:xfrm>
-            <a:off x="566928" y="2953512"/>
-            <a:ext cx="5449824" cy="1179576"/>
+            <a:off x="566928" y="2862072"/>
+            <a:ext cx="5449824" cy="1335024"/>
           </a:xfrm>
           <a:prstGeom prst="rect">
             <a:avLst/>
@@ -6074,7 +6098,7 @@
               <a:buNone/>
             </a:pPr>
             <a:r>
-              <a:rPr lang="en-US" sz="750" dirty="0">
+              <a:rPr lang="en-US" sz="720" dirty="0">
                 <a:solidFill>
                   <a:srgbClr val="8FB3AE"/>
                 </a:solidFill>
@@ -6082,16 +6106,16 @@
                 <a:ea typeface="Courier New" pitchFamily="34" charset="-122"/>
                 <a:cs typeface="Courier New" pitchFamily="34" charset="-120"/>
               </a:rPr>
-              <a:t># run.log, 22 Sept 09:44 - sub-question 4</a:t>
-            </a:r>
-            <a:endParaRPr lang="en-US" sz="750" dirty="0"/>
-          </a:p>
-          <a:p>
-            <a:pPr indent="0" marL="0">
-              <a:buNone/>
-            </a:pPr>
-            <a:r>
-              <a:rPr lang="en-US" sz="750" dirty="0">
+              <a:t># run.log, 30 Sept 10:11-10:15 (abridged)</a:t>
+            </a:r>
+            <a:endParaRPr lang="en-US" sz="720" dirty="0"/>
+          </a:p>
+          <a:p>
+            <a:pPr indent="0" marL="0">
+              <a:buNone/>
+            </a:pPr>
+            <a:r>
+              <a:rPr lang="en-US" sz="720" dirty="0">
                 <a:solidFill>
                   <a:srgbClr val="E6EFEE"/>
                 </a:solidFill>
@@ -6099,16 +6123,16 @@
                 <a:ea typeface="Courier New" pitchFamily="34" charset="-122"/>
                 <a:cs typeface="Courier New" pitchFamily="34" charset="-120"/>
               </a:rPr>
-              <a:t>evaluation   | evaluate summary | scored=12 | selected=1 | dropped=11 | cutoff=3</a:t>
-            </a:r>
-            <a:endParaRPr lang="en-US" sz="750" dirty="0"/>
-          </a:p>
-          <a:p>
-            <a:pPr indent="0" marL="0">
-              <a:buNone/>
-            </a:pPr>
-            <a:r>
-              <a:rPr lang="en-US" sz="750" dirty="0">
+              <a:t>retrieval | retrieving | subquestion=1 | sources=openalex,semanticscholar</a:t>
+            </a:r>
+            <a:endParaRPr lang="en-US" sz="720" dirty="0"/>
+          </a:p>
+          <a:p>
+            <a:pPr indent="0" marL="0">
+              <a:buNone/>
+            </a:pPr>
+            <a:r>
+              <a:rPr lang="en-US" sz="720" dirty="0">
                 <a:solidFill>
                   <a:srgbClr val="E6EFEE"/>
                 </a:solidFill>
@@ -6116,16 +6140,16 @@
                 <a:ea typeface="Courier New" pitchFamily="34" charset="-122"/>
                 <a:cs typeface="Courier New" pitchFamily="34" charset="-120"/>
               </a:rPr>
-              <a:t>orchestrator | threshold | subquestion=4 | the query returned 12 records but only</a:t>
-            </a:r>
-            <a:endParaRPr lang="en-US" sz="750" dirty="0"/>
-          </a:p>
-          <a:p>
-            <a:pPr indent="0" marL="0">
-              <a:buNone/>
-            </a:pPr>
-            <a:r>
-              <a:rPr lang="en-US" sz="750" dirty="0">
+              <a:t>retrieval | retrieved  | subquestion=1 | source=openalex | records=20 | with_abstract=20</a:t>
+            </a:r>
+            <a:endParaRPr lang="en-US" sz="720" dirty="0"/>
+          </a:p>
+          <a:p>
+            <a:pPr indent="0" marL="0">
+              <a:buNone/>
+            </a:pPr>
+            <a:r>
+              <a:rPr lang="en-US" sz="720" dirty="0">
                 <a:solidFill>
                   <a:srgbClr val="E6EFEE"/>
                 </a:solidFill>
@@ -6133,16 +6157,16 @@
                 <a:ea typeface="Courier New" pitchFamily="34" charset="-122"/>
                 <a:cs typeface="Courier New" pitchFamily="34" charset="-120"/>
               </a:rPr>
-              <a:t>               1 were relevant (minimum 5) | reformulating (1 of 1 allowed)</a:t>
-            </a:r>
-            <a:endParaRPr lang="en-US" sz="750" dirty="0"/>
-          </a:p>
-          <a:p>
-            <a:pPr indent="0" marL="0">
-              <a:buNone/>
-            </a:pPr>
-            <a:r>
-              <a:rPr lang="en-US" sz="750" dirty="0">
+              <a:t>http      | semanticscholar | HTTP 429 (transient) - retry 4/4 in 24s</a:t>
+            </a:r>
+            <a:endParaRPr lang="en-US" sz="720" dirty="0"/>
+          </a:p>
+          <a:p>
+            <a:pPr indent="0" marL="0">
+              <a:buNone/>
+            </a:pPr>
+            <a:r>
+              <a:rPr lang="en-US" sz="720" dirty="0">
                 <a:solidFill>
                   <a:srgbClr val="E6EFEE"/>
                 </a:solidFill>
@@ -6150,16 +6174,16 @@
                 <a:ea typeface="Courier New" pitchFamily="34" charset="-122"/>
                 <a:cs typeface="Courier New" pitchFamily="34" charset="-120"/>
               </a:rPr>
-              <a:t>planning     | reformulated | subquestion=4</a:t>
-            </a:r>
-            <a:endParaRPr lang="en-US" sz="750" dirty="0"/>
-          </a:p>
-          <a:p>
-            <a:pPr indent="0" marL="0">
-              <a:buNone/>
-            </a:pPr>
-            <a:r>
-              <a:rPr lang="en-US" sz="750" dirty="0">
+              <a:t>retrieval | subquestion=1 | source=semanticscholar failed (... after 4 retries</a:t>
+            </a:r>
+            <a:endParaRPr lang="en-US" sz="720" dirty="0"/>
+          </a:p>
+          <a:p>
+            <a:pPr indent="0" marL="0">
+              <a:buNone/>
+            </a:pPr>
+            <a:r>
+              <a:rPr lang="en-US" sz="720" dirty="0">
                 <a:solidFill>
                   <a:srgbClr val="E6EFEE"/>
                 </a:solidFill>
@@ -6167,16 +6191,16 @@
                 <a:ea typeface="Courier New" pitchFamily="34" charset="-122"/>
                 <a:cs typeface="Courier New" pitchFamily="34" charset="-120"/>
               </a:rPr>
-              <a:t>               old='benchmarking detecting hallucination evaluation metrics ...'</a:t>
-            </a:r>
-            <a:endParaRPr lang="en-US" sz="750" dirty="0"/>
-          </a:p>
-          <a:p>
-            <a:pPr indent="0" marL="0">
-              <a:buNone/>
-            </a:pPr>
-            <a:r>
-              <a:rPr lang="en-US" sz="750" dirty="0">
+              <a:t>            (last problem: HTTP 429)) - continuing with remaining sources</a:t>
+            </a:r>
+            <a:endParaRPr lang="en-US" sz="720" dirty="0"/>
+          </a:p>
+          <a:p>
+            <a:pPr indent="0" marL="0">
+              <a:buNone/>
+            </a:pPr>
+            <a:r>
+              <a:rPr lang="en-US" sz="720" dirty="0">
                 <a:solidFill>
                   <a:srgbClr val="E6EFEE"/>
                 </a:solidFill>
@@ -6184,16 +6208,16 @@
                 <a:ea typeface="Courier New" pitchFamily="34" charset="-122"/>
                 <a:cs typeface="Courier New" pitchFamily="34" charset="-120"/>
               </a:rPr>
-              <a:t>               new='hallucination benchmark evaluation long horizon ... detection'</a:t>
-            </a:r>
-            <a:endParaRPr lang="en-US" sz="750" dirty="0"/>
-          </a:p>
-          <a:p>
-            <a:pPr indent="0" marL="0">
-              <a:buNone/>
-            </a:pPr>
-            <a:r>
-              <a:rPr lang="en-US" sz="750" dirty="0">
+              <a:t>orchestr. | threshold | subquestion=4 | returned 8 records but only 2 were relevant</a:t>
+            </a:r>
+            <a:endParaRPr lang="en-US" sz="720" dirty="0"/>
+          </a:p>
+          <a:p>
+            <a:pPr indent="0" marL="0">
+              <a:buNone/>
+            </a:pPr>
+            <a:r>
+              <a:rPr lang="en-US" sz="720" dirty="0">
                 <a:solidFill>
                   <a:srgbClr val="E6EFEE"/>
                 </a:solidFill>
@@ -6201,9 +6225,43 @@
                 <a:ea typeface="Courier New" pitchFamily="34" charset="-122"/>
                 <a:cs typeface="Courier New" pitchFamily="34" charset="-120"/>
               </a:rPr>
-              <a:t>orchestrator | threshold | subquestion=4 | after reformulation: 13 new, 2 relevant</a:t>
-            </a:r>
-            <a:endParaRPr lang="en-US" sz="750" dirty="0"/>
+              <a:t>            (minimum 5) | reformulating (1 of 1 allowed)</a:t>
+            </a:r>
+            <a:endParaRPr lang="en-US" sz="720" dirty="0"/>
+          </a:p>
+          <a:p>
+            <a:pPr indent="0" marL="0">
+              <a:buNone/>
+            </a:pPr>
+            <a:r>
+              <a:rPr lang="en-US" sz="720" dirty="0">
+                <a:solidFill>
+                  <a:srgbClr val="E6EFEE"/>
+                </a:solidFill>
+                <a:latin typeface="Courier New" pitchFamily="34" charset="0"/>
+                <a:ea typeface="Courier New" pitchFamily="34" charset="-122"/>
+                <a:cs typeface="Courier New" pitchFamily="34" charset="-120"/>
+              </a:rPr>
+              <a:t>retrieval | retrieved | subquestion=4 | sources_answered=openalex,semanticscholar | records=40</a:t>
+            </a:r>
+            <a:endParaRPr lang="en-US" sz="720" dirty="0"/>
+          </a:p>
+          <a:p>
+            <a:pPr indent="0" marL="0">
+              <a:buNone/>
+            </a:pPr>
+            <a:r>
+              <a:rPr lang="en-US" sz="720" dirty="0">
+                <a:solidFill>
+                  <a:srgbClr val="E6EFEE"/>
+                </a:solidFill>
+                <a:latin typeface="Courier New" pitchFamily="34" charset="0"/>
+                <a:ea typeface="Courier New" pitchFamily="34" charset="-122"/>
+                <a:cs typeface="Courier New" pitchFamily="34" charset="-120"/>
+              </a:rPr>
+              <a:t>orchestr. | threshold | subquestion=4 | after reformulation: 33 new records, 20 relevant</a:t>
+            </a:r>
+            <a:endParaRPr lang="en-US" sz="720" dirty="0"/>
           </a:p>
         </p:txBody>
       </p:sp>
@@ -6215,7 +6273,7 @@
         </p:nvSpPr>
         <p:spPr>
           <a:xfrm>
-            <a:off x="457200" y="4279392"/>
+            <a:off x="457200" y="4315968"/>
             <a:ext cx="5669280" cy="365760"/>
           </a:xfrm>
           <a:prstGeom prst="rect">
@@ -6240,7 +6298,7 @@
                 <a:ea typeface="Calibri" pitchFamily="34" charset="-122"/>
                 <a:cs typeface="Calibri" pitchFamily="34" charset="-120"/>
               </a:rPr>
-              <a:t>Above: one score per paper with its reason.  Below: the single automatic retry, with the rejection reasons passed to the planner.</a:t>
+              <a:t>Above: one score per paper with its reason.  Below: a source failing over, and the single automatic retry with both sources answering.</a:t>
             </a:r>
             <a:endParaRPr lang="en-US" sz="950" dirty="0"/>
           </a:p>
@@ -6306,7 +6364,7 @@
                 <a:ea typeface="Cambria" pitchFamily="34" charset="-122"/>
                 <a:cs typeface="Cambria" pitchFamily="34" charset="-120"/>
               </a:rPr>
-              <a:t>80 → 65</a:t>
+              <a:t>140 → 117</a:t>
             </a:r>
             <a:endParaRPr lang="en-US" sz="1900" dirty="0"/>
           </a:p>
@@ -6321,7 +6379,7 @@
         <p:spPr>
           <a:xfrm>
             <a:off x="6492240" y="1554480"/>
-            <a:ext cx="2103120" cy="457200"/>
+            <a:ext cx="2103120" cy="502920"/>
           </a:xfrm>
           <a:prstGeom prst="rect">
             <a:avLst/>
@@ -6345,7 +6403,7 @@
                 <a:ea typeface="Calibri" pitchFamily="34" charset="-122"/>
                 <a:cs typeface="Calibri" pitchFamily="34" charset="-120"/>
               </a:rPr>
-              <a:t>records → unique papers</a:t>
+              <a:t>records from 2 sources → unique papers</a:t>
             </a:r>
             <a:endParaRPr lang="en-US" sz="950" dirty="0"/>
           </a:p>
@@ -6384,7 +6442,7 @@
                 <a:ea typeface="Cambria" pitchFamily="34" charset="-122"/>
                 <a:cs typeface="Cambria" pitchFamily="34" charset="-120"/>
               </a:rPr>
-              <a:t>46 / 65</a:t>
+              <a:t>78 / 117</a:t>
             </a:r>
             <a:endParaRPr lang="en-US" sz="1900" dirty="0"/>
           </a:p>
@@ -6399,7 +6457,7 @@
         <p:spPr>
           <a:xfrm>
             <a:off x="6492240" y="2423160"/>
-            <a:ext cx="2103120" cy="457200"/>
+            <a:ext cx="2103120" cy="502920"/>
           </a:xfrm>
           <a:prstGeom prst="rect">
             <a:avLst/>
@@ -6462,7 +6520,7 @@
                 <a:ea typeface="Cambria" pitchFamily="34" charset="-122"/>
                 <a:cs typeface="Cambria" pitchFamily="34" charset="-120"/>
               </a:rPr>
-              <a:t>26 kept</a:t>
+              <a:t>77 kept</a:t>
             </a:r>
             <a:endParaRPr lang="en-US" sz="1900" dirty="0"/>
           </a:p>
@@ -6477,7 +6535,7 @@
         <p:spPr>
           <a:xfrm>
             <a:off x="6492240" y="3291840"/>
-            <a:ext cx="2103120" cy="457200"/>
+            <a:ext cx="2103120" cy="502920"/>
           </a:xfrm>
           <a:prstGeom prst="rect">
             <a:avLst/>
@@ -6501,7 +6559,7 @@
                 <a:ea typeface="Calibri" pitchFamily="34" charset="-122"/>
                 <a:cs typeface="Calibri" pitchFamily="34" charset="-120"/>
               </a:rPr>
-              <a:t>of 78 retrieved, at cut-off 3/5, each with a reason</a:t>
+              <a:t>of 117 at cut-off 3/5, each with a reason</a:t>
             </a:r>
             <a:endParaRPr lang="en-US" sz="950" dirty="0"/>
           </a:p>
@@ -6540,7 +6598,7 @@
                 <a:ea typeface="Cambria" pitchFamily="34" charset="-122"/>
                 <a:cs typeface="Cambria" pitchFamily="34" charset="-120"/>
               </a:rPr>
-              <a:t>1 → 3</a:t>
+              <a:t>2 → 22</a:t>
             </a:r>
             <a:endParaRPr lang="en-US" sz="1900" dirty="0"/>
           </a:p>
@@ -6555,7 +6613,7 @@
         <p:spPr>
           <a:xfrm>
             <a:off x="6492240" y="4160520"/>
-            <a:ext cx="2103120" cy="457200"/>
+            <a:ext cx="2103120" cy="502920"/>
           </a:xfrm>
           <a:prstGeom prst="rect">
             <a:avLst/>
@@ -6579,7 +6637,7 @@
                 <a:ea typeface="Calibri" pitchFamily="34" charset="-122"/>
                 <a:cs typeface="Calibri" pitchFamily="34" charset="-120"/>
               </a:rPr>
-              <a:t>relevant papers for sub-question 4 after the single retry</a:t>
+              <a:t>relevant papers for sub-question 4 after the single retry (1 → 3 with one source)</a:t>
             </a:r>
             <a:endParaRPr lang="en-US" sz="950" dirty="0"/>
           </a:p>
@@ -6765,7 +6823,7 @@
                 <a:ea typeface="Courier New" pitchFamily="34" charset="-122"/>
                 <a:cs typeface="Courier New" pitchFamily="34" charset="-120"/>
               </a:rPr>
-              <a:t>Sub-question 4: How are hallucinations in autonomous agents benchmarked,</a:t>
+              <a:t>Sub-question 4: How are hallucination rates and factual accuracy evaluated</a:t>
             </a:r>
             <a:endParaRPr lang="en-US" sz="700" dirty="0"/>
           </a:p>
@@ -6782,7 +6840,7 @@
                 <a:ea typeface="Courier New" pitchFamily="34" charset="-122"/>
                 <a:cs typeface="Courier New" pitchFamily="34" charset="-120"/>
               </a:rPr>
-              <a:t>  detected, and evaluated ...? (query reformulated once: ... )</a:t>
+              <a:t>  in multi-step agent workflows? (query reformulated once: ... )</a:t>
             </a:r>
             <a:endParaRPr lang="en-US" sz="700" dirty="0"/>
           </a:p>
@@ -6799,7 +6857,7 @@
                 <a:ea typeface="Courier New" pitchFamily="34" charset="-122"/>
                 <a:cs typeface="Courier New" pitchFamily="34" charset="-120"/>
               </a:rPr>
-              <a:t>  24. [3/5] A survey on large language model based autonomous agents (2024)</a:t>
+              <a:t>  65. [5/5] AgentHallu: Benchmarking Automated Hallucination Attribution of</a:t>
             </a:r>
             <a:endParaRPr lang="en-US" sz="700" dirty="0"/>
           </a:p>
@@ -6816,7 +6874,7 @@
                 <a:ea typeface="Courier New" pitchFamily="34" charset="-122"/>
                 <a:cs typeface="Courier New" pitchFamily="34" charset="-120"/>
               </a:rPr>
-              <a:t>            - DOI verified</a:t>
+              <a:t>            LLM-based Agents (2026) - DOI UNVERIFIED</a:t>
             </a:r>
             <a:endParaRPr lang="en-US" sz="700" dirty="0"/>
           </a:p>
@@ -6833,7 +6891,7 @@
                 <a:ea typeface="Courier New" pitchFamily="34" charset="-122"/>
                 <a:cs typeface="Courier New" pitchFamily="34" charset="-120"/>
               </a:rPr>
-              <a:t>  25. [3/5] Benchmark Evaluations, Applications, and Challenges of Large</a:t>
+              <a:t>  76. [5/5] From Output Errors to Workflow Harm: A Practitioner-Audit Method</a:t>
             </a:r>
             <a:endParaRPr lang="en-US" sz="700" dirty="0"/>
           </a:p>
@@ -6850,7 +6908,7 @@
                 <a:ea typeface="Courier New" pitchFamily="34" charset="-122"/>
                 <a:cs typeface="Courier New" pitchFamily="34" charset="-120"/>
               </a:rPr>
-              <a:t>            Vision Language Models: A Survey (2025) - DOI verified</a:t>
+              <a:t>            for LLM-Mediated Research (2026) - DOI verified</a:t>
             </a:r>
             <a:endParaRPr lang="en-US" sz="700" dirty="0"/>
           </a:p>
@@ -6867,7 +6925,7 @@
                 <a:ea typeface="Courier New" pitchFamily="34" charset="-122"/>
                 <a:cs typeface="Courier New" pitchFamily="34" charset="-120"/>
               </a:rPr>
-              <a:t>  26. [4/5] Exploring Autonomous Agents through the Lens of Large Language</a:t>
+              <a:t>77 papers selected; 40 screened out (reasons are recorded in the brief).</a:t>
             </a:r>
             <a:endParaRPr lang="en-US" sz="700" dirty="0"/>
           </a:p>
@@ -6884,7 +6942,7 @@
                 <a:ea typeface="Courier New" pitchFamily="34" charset="-122"/>
                 <a:cs typeface="Courier New" pitchFamily="34" charset="-120"/>
               </a:rPr>
-              <a:t>            Models: A Review (2024) - DOI UNVERIFIED</a:t>
+              <a:t>Type 'approve' to write the brief, or 'drop 3, 7' ..., or 'reject' ...</a:t>
             </a:r>
             <a:endParaRPr lang="en-US" sz="700" dirty="0"/>
           </a:p>
@@ -6895,13 +6953,13 @@
             <a:r>
               <a:rPr lang="en-US" sz="700" dirty="0">
                 <a:solidFill>
-                  <a:srgbClr val="E6EFEE"/>
+                  <a:srgbClr val="F2C572"/>
                 </a:solidFill>
                 <a:latin typeface="Courier New" pitchFamily="34" charset="0"/>
                 <a:ea typeface="Courier New" pitchFamily="34" charset="-122"/>
                 <a:cs typeface="Courier New" pitchFamily="34" charset="-120"/>
               </a:rPr>
-              <a:t>26 papers selected; 52 screened out (reasons are recorded in the brief).</a:t>
+              <a:t>&gt; approve</a:t>
             </a:r>
             <a:endParaRPr lang="en-US" sz="700" dirty="0"/>
           </a:p>
@@ -6918,7 +6976,7 @@
                 <a:ea typeface="Courier New" pitchFamily="34" charset="-122"/>
                 <a:cs typeface="Courier New" pitchFamily="34" charset="-120"/>
               </a:rPr>
-              <a:t>Type 'approve' to write the brief, or 'drop 3, 7' ..., or 'reject' ...</a:t>
+              <a:t>evaluation   | summarising | subquestion=4 | batch=1/3 | papers=10</a:t>
             </a:r>
             <a:endParaRPr lang="en-US" sz="700" dirty="0"/>
           </a:p>
@@ -6929,13 +6987,13 @@
             <a:r>
               <a:rPr lang="en-US" sz="700" dirty="0">
                 <a:solidFill>
-                  <a:srgbClr val="F2C572"/>
+                  <a:srgbClr val="E6EFEE"/>
                 </a:solidFill>
                 <a:latin typeface="Courier New" pitchFamily="34" charset="0"/>
                 <a:ea typeface="Courier New" pitchFamily="34" charset="-122"/>
                 <a:cs typeface="Courier New" pitchFamily="34" charset="-120"/>
               </a:rPr>
-              <a:t>&gt; approve</a:t>
+              <a:t>evaluation   | summarised | papers=77</a:t>
             </a:r>
             <a:endParaRPr lang="en-US" sz="700" dirty="0"/>
           </a:p>
@@ -6952,7 +7010,7 @@
                 <a:ea typeface="Courier New" pitchFamily="34" charset="-122"/>
                 <a:cs typeface="Courier New" pitchFamily="34" charset="-120"/>
               </a:rPr>
-              <a:t>evaluation   | summarising | subquestion=1 | batch=1/1 | papers=9</a:t>
+              <a:t>evaluation   | synthesised | themes=4 | gaps=3</a:t>
             </a:r>
             <a:endParaRPr lang="en-US" sz="700" dirty="0"/>
           </a:p>
@@ -6969,7 +7027,7 @@
                 <a:ea typeface="Courier New" pitchFamily="34" charset="-122"/>
                 <a:cs typeface="Courier New" pitchFamily="34" charset="-120"/>
               </a:rPr>
-              <a:t>evaluation   | summarised | papers=26</a:t>
+              <a:t>117 unique papers across 4 sub-questions | 78 DOIs verified</a:t>
             </a:r>
             <a:endParaRPr lang="en-US" sz="700" dirty="0"/>
           </a:p>
@@ -6986,7 +7044,7 @@
                 <a:ea typeface="Courier New" pitchFamily="34" charset="-122"/>
                 <a:cs typeface="Courier New" pitchFamily="34" charset="-120"/>
               </a:rPr>
-              <a:t>evaluation   | synthesised | themes=3 | gaps=3</a:t>
+              <a:t>  | 77 approved, 40 excluded | 4 themes, 3 gaps | reformulations: 1</a:t>
             </a:r>
             <a:endParaRPr lang="en-US" sz="700" dirty="0"/>
           </a:p>
@@ -7003,41 +7061,7 @@
                 <a:ea typeface="Courier New" pitchFamily="34" charset="-122"/>
                 <a:cs typeface="Courier New" pitchFamily="34" charset="-120"/>
               </a:rPr>
-              <a:t>78 unique papers across 4 sub-questions | 55 DOIs verified</a:t>
-            </a:r>
-            <a:endParaRPr lang="en-US" sz="700" dirty="0"/>
-          </a:p>
-          <a:p>
-            <a:pPr indent="0" marL="0">
-              <a:buNone/>
-            </a:pPr>
-            <a:r>
-              <a:rPr lang="en-US" sz="700" dirty="0">
-                <a:solidFill>
-                  <a:srgbClr val="E6EFEE"/>
-                </a:solidFill>
-                <a:latin typeface="Courier New" pitchFamily="34" charset="0"/>
-                <a:ea typeface="Courier New" pitchFamily="34" charset="-122"/>
-                <a:cs typeface="Courier New" pitchFamily="34" charset="-120"/>
-              </a:rPr>
-              <a:t>  | 26 approved, 52 excluded | 3 themes, 3 gaps | reformulations: 1</a:t>
-            </a:r>
-            <a:endParaRPr lang="en-US" sz="700" dirty="0"/>
-          </a:p>
-          <a:p>
-            <a:pPr indent="0" marL="0">
-              <a:buNone/>
-            </a:pPr>
-            <a:r>
-              <a:rPr lang="en-US" sz="700" dirty="0">
-                <a:solidFill>
-                  <a:srgbClr val="E6EFEE"/>
-                </a:solidFill>
-                <a:latin typeface="Courier New" pitchFamily="34" charset="0"/>
-                <a:ea typeface="Courier New" pitchFamily="34" charset="-122"/>
-                <a:cs typeface="Courier New" pitchFamily="34" charset="-120"/>
-              </a:rPr>
-              <a:t>Stage 6 complete - brief written.</a:t>
+              <a:t>Run complete - brief written.</a:t>
             </a:r>
             <a:endParaRPr lang="en-US" sz="700" dirty="0"/>
           </a:p>
@@ -7103,7 +7127,7 @@
                 <a:ea typeface="Calibri" pitchFamily="34" charset="-122"/>
                 <a:cs typeface="Calibri" pitchFamily="34" charset="-120"/>
               </a:rPr>
-              <a:t>From the brief (22 Sept run, abridged)</a:t>
+              <a:t>From the brief (30 Sept run, abridged)</a:t>
             </a:r>
             <a:endParaRPr lang="en-US" sz="1150" dirty="0"/>
           </a:p>
@@ -7134,7 +7158,7 @@
               <a:buNone/>
             </a:pPr>
             <a:r>
-              <a:rPr lang="en-US" sz="950" b="1" dirty="0">
+              <a:rPr lang="en-US" sz="900" b="1" dirty="0">
                 <a:solidFill>
                   <a:srgbClr val="8A5A17"/>
                 </a:solidFill>
@@ -7142,13 +7166,13 @@
                 <a:ea typeface="Calibri" pitchFamily="34" charset="-122"/>
                 <a:cs typeface="Calibri" pitchFamily="34" charset="-120"/>
               </a:rPr>
-              <a:t>Evidence note [5]  </a:t>
-            </a:r>
-            <a:pPr indent="0" marL="0">
-              <a:buNone/>
-            </a:pPr>
-            <a:r>
-              <a:rPr lang="en-US" sz="950" dirty="0">
+              <a:t>Evidence note [76]  </a:t>
+            </a:r>
+            <a:pPr indent="0" marL="0">
+              <a:buNone/>
+            </a:pPr>
+            <a:r>
+              <a:rPr lang="en-US" sz="900" dirty="0">
                 <a:solidFill>
                   <a:srgbClr val="1F3A3D"/>
                 </a:solidFill>
@@ -7156,25 +7180,25 @@
                 <a:ea typeface="Calibri" pitchFamily="34" charset="-122"/>
                 <a:cs typeface="Calibri" pitchFamily="34" charset="-120"/>
               </a:rPr>
-              <a:t>RAG-based legal tools reduce hallucinations versus GPT-4 but still hallucinate 17-33% of the time - every figure is in the paper's abstract.</a:t>
-            </a:r>
-            <a:pPr indent="0" marL="0">
-              <a:buNone/>
-            </a:pPr>
-            <a:endParaRPr lang="en-US" sz="950" dirty="0"/>
-          </a:p>
-          <a:p>
-            <a:pPr indent="0" marL="0">
-              <a:buNone/>
-            </a:pPr>
-            <a:endParaRPr lang="en-US" sz="950" dirty="0"/>
-          </a:p>
-          <a:p>
-            <a:pPr indent="0" marL="0">
-              <a:buNone/>
-            </a:pPr>
-            <a:r>
-              <a:rPr lang="en-US" sz="950" b="1" dirty="0">
+              <a:t>TRACE, a practitioner-audit framework, demonstrated on 45 documentation-positive incidents recorded by a clinician-informatician - the figure is in the paper's abstract. Found by Semantic Scholar only.</a:t>
+            </a:r>
+            <a:pPr indent="0" marL="0">
+              <a:buNone/>
+            </a:pPr>
+            <a:endParaRPr lang="en-US" sz="900" dirty="0"/>
+          </a:p>
+          <a:p>
+            <a:pPr indent="0" marL="0">
+              <a:buNone/>
+            </a:pPr>
+            <a:endParaRPr lang="en-US" sz="900" dirty="0"/>
+          </a:p>
+          <a:p>
+            <a:pPr indent="0" marL="0">
+              <a:buNone/>
+            </a:pPr>
+            <a:r>
+              <a:rPr lang="en-US" sz="900" b="1" dirty="0">
                 <a:solidFill>
                   <a:srgbClr val="8A5A17"/>
                 </a:solidFill>
@@ -7184,14 +7208,14 @@
               </a:rPr>
               <a:t>Theme  </a:t>
             </a:r>
-            <a:endParaRPr lang="en-US" sz="950" dirty="0"/>
-          </a:p>
-          <a:p>
-            <a:pPr indent="0" marL="0">
-              <a:buNone/>
-            </a:pPr>
-            <a:r>
-              <a:rPr lang="en-US" sz="950" dirty="0">
+            <a:endParaRPr lang="en-US" sz="900" dirty="0"/>
+          </a:p>
+          <a:p>
+            <a:pPr indent="0" marL="0">
+              <a:buNone/>
+            </a:pPr>
+            <a:r>
+              <a:rPr lang="en-US" sz="900" dirty="0">
                 <a:solidFill>
                   <a:srgbClr val="1F3A3D"/>
                 </a:solidFill>
@@ -7199,25 +7223,25 @@
                 <a:ea typeface="Calibri" pitchFamily="34" charset="-122"/>
                 <a:cs typeface="Calibri" pitchFamily="34" charset="-120"/>
               </a:rPr>
-              <a:t>Self-reflection and multi-agent consensus reduce unfaithful reasoning through iterative verification loops. [10, 11, 14, 16, 17]</a:t>
-            </a:r>
-            <a:pPr indent="0" marL="0">
-              <a:buNone/>
-            </a:pPr>
-            <a:endParaRPr lang="en-US" sz="950" dirty="0"/>
-          </a:p>
-          <a:p>
-            <a:pPr indent="0" marL="0">
-              <a:buNone/>
-            </a:pPr>
-            <a:endParaRPr lang="en-US" sz="950" dirty="0"/>
-          </a:p>
-          <a:p>
-            <a:pPr indent="0" marL="0">
-              <a:buNone/>
-            </a:pPr>
-            <a:r>
-              <a:rPr lang="en-US" sz="950" b="1" dirty="0">
+              <a:t>Evaluation of multi-step agent workflows involves specialised benchmarks, automated hallucination attribution frameworks, multi-agent audits and domain-aware metrics. [63, 64, 65, 67, 73, 74, 76, 77]</a:t>
+            </a:r>
+            <a:pPr indent="0" marL="0">
+              <a:buNone/>
+            </a:pPr>
+            <a:endParaRPr lang="en-US" sz="900" dirty="0"/>
+          </a:p>
+          <a:p>
+            <a:pPr indent="0" marL="0">
+              <a:buNone/>
+            </a:pPr>
+            <a:endParaRPr lang="en-US" sz="900" dirty="0"/>
+          </a:p>
+          <a:p>
+            <a:pPr indent="0" marL="0">
+              <a:buNone/>
+            </a:pPr>
+            <a:r>
+              <a:rPr lang="en-US" sz="900" b="1" dirty="0">
                 <a:solidFill>
                   <a:srgbClr val="8A5A17"/>
                 </a:solidFill>
@@ -7227,14 +7251,14 @@
               </a:rPr>
               <a:t>Gap  </a:t>
             </a:r>
-            <a:endParaRPr lang="en-US" sz="950" dirty="0"/>
-          </a:p>
-          <a:p>
-            <a:pPr indent="0" marL="0">
-              <a:buNone/>
-            </a:pPr>
-            <a:r>
-              <a:rPr lang="en-US" sz="950" dirty="0">
+            <a:endParaRPr lang="en-US" sz="900" dirty="0"/>
+          </a:p>
+          <a:p>
+            <a:pPr indent="0" marL="0">
+              <a:buNone/>
+            </a:pPr>
+            <a:r>
+              <a:rPr lang="en-US" sz="900" dirty="0">
                 <a:solidFill>
                   <a:srgbClr val="1F3A3D"/>
                 </a:solidFill>
@@ -7242,25 +7266,25 @@
                 <a:ea typeface="Calibri" pitchFamily="34" charset="-122"/>
                 <a:cs typeface="Calibri" pitchFamily="34" charset="-120"/>
               </a:rPr>
-              <a:t>Sub-question 4 lacks direct empirical work on long-horizon agent tasks; most evidence is surveys.</a:t>
-            </a:r>
-            <a:pPr indent="0" marL="0">
-              <a:buNone/>
-            </a:pPr>
-            <a:endParaRPr lang="en-US" sz="950" dirty="0"/>
-          </a:p>
-          <a:p>
-            <a:pPr indent="0" marL="0">
-              <a:buNone/>
-            </a:pPr>
-            <a:endParaRPr lang="en-US" sz="950" dirty="0"/>
-          </a:p>
-          <a:p>
-            <a:pPr indent="0" marL="0">
-              <a:buNone/>
-            </a:pPr>
-            <a:r>
-              <a:rPr lang="en-US" sz="950" b="1" dirty="0">
+              <a:t>Few papers address the computational overhead and latency of continuous self-correction loops.</a:t>
+            </a:r>
+            <a:pPr indent="0" marL="0">
+              <a:buNone/>
+            </a:pPr>
+            <a:endParaRPr lang="en-US" sz="900" dirty="0"/>
+          </a:p>
+          <a:p>
+            <a:pPr indent="0" marL="0">
+              <a:buNone/>
+            </a:pPr>
+            <a:endParaRPr lang="en-US" sz="900" dirty="0"/>
+          </a:p>
+          <a:p>
+            <a:pPr indent="0" marL="0">
+              <a:buNone/>
+            </a:pPr>
+            <a:r>
+              <a:rPr lang="en-US" sz="900" b="1" dirty="0">
                 <a:solidFill>
                   <a:srgbClr val="8A5A17"/>
                 </a:solidFill>
@@ -7270,14 +7294,14 @@
               </a:rPr>
               <a:t>Limitation  </a:t>
             </a:r>
-            <a:endParaRPr lang="en-US" sz="950" dirty="0"/>
-          </a:p>
-          <a:p>
-            <a:pPr indent="0" marL="0">
-              <a:buNone/>
-            </a:pPr>
-            <a:r>
-              <a:rPr lang="en-US" sz="950" dirty="0">
+            <a:endParaRPr lang="en-US" sz="900" dirty="0"/>
+          </a:p>
+          <a:p>
+            <a:pPr indent="0" marL="0">
+              <a:buNone/>
+            </a:pPr>
+            <a:r>
+              <a:rPr lang="en-US" sz="900" dirty="0">
                 <a:solidFill>
                   <a:srgbClr val="1F3A3D"/>
                 </a:solidFill>
@@ -7285,9 +7309,9 @@
                 <a:ea typeface="Calibri" pitchFamily="34" charset="-122"/>
                 <a:cs typeface="Calibri" pitchFamily="34" charset="-120"/>
               </a:rPr>
-              <a:t>Sub-question(s) 4 (3 papers) ended with fewer than 5 approved papers; conclusions there rest on thin evidence.</a:t>
-            </a:r>
-            <a:endParaRPr lang="en-US" sz="950" dirty="0"/>
+              <a:t>openalex: 5 of 5 searches answered, 100 records; semanticscholar: 2 of 5, 40 records. Automatic failover was used: semanticscholar failed for 3 search(es).</a:t>
+            </a:r>
+            <a:endParaRPr lang="en-US" sz="900" dirty="0"/>
           </a:p>
         </p:txBody>
       </p:sp>
@@ -7493,7 +7517,7 @@
                 <a:ea typeface="Cambria" pitchFamily="34" charset="-122"/>
                 <a:cs typeface="Cambria" pitchFamily="34" charset="-120"/>
               </a:rPr>
-              <a:t>56</a:t>
+              <a:t>68</a:t>
             </a:r>
             <a:endParaRPr lang="en-US" sz="4400" dirty="0"/>
           </a:p>
@@ -7563,7 +7587,7 @@
               <a:buNone/>
             </a:pPr>
             <a:r>
-              <a:rPr lang="en-US" sz="1000" dirty="0">
+              <a:rPr lang="en-US" sz="950" dirty="0">
                 <a:solidFill>
                   <a:srgbClr val="1F3A3D"/>
                 </a:solidFill>
@@ -7571,9 +7595,9 @@
                 <a:ea typeface="Calibri" pitchFamily="34" charset="-122"/>
                 <a:cs typeface="Calibri" pitchFamily="34" charset="-120"/>
               </a:rPr>
-              <a:t>pytest, no network. Recorded API replies in tests/fixtures. Data models, abstract reconstruction, de-duplication and DOI checks, the 3-5 rule, schema validation and repair, review loops, threshold and retry caps, cut-off, batching, themes citing non-existent papers, retry policies, brief layout.</a:t>
-            </a:r>
-            <a:endParaRPr lang="en-US" sz="1000" dirty="0"/>
+              <a:t>pytest, no network. Recorded API replies in tests/fixtures. Data models, abstract reconstruction, de-duplication and DOI checks, the 3-5 rule, schema validation and repair, review loops, threshold and retry caps, cut-off, batching, themes citing non-existent papers, retry policies, brief layout; the second source, merging and failover.</a:t>
+            </a:r>
+            <a:endParaRPr lang="en-US" sz="950" dirty="0"/>
           </a:p>
         </p:txBody>
       </p:sp>
@@ -7637,7 +7661,7 @@
                 <a:ea typeface="Cambria" pitchFamily="34" charset="-122"/>
                 <a:cs typeface="Cambria" pitchFamily="34" charset="-120"/>
               </a:rPr>
-              <a:t>9</a:t>
+              <a:t>11</a:t>
             </a:r>
             <a:endParaRPr lang="en-US" sz="4400" dirty="0"/>
           </a:p>
@@ -7707,7 +7731,7 @@
               <a:buNone/>
             </a:pPr>
             <a:r>
-              <a:rPr lang="en-US" sz="1000" dirty="0">
+              <a:rPr lang="en-US" sz="950" dirty="0">
                 <a:solidFill>
                   <a:srgbClr val="1F3A3D"/>
                 </a:solidFill>
@@ -7715,9 +7739,9 @@
                 <a:ea typeface="Calibri" pitchFamily="34" charset="-122"/>
                 <a:cs typeface="Calibri" pitchFamily="34" charset="-120"/>
               </a:rPr>
-              <a:t>Live, against the real services, each with command, expected and observed result. Missing key; drop at Review 2; revise at Review 1; reject scope once then refused; full run; threshold retry; transient errors; daily quota stop; malformed-JSON repair. All pass.</a:t>
-            </a:r>
-            <a:endParaRPr lang="en-US" sz="1000" dirty="0"/>
+              <a:t>Live, against the real services, each with command, expected and observed result. Missing key; drop; revise; reject scope once then refused; full run; threshold retry; transient errors; daily quota stop; malformed-JSON repair; two-source run with real failover; non-transient failure not retried. All pass.</a:t>
+            </a:r>
+            <a:endParaRPr lang="en-US" sz="950" dirty="0"/>
           </a:p>
         </p:txBody>
       </p:sp>
@@ -7851,7 +7875,7 @@
               <a:buNone/>
             </a:pPr>
             <a:r>
-              <a:rPr lang="en-US" sz="1000" dirty="0">
+              <a:rPr lang="en-US" sz="950" dirty="0">
                 <a:solidFill>
                   <a:srgbClr val="1F3A3D"/>
                 </a:solidFill>
@@ -7861,7 +7885,7 @@
               </a:rPr>
               <a:t>Every problem met during development, its cause, the change made, and how the fix was verified - the model retirement, 503s, timeouts, quotas, OpenAlex's policy change, a typo that re-planned.</a:t>
             </a:r>
-            <a:endParaRPr lang="en-US" sz="1000" dirty="0"/>
+            <a:endParaRPr lang="en-US" sz="950" dirty="0"/>
           </a:p>
         </p:txBody>
       </p:sp>
@@ -7925,7 +7949,7 @@
                 <a:ea typeface="Courier New" pitchFamily="34" charset="-122"/>
                 <a:cs typeface="Courier New" pitchFamily="34" charset="-120"/>
               </a:rPr>
-              <a:t>$ pytest</a:t>
+              <a:t>$ pytest -q</a:t>
             </a:r>
             <a:endParaRPr lang="en-US" sz="800" dirty="0"/>
           </a:p>
@@ -7942,7 +7966,7 @@
                 <a:ea typeface="Courier New" pitchFamily="34" charset="-122"/>
                 <a:cs typeface="Courier New" pitchFamily="34" charset="-120"/>
               </a:rPr>
-              <a:t>collected 56 items   (evaluation 13 . http 5 . models 5 . planning 6 . search_client 4 . stage5 8 . storage 1 . synthesis 9 . validation 5)</a:t>
+              <a:t>collected 68 items   (evaluation 13 . http 5 . models 5 . planning 6 . retrieval 7 . s2_client 5 . search_client 4 . stage5 8 . storage 1 . synthesis 9 . validation 5)</a:t>
             </a:r>
             <a:endParaRPr lang="en-US" sz="800" dirty="0"/>
           </a:p>
@@ -7959,7 +7983,7 @@
                 <a:ea typeface="Courier New" pitchFamily="34" charset="-122"/>
                 <a:cs typeface="Courier New" pitchFamily="34" charset="-120"/>
               </a:rPr>
-              <a:t>56 passed in 0.33s</a:t>
+              <a:t>68 passed in 0.32s</a:t>
             </a:r>
             <a:endParaRPr lang="en-US" sz="800" dirty="0"/>
           </a:p>
@@ -8853,7 +8877,7 @@
         </p:nvSpPr>
         <p:spPr>
           <a:xfrm>
-            <a:off x="457200" y="4343400"/>
+            <a:off x="457200" y="4315968"/>
             <a:ext cx="8229600" cy="457200"/>
           </a:xfrm>
           <a:prstGeom prst="rect">
@@ -8878,7 +8902,7 @@
                 <a:ea typeface="Calibri" pitchFamily="34" charset="-122"/>
                 <a:cs typeface="Calibri" pitchFamily="34" charset="-120"/>
               </a:rPr>
-              <a:t>None of these needed a rewrite. Keeping every tunable in one configuration module, and every external call behind one small client, is what made each fix a line or two - 13 commits across September.</a:t>
+              <a:t>None of these needed a rewrite. Keeping every tunable in one configuration module, and every external call behind one small client, is what made each fix a line or two - and adding a second source one new module. Commits run from 9 to 30 September, roughly one per stage.</a:t>
             </a:r>
             <a:endParaRPr lang="en-US" sz="1050" dirty="0"/>
           </a:p>

</xml_diff>

<commit_message>
113 tests; FT-12 to FT-16 live runs of 2 October; FT-13 screening checked by a second Gemini model (evidence/judge_with_model.py, kappa 0.65); README, presentation at 20 minutes and transcript updated
</commit_message>
<xml_diff>
--- a/presentation/Research_Agent_Presentation.pptx
+++ b/presentation/Research_Agent_Presentation.pptx
@@ -510,10 +510,8 @@
           <a:lstStyle/>
           <a:p>
             <a:r>
-              <a:rPr lang="en-US" dirty="0"/>
-              <a:t>Hello, and thanks for watching. This is my individual project for the Intelligent Agents module. Earlier in the module our group designed a research agent on paper. My job here was to build it, test it, and then, once that design had been marked, act on the feedback. The system takes a research question and turns it into an evidence brief that a researcher can check line by line. Over the next fifteen minutes I'll cover what the design asked for, how I built it, show it running on a real question, go through the testing, what went wrong along the way, what I changed after the tutor's feedback, and where it still falls short. The code, the tests, the logs and the README are all in the GitHub repository on the slide.</a:t>
-            </a:r>
-            <a:endParaRPr lang="en-US" dirty="0"/>
+              <a:t>Hello, and thanks for watching. This is my individual project for the Intelligent Agents module. Earlier in the module our group designed a research agent on paper. My job here was to build it, test it, and then, once that design had been marked, act on the feedback. The system takes a research question and turns it into an evidence brief that a researcher can check line by line. In this presentation I'll cover what the design asked for, how I built it, a real run, the testing, what went wrong, what I changed after the tutor's feedback, and where it still falls short. The code, the tests, the logs and the README are all in the GitHub repository on the slide.</a:t>
+            </a:r>
           </a:p>
         </p:txBody>
       </p:sp>
@@ -598,12 +596,20 @@
           <a:lstStyle/>
           <a:p>
             <a:r>
-              <a:rPr lang="en-US" dirty="0"/>
-              <a:t>To finish, a fair comparison with the design, and what changed after the feedback. Where it matters, the implementation matches: the three agents, the orchestrator, the four data classes and the decision enum, both review points, both autonomy limits, Crossref checking that flags but never drops, and the brief with notes, themes, gaps, limitations and references. Three small departures: a second retry trigger after scoring, because a search can return twenty perfect abstracts of which only one answers the question; a shared retry policy the design never mentioned, because the services forced it; and the previous query kept on each sub-question so the brief can show both.
-The feedback had three points, and each has an answer. The model choice is now justified with the provider's own figures - a million-token context against prompts of twelve thousand, structured output supported, five hundred requests a day on the free tier, thirty cents per million input tokens, and the benchmark scores, with the caveat that none of them measures abstract screening. The test targets are stated honestly, as I said: what is measured, what is not, and what a gold set would have to look like. And the third point was built: two sources for every search, failover between them, seventy-eight papers becoming a hundred and seventeen on the same question.
-The limits are real. Abstracts only, twenty per query per source. The Lite model is a more generous judge than the full Flash model, forty-two papers kept against twenty-six on the same question, so the cut-off needs calibrating per model. A paper published under two DOIs is still not merged. And without a key, Semantic Scholar's public pool refuses more than it answers. Next would be a DataCite lookup for the preprints, a labelled set so recall and precision can finally be measured, and full text where it is open. Everything is in the repository, and the README explains how to run it. Thank you for listening.</a:t>
-            </a:r>
-            <a:endParaRPr lang="en-US" dirty="0"/>
+              <a:t>To finish, a comparison with the design. Where it matters, the implementation matches the design: the agents, the orchestrator, both reviews, both limits, the Crossref check and the brief. The README lists every departure; these are the main ones. The proposal put Semantic Scholar first with OpenAlex as the fallback, and I built on OpenAlex alone until the last stage, because it needed no key when I started. Checking and scoring run one sub-question at a time, with a second retry trigger after scoring. Crossref compares the title, not all the metadata. And a second scope rejection is refused instead of stopping the run.</a:t>
+            </a:r>
+          </a:p>
+          <a:p/>
+          <a:p>
+            <a:r>
+              <a:t>The feedback had three points, and each has an answer. The model choice is now justified with the provider's own figures - context size against the size of my prompts, structured output, free-tier quota, price and benchmarks - with two caveats: function calling is not used at all, because the orchestrator calls the tools, and no benchmark measures abstract screening. The targets and their datasets are stated, as I said. And the third point was built: two sources for every search, failover between them, seventy-seven unique papers becoming a hundred and seventeen on the same plan and model.</a:t>
+            </a:r>
+          </a:p>
+          <a:p/>
+          <a:p>
+            <a:r>
+              <a:t>The limits: abstracts only, twenty per query per source. Without a key, Semantic Scholar refused every live search on the second of October, so the new searches of those runs rested on OpenAlex alone. The Lite model kept forty-two of seventy-seven papers where the full Flash model kept twenty-six of seventy-eight - each on its own plan - and the second opinion disagreed only around the cut-off, so the cut-off needs calibrating per model. One professional point: on the free tier the provider may use prompts to improve its products, so a confidential question needs a paid key. Next would be a DataCite lookup for the preprints, the gold set, and full text where it is open. Everything is in the repository; the references are in the README and the transcript. Thank you for listening.</a:t>
+            </a:r>
           </a:p>
         </p:txBody>
       </p:sp>
@@ -688,12 +694,20 @@
           <a:lstStyle/>
           <a:p>
             <a:r>
-              <a:rPr lang="en-US" dirty="0"/>
-              <a:t>The starting point was our Group D design proposal. A research question goes in, a traceable evidence brief comes out. The design pinned down quite a lot before any code existed: three specialised agents and a coordinator that is deliberately not an agent; two human reviews, first of the plan and then of the evidence; every DOI checked against Crossref before it can be cited; limited autonomy, meaning one automatic retry of a query per sub-question and one scope revision per run; and a brief that has to say what it could not cover.
-All of that comes from one fear. Ask a language model for literature and it will give you plausible papers that don't exist. So in this system the model never writes a reference. It breaks questions down, scores relevance and summarises abstracts, and that's all. Anything with an exact answer - de-duplication, DOI checks, the reference list - is plain code.
-My task was to build that, test it, and show it working. The design itself was marked at the end of September, with three points of feedback: justify the choice of model, set measurable quality targets, and use more than one literature source with automatic failover. Those three points shaped the last stage of the build, and I'll come back to each of them.</a:t>
-            </a:r>
-            <a:endParaRPr lang="en-US" dirty="0"/>
+              <a:t>The starting point was our Group D design proposal. The design pinned down a lot before any code existed: three specialised agents and a coordinator that is deliberately not an agent; two human reviews; every DOI checked against Crossref; one automatic retry per sub-question and one scope revision per run; and a brief that has to say what it could not cover.</a:t>
+            </a:r>
+          </a:p>
+          <a:p/>
+          <a:p>
+            <a:r>
+              <a:t>All of that comes from one fear. Ask a language model for literature and it will give you plausible papers that don't exist - Walters and Wilder measured exactly that for ChatGPT in 2023. So in this system the model never writes a reference. It turns questions into search queries, scores relevance, summarises abstracts and draws themes from those summaries - nothing more. Anything with an exact answer - de-duplication, DOI checks, the reference list - is plain code.</a:t>
+            </a:r>
+          </a:p>
+          <a:p/>
+          <a:p>
+            <a:r>
+              <a:t>My task was to build that, test it, and show it working. The feedback on the design reached me at the end of September, with three points: justify the choice of model, set measurable quality targets, and use more than one literature source with automatic failover.</a:t>
+            </a:r>
           </a:p>
         </p:txBody>
       </p:sp>
@@ -778,11 +792,20 @@
           <a:lstStyle/>
           <a:p>
             <a:r>
-              <a:rPr lang="en-US" dirty="0"/>
-              <a:t>The architecture follows the class diagram from our proposal. The researcher talks to one boundary class, which handles both reviews. Behind it, the orchestrator runs the steps in a fixed order, enforces the limits, and does the exact work itself. Under it are the three agents. The Planning Agent uses the language model to turn the question into sub-questions and queries, and to rewrite a query when a search comes up short. The Retrieval Agent has no model at all: it searches two sources, OpenAlex and Semantic Scholar, for every sub-question, merges what comes back, and decides, by counting, whether it got enough usable records. If one source is down or rate-limited it carries on with the other and remembers that for the brief. The Evaluation and Synthesis Agent uses the model for judgement: scoring each paper's relevance with a reason, and later writing notes, themes and gaps from whatever was approved.
-What passes between them are the four classes from the diagram, as Pydantic models. Every reply from the model is parsed against a schema; if it doesn't fit, the error goes back once for repair, and if that fails the run stops. I'd rather it stopped than carried on with a broken object. The numbers on the right are the autonomy limits from the design. They live in one configuration file, together with the model name and the list of sources, so none of them is buried in an agent.</a:t>
-            </a:r>
-            <a:endParaRPr lang="en-US" dirty="0"/>
+              <a:t>The architecture follows the class diagram from our proposal. The researcher talks to one boundary class for both reviews. Behind it, the orchestrator runs the steps in a fixed order, enforces the limits, and does the exact work itself. The Planning Agent uses the language model to turn the question into sub-questions and queries, and to rewrite a query when a search comes up short. The Retrieval Agent has no model at all: it searches two sources, OpenAlex and Semantic Scholar, for every sub-question, merges what comes back, and decides, by counting, whether it got enough usable records. The Evaluation and Synthesis Agent uses the model for judgement: scoring each paper's relevance with a reason, and later writing notes, themes and gaps from whatever was approved.</a:t>
+            </a:r>
+          </a:p>
+          <a:p/>
+          <a:p>
+            <a:r>
+              <a:t>Two choices here rest on the literature. Each agent has one goal of its own, the goal-directed behaviour Wooldridge and Jennings ask of an agent, and the split into roles follows the Gaia method. To be exact, only the Retrieval Agent checks its own goal; the plan is judged by the researcher, and the number of relevant papers by the orchestrator. And there is one coordinator on purpose: Kim and colleagues reported this year that designs without central verification pass errors on more strongly.</a:t>
+            </a:r>
+          </a:p>
+          <a:p/>
+          <a:p>
+            <a:r>
+              <a:t>Every model reply is checked against a schema, repaired once if needed, or the run stops. The numbers on the right are the limits the agents work within: the first three come from the design, the relevance cut-off was chosen during the build, and all four live in one configuration file.</a:t>
+            </a:r>
           </a:p>
         </p:txBody>
       </p:sp>
@@ -867,11 +890,14 @@
           <a:lstStyle/>
           <a:p>
             <a:r>
-              <a:rPr lang="en-US" dirty="0"/>
-              <a:t>Here's one run from start to finish. The question is planned into three to five sub-questions with search queries, and that plan goes to the researcher at Review 1: approve, or say what to change and get a new one. Nothing has been searched yet, so that loop can repeat freely. Each sub-question is then searched on both sources, twenty records from each. The results are merged and de-duplicated by DOI, every DOI is looked up in Crossref, and each paper is scored one to five from its abstract with a one-sentence reason. Review 2 shows every paper above the cut-off and offers three choices: approve, drop papers by number, or reject the scope and go back to planning, which is allowed once. After approval the agent writes a note per paper, then themes and gaps, and the orchestrator adds a limitations section computed from the run and a reference list built from the records.
-Two pieces of automatic behaviour sit in the middle. If a search falls short - too few abstracts, or too few relevant papers after scoring - the Planning Agent rewrites the query once and is told why the search fell short. It never gets a second attempt. And if a source fails after its retries, the Retrieval Agent skips it for that query, tries it again on the next one, and the brief records how many searches each source answered. Only if every source fails does the run stop, because then there is nothing honest to continue with.</a:t>
-            </a:r>
-            <a:endParaRPr lang="en-US" dirty="0"/>
+              <a:t>A run starts with one command: python main dot py, and the question. The question is planned into three to five sub-questions with search queries, and that plan goes to the researcher at Review 1: approve, or say what to change. Each sub-question is then searched on both sources, twenty records from each. The results are merged and de-duplicated by DOI, every DOI is looked up in Crossref, and each paper is scored one to five from its abstract, with a reason. Review 2 shows every paper that reached the cut-off and offers three choices: approve, drop papers by number, or reject the scope and go back to planning. After approval the agent writes a note per paper, then themes and gaps, and the orchestrator adds limitations computed from the run and a reference list built from the records.</a:t>
+            </a:r>
+          </a:p>
+          <a:p/>
+          <a:p>
+            <a:r>
+              <a:t>If a search falls short - too few usable records, or too few relevant papers after scoring - the Planning Agent rewrites the query once, and only once. And if a source fails after its retries, the Retrieval Agent skips it for that query and tries it again on the next.</a:t>
+            </a:r>
           </a:p>
         </p:txBody>
       </p:sp>
@@ -956,10 +982,20 @@
           <a:lstStyle/>
           <a:p>
             <a:r>
-              <a:rPr lang="en-US" dirty="0"/>
-              <a:t>This is the first review point in a live run, on the question 'What approaches reduce hallucination in LLM-based autonomous agents'. The Planning Agent has returned an interpretation and four sub-questions, each with a query, and the program is waiting for me. The researcher sees exactly what will be searched before it happens. Revising costs nothing here because no quota has been spent; when I tested it, I asked to merge two sub-questions into one about evaluation, and the next plan came back with exactly three, merged as asked. And any constraints the user gives are re-sent with every prompt rather than left to the model's memory, so they can't quietly drop out. The plan you see here is the one the rest of the demo runs on.</a:t>
-            </a:r>
-            <a:endParaRPr lang="en-US" dirty="0"/>
+              <a:t>This is the first review point, on the question 'What approaches reduce hallucination in LLM-based autonomous agents'. The screenshot is from the fifteenth of September, on the full Flash model: an interpretation and four sub-questions, each with a query. Nothing has been searched at this point, so the plan can be revised as often as needed; each revision is one more model request.</a:t>
+            </a:r>
+          </a:p>
+          <a:p/>
+          <a:p>
+            <a:r>
+              <a:t>When I moved to the Lite model, the same question produced a different plan, the one in the first box, and the run of the thirtieth on the next two slides used it. Two models, two plans for one question: that is why a person approves the plan.</a:t>
+            </a:r>
+          </a:p>
+          <a:p/>
+          <a:p>
+            <a:r>
+              <a:t>It was on that Lite plan that I tested a revision. I asked to merge sub-questions three and four into one about evaluation, and the next plan came back with exactly three, one of them on evaluation. Reading the code again on the first of October, I found that the revision prompt had never contained the plan it was revising. The model had followed my words, not the numbers: the old third sub-question, on self-correction and memory, was simply gone. The plan now travels with the feedback. On the second of October I ran the same request again: this time the first two sub-questions came back word for word, and the third and fourth were combined into one, on self-correction and evaluation. Only the memory part was lost.</a:t>
+            </a:r>
           </a:p>
         </p:txBody>
       </p:sp>
@@ -1044,12 +1080,26 @@
           <a:lstStyle/>
           <a:p>
             <a:r>
-              <a:rPr lang="en-US" dirty="0"/>
-              <a:t>This is the log from the run on the thirtieth of September, after the second source was added. Each sub-question went to both sources. OpenAlex answered all five searches, a hundred records. Semantic Scholar, which I use without a key, refused three of the five with 'too many requests'. Each time, the retry policy tried four times over about forty-five seconds, gave up, and the Retrieval Agent logged the failure and carried on with OpenAlex. It answered the other two searches, forty records. That is the failover the feedback asked for, working for real rather than staged: the run didn't die, and the brief says which sub-questions were covered by one source only.
-A hundred and forty records came back; a hundred and seventeen were unique. Seventy-eight DOIs were found in Crossref; the rest are mostly arXiv preprints, which register with DataCite instead, so they're flagged but kept. Then one scoring line per paper: score, keep or drop, DOI, reason. Seventy-seven papers ended up above the cut-off.
-The lower panel is the retry doing its job. Sub-question 4, on evaluation, produced eight new records with only two relevant; the query had pulled in general surveys and a conference preface. The orchestrator asked for one reformulation, passing the rejection reasons along. This time both sources answered the new query: thirty-three new records, twenty of them relevant, so that sub-question finished with twenty-two papers instead of two. On the single-source system, the same retry had lifted it from one paper to three. That difference is what a second source is for.</a:t>
-            </a:r>
-            <a:endParaRPr lang="en-US" dirty="0"/>
+              <a:t>This is the run of the thirtieth of September, after the second source was added. Each sub-question went to both sources. OpenAlex answered all five searches, a hundred records. Semantic Scholar, used without a key, refused three of the five with 'too many requests'. Each time, after four retries, the Retrieval Agent logged the failure and carried on with OpenAlex. That is the failover the feedback asked for: the run didn't die, and the brief says how many searches each source answered.</a:t>
+            </a:r>
+          </a:p>
+          <a:p/>
+          <a:p>
+            <a:r>
+              <a:t>A hundred and forty records came back; a hundred and seventeen were unique. Seventy-eight DOIs were found in Crossref; the rest are mostly arXiv preprints, which register with DataCite instead, so they're flagged but kept. Every paper was then scored with a reason, and seventy-seven reached the cut-off.</a:t>
+            </a:r>
+          </a:p>
+          <a:p/>
+          <a:p>
+            <a:r>
+              <a:t>The code at the top is the part of the orchestrator that decides on a retry. There are two checks: the Retrieval Agent's own count of usable records, and, after scoring, a count of the relevant ones. The comment says why the second exists: a search can return plenty of abstracts of which only one answers the question. Both checks share a single retry.</a:t>
+            </a:r>
+          </a:p>
+          <a:p/>
+          <a:p>
+            <a:r>
+              <a:t>The lower panel is that retry doing its job. Sub-question 4, on evaluation, produced eight new records with only two relevant. The orchestrator asked for one reformulation. This time both sources answered the new query: thirty-three new records, twenty of them relevant, so that sub-question finished with twenty-two papers instead of two. A week earlier, with one source and the same plan and model, the same retry had taken it from two papers to six.</a:t>
+            </a:r>
           </a:p>
         </p:txBody>
       </p:sp>
@@ -1134,11 +1184,14 @@
           <a:lstStyle/>
           <a:p>
             <a:r>
-              <a:rPr lang="en-US" dirty="0"/>
-              <a:t>Review 2 lists every paper that passed, grouped and numbered, with score and reason, and notes where a query was reformulated. From here I can approve, drop papers by number, or reject the scope. In the functional tests I did all three: dropping two papers removed and re-numbered them and the brief recorded the removal; rejecting the scope sent the run back to planning with my feedback, and a second reject was refused because that budget was used.
-After approval the seventy-seven papers were summarised in ten calls and the themes and gaps took one more. On the right are pieces of the brief. The note for paper seventy-six describes a practitioner audit built on forty-five recorded incidents; I checked, and that figure is in the paper's abstract - and that paper came from Semantic Scholar only, so the single-source system would never have seen it. Each theme cites paper numbers, and the schema rejects a theme that cites a number not in the list. The limitations are computed by the orchestrator, not written by the model, and since this stage they include what each source contributed and where failover was used. The reference list comes straight from the records' metadata. The model never writes a citation.</a:t>
-            </a:r>
-            <a:endParaRPr lang="en-US" dirty="0"/>
+              <a:t>Review 2 lists every paper that passed, grouped and numbered, with score and reason. In the functional tests I tried all three choices - approve, drop, reject; a second reject was refused because that budget was used.</a:t>
+            </a:r>
+          </a:p>
+          <a:p/>
+          <a:p>
+            <a:r>
+              <a:t>After approval the seventy-seven papers were summarised in ten batches, and the themes and gaps took one more call. The note for paper seventy-six describes a practitioner audit built on forty-five recorded incidents; I checked, and that figure is in the paper's abstract - and that paper came from Semantic Scholar only, so the single-source system would never have seen it. Each theme cites paper numbers, and the schema rejects a theme that cites a number not in the list. The limitations are computed by the orchestrator, not written by the model, and they include what each source contributed. The reference list comes straight from the records' metadata. The model cites papers by number; it never writes a reference.</a:t>
+            </a:r>
           </a:p>
         </p:txBody>
       </p:sp>
@@ -1223,11 +1276,14 @@
           <a:lstStyle/>
           <a:p>
             <a:r>
-              <a:rPr lang="en-US" dirty="0"/>
-              <a:t>Testing happened at three levels. Sixty-eight unit tests run without any network, against recorded replies from the four services; they cover the data models, abstract reconstruction, de-duplication and DOI checks, schema validation and repair, both review loops, the threshold and retry caps, the cut-off, batching, the rule that a theme can't cite a paper that isn't there, the retry policies, the brief layout, and, since the last stage, the second source, the merging of results and the failover between sources. Eleven functional tests were run live, each with the command, the expected result and what actually happened: no API key, drop, revise, reject scope and be refused the second time, a full run, the threshold retry, transient errors, the daily quota stop, malformed JSON repair, the two-source run with real failover, and a forced non-transient failure that must not be retried. All eleven pass. And a remediation log with eleven entries records every problem I hit, its cause, the change, and how I checked it. That log is the next slide.
-The feedback also asked what the tests measure. Honestly: de-duplication and citation accuracy are measured - structurally, in that a fabricated citation cannot reach the brief - and grounding was spot-checked. Recall and precision are not measured, because there is no labelled dataset for the question, and I'd rather say that than invent a number. The README sets out what a real evaluation would need.</a:t>
-            </a:r>
-            <a:endParaRPr lang="en-US" dirty="0"/>
+              <a:t>Testing happened at three levels. A hundred and thirteen unit tests run without any network; they cover every agent and every check, and the slide lists them. Sixteen functional tests were run live, each with its steps, the expected result and what actually happened. Eleven were run during development, from a missing API key to the two-source run with real failover; five more on the second of October, on the submitted code. All sixteen pass, two with a qualification: the early plan revision, as I said, and the constraint test, which showed that a constraint steers the search but does not filter the results. And a remediation log with twenty-one entries records every problem I hit, its cause, the change, and how it was checked.</a:t>
+            </a:r>
+          </a:p>
+          <a:p/>
+          <a:p>
+            <a:r>
+              <a:t>The feedback also asked for clear targets and the dataset to test them on. The README now states them: precision of at least zero point eight at the cut-off and recall of at least zero point six, measured on a gold set - the hundred and twenty or so records of this question judged by two people, and the studies included in a published review. That set has not been built, so I claim no result for either. Citation accuracy holds by construction, because a fabricated citation cannot reach the brief. De-duplication misses its target: four papers appear twice under different DOIs. And the proposal planned a varied set of test questions. For nearly all of the work I used one; on the last day I ran three others - telemedicine, food waste in retail, and a deliberately vague one. Each produced a complete brief, but no person has judged those briefs. For the telemedicine run I did get a second opinion: the full Gemini Flash model judged all sixty-five papers from the same titles and abstracts, without seeing the agent's scores. Of the thirty-five kept papers it answered clearly on, it would keep twenty-seven; across all its clear answers, kappa was zero point six five. Every kept paper it would not keep sat exactly at the cut-off. That is agreement between two models, not precision.</a:t>
+            </a:r>
           </a:p>
         </p:txBody>
       </p:sp>
@@ -1312,11 +1368,14 @@
           <a:lstStyle/>
           <a:p>
             <a:r>
-              <a:rPr lang="en-US" dirty="0"/>
-              <a:t>Nearly every problem came from outside the code, and each one left a mark on it. The very first Gemini call returned a 404: the model I'd set up with had been retired between design and build. The name was already in configuration, so the fix was one line. A few days later a run died on a 503, and the next on a read timeout; that produced the transient-error retry, with 'busy' errors retried and 'wrong' errors failing at once so a bad key can't hide behind retries. Then came 429s. Once I logged the quota name it turned out the free tier for that model allows twenty requests a day, retries included, so the client now stops immediately on a daily quota, and I switched to a Flash-Lite model with five hundred a day - again one line. On the twenty-third OpenAlex started refusing requests: their access model had changed and keyless use is now capped, so a free key went into configuration and the retry logic moved into one shared policy for all the scholarly APIs. And a typo: I typed 'approv' at Review 1 and it was taken as feedback and re-planned. Now a short unrecognised input is simply asked again.
-None of this needed a rewrite. One configuration module and one small client per service meant each fix was a line or two, and it is also what made adding a second source a single new client module. The repository's commit history runs from the ninth to the thirtieth of September, roughly one commit per stage, so every one of these changes can be found.</a:t>
-            </a:r>
-            <a:endParaRPr lang="en-US" dirty="0"/>
+              <a:t>Most of the problems on this slide came from outside the code. The very first Gemini call returned a 404: the model I had configured had been retired by the provider. The name was in configuration, so the fix was a change of setting. Then runs died on a 503 and on a read timeout; that produced the retry for transient errors, while a wrong request still fails at once. Then came 429s: the free tier for that model allows twenty requests a day, retries included. The client now stops at once on a daily quota, and I switched to a Flash-Lite model with five hundred a day - again only a setting. On the twenty-third OpenAlex started refusing requests - keyless use is now capped - so a free key went into configuration and the retry logic into one shared policy for the scholarly APIs.</a:t>
+            </a:r>
+          </a:p>
+          <a:p/>
+          <a:p>
+            <a:r>
+              <a:t>None of this needed a rewrite: the settings sit in one module and each service behind one small client. The commit history starts on the ninth of September, roughly one commit per stage. The last ten entries in the log are of a different kind. On the first of October I read the code and the documents against each other and found a rejected model reply being kept in the cache, a title check that could not fail for titles in other scripts, the revision prompt I mentioned, and an error message that could have written an API key into the log. Those are fixed and unit-tested. The run of the thirtieth, replayed offline from the saved replies, produced the same papers, scores, notes and themes, and the five live tests of the second of October ran on the corrected code.</a:t>
+            </a:r>
           </a:p>
         </p:txBody>
       </p:sp>
@@ -1837,7 +1896,7 @@
                 <a:ea typeface="Calibri" pitchFamily="34" charset="-122"/>
                 <a:cs typeface="Calibri" pitchFamily="34" charset="-120"/>
               </a:rPr>
-              <a:t>Sergei Misjura  ·  Intelligent Agents (PCOM7E), University of Essex Online  ·  October 2026</a:t>
+              <a:t>Intelligent Agents (PCOM7E), University of Essex Online  ·  October 2026</a:t>
             </a:r>
             <a:endParaRPr lang="en-US" sz="1300" dirty="0"/>
           </a:p>
@@ -2029,7 +2088,7 @@
                 <a:ea typeface="Calibri" pitchFamily="34" charset="-122"/>
                 <a:cs typeface="Calibri" pitchFamily="34" charset="-120"/>
               </a:rPr>
-              <a:t>Three agents, orchestrator, the four data classes and Decision enum from Diagram 1</a:t>
+              <a:t>Three agents, orchestrator, the data classes and Decision enum of Diagram 1 (field changes listed in the README)</a:t>
             </a:r>
             <a:endParaRPr lang="en-US" sz="1000" dirty="0"/>
           </a:p>
@@ -2113,7 +2172,7 @@
                 <a:ea typeface="Calibri" pitchFamily="34" charset="-122"/>
                 <a:cs typeface="Calibri" pitchFamily="34" charset="-120"/>
               </a:rPr>
-              <a:t>Three small departures: a second retry trigger after scoring; a shared retry policy; previous_query kept on SubQuestion</a:t>
+              <a:t>Departures: OpenAlex first, not Semantic Scholar; checks run per sub-question, with a second retry trigger after scoring; Crossref compares titles only; a second scope rejection is refused, not a stop; one test question until the last day, not a varied set used throughout</a:t>
             </a:r>
             <a:endParaRPr lang="en-US" sz="1000" dirty="0"/>
           </a:p>
@@ -2152,7 +2211,7 @@
                 <a:ea typeface="Calibri" pitchFamily="34" charset="-122"/>
                 <a:cs typeface="Calibri" pitchFamily="34" charset="-120"/>
               </a:rPr>
-              <a:t>Changed after the feedback (29 Sept)</a:t>
+              <a:t>Changed after the feedback</a:t>
             </a:r>
             <a:endParaRPr lang="en-US" sz="1300" dirty="0"/>
           </a:p>
@@ -2195,7 +2254,7 @@
                 <a:ea typeface="Calibri" pitchFamily="34" charset="-122"/>
                 <a:cs typeface="Calibri" pitchFamily="34" charset="-120"/>
               </a:rPr>
-              <a:t>Model choice justified from the provider's figures: 1M-token context vs 12k-token prompts, structured output, 500 requests/day free, $0.30 per M input tokens, benchmarks - none of which measures abstract screening</a:t>
+              <a:t>Model choice justified from the provider's figures (Google, 2026b, 2026c, 2026d; Google DeepMind, 2026a): 1M-token context vs prompts of at most ~12k tokens, structured output (function calling is not used), 500 requests/day free, $0.30 per M input tokens, benchmarks - none of which measures abstract screening</a:t>
             </a:r>
             <a:endParaRPr lang="en-US" sz="1000" dirty="0"/>
           </a:p>
@@ -2216,7 +2275,7 @@
                 <a:ea typeface="Calibri" pitchFamily="34" charset="-122"/>
                 <a:cs typeface="Calibri" pitchFamily="34" charset="-120"/>
               </a:rPr>
-              <a:t>Test targets stated honestly: de-duplication and citation accuracy measured; recall and precision not - no gold set - with what one would need</a:t>
+              <a:t>Targets and datasets stated: precision ≥ 0.8 on a gold set, recall ≥ 0.6 against a published review's list - neither built yet, so not measured; de-duplication missed (4 pairs in 77); one run checked by a second model: κ 0.65, agreement, not precision</a:t>
             </a:r>
             <a:endParaRPr lang="en-US" sz="1000" dirty="0"/>
           </a:p>
@@ -2237,7 +2296,7 @@
                 <a:ea typeface="Calibri" pitchFamily="34" charset="-122"/>
                 <a:cs typeface="Calibri" pitchFamily="34" charset="-120"/>
               </a:rPr>
-              <a:t>Built: two sources for every search, automatic failover; 78 -&gt; 117 papers on the same question</a:t>
+              <a:t>Built: two sources for every search, automatic failover; 77 → 117 unique papers on the same plan and model</a:t>
             </a:r>
             <a:endParaRPr lang="en-US" sz="1000" dirty="0"/>
           </a:p>
@@ -2340,7 +2399,7 @@
                 <a:ea typeface="Calibri" pitchFamily="34" charset="-122"/>
                 <a:cs typeface="Calibri" pitchFamily="34" charset="-120"/>
               </a:rPr>
-              <a:t>Lite keeps more papers than Flash (42 vs 26) - calibrate the cut-off per model</a:t>
+              <a:t>Lite kept 42 of 77 papers, Flash 26 of 78 (each on its own plan) - calibrate the cut-off per model</a:t>
             </a:r>
             <a:endParaRPr lang="en-US" sz="1000" dirty="0"/>
           </a:p>
@@ -2361,7 +2420,7 @@
                 <a:ea typeface="Calibri" pitchFamily="34" charset="-122"/>
                 <a:cs typeface="Calibri" pitchFamily="34" charset="-120"/>
               </a:rPr>
-              <a:t>A paper under two DOIs is not merged; Semantic Scholar's keyless pool refuses more than it answers</a:t>
+              <a:t>A paper under two DOIs is not merged; Semantic Scholar's keyless pool refused 3 of 5 searches on 30 Sept and all 16 live ones on 2 Oct</a:t>
             </a:r>
             <a:endParaRPr lang="en-US" sz="1000" dirty="0"/>
           </a:p>
@@ -2382,7 +2441,49 @@
                 <a:ea typeface="Calibri" pitchFamily="34" charset="-122"/>
                 <a:cs typeface="Calibri" pitchFamily="34" charset="-120"/>
               </a:rPr>
-              <a:t>Next: DataCite lookup, a labelled set for recall and precision, full text where open</a:t>
+              <a:t>One research question during development; three more run once each on 2 Oct, their briefs not judged</a:t>
+            </a:r>
+            <a:endParaRPr lang="en-US" sz="1000" dirty="0"/>
+          </a:p>
+          <a:p>
+            <a:pPr marL="342900" indent="-342900">
+              <a:spcAft>
+                <a:spcPts val="600"/>
+              </a:spcAft>
+              <a:buSzPct val="100000"/>
+              <a:buChar char="•"/>
+            </a:pPr>
+            <a:r>
+              <a:rPr lang="en-US" sz="1000" dirty="0">
+                <a:solidFill>
+                  <a:srgbClr val="FFFFFF"/>
+                </a:solidFill>
+                <a:latin typeface="Calibri" pitchFamily="34" charset="0"/>
+                <a:ea typeface="Calibri" pitchFamily="34" charset="-122"/>
+                <a:cs typeface="Calibri" pitchFamily="34" charset="-120"/>
+              </a:rPr>
+              <a:t>Free-tier prompts may be used by the provider: a confidential question needs a paid key</a:t>
+            </a:r>
+            <a:endParaRPr lang="en-US" sz="1000" dirty="0"/>
+          </a:p>
+          <a:p>
+            <a:pPr marL="342900" indent="-342900">
+              <a:spcAft>
+                <a:spcPts val="600"/>
+              </a:spcAft>
+              <a:buSzPct val="100000"/>
+              <a:buChar char="•"/>
+            </a:pPr>
+            <a:r>
+              <a:rPr lang="en-US" sz="1000" dirty="0">
+                <a:solidFill>
+                  <a:srgbClr val="FFFFFF"/>
+                </a:solidFill>
+                <a:latin typeface="Calibri" pitchFamily="34" charset="0"/>
+                <a:ea typeface="Calibri" pitchFamily="34" charset="-122"/>
+                <a:cs typeface="Calibri" pitchFamily="34" charset="-120"/>
+              </a:rPr>
+              <a:t>Next: DataCite lookup, the gold set, full text where open</a:t>
             </a:r>
             <a:endParaRPr lang="en-US" sz="1000" dirty="0"/>
           </a:p>
@@ -2421,7 +2522,7 @@
                 <a:ea typeface="Courier New" pitchFamily="34" charset="-122"/>
                 <a:cs typeface="Courier New" pitchFamily="34" charset="-120"/>
               </a:rPr>
-              <a:t>github.com/sergio88mi/research-agent  ·  README covers setup, keys and how to run</a:t>
+              <a:t>github.com/sergio88mi/research-agent  ·  README: setup, keys, how to run, references</a:t>
             </a:r>
             <a:endParaRPr lang="en-US" sz="1100" dirty="0"/>
           </a:p>
@@ -2556,6 +2657,10 @@
             <a:prstDash val="solid"/>
           </a:ln>
         </p:spPr>
+        <p:txBody>
+          <a:bodyPr/>
+          <a:p/>
+        </p:txBody>
       </p:sp>
       <p:sp>
         <p:nvSpPr>
@@ -2620,6 +2725,10 @@
             <a:prstDash val="solid"/>
           </a:ln>
         </p:spPr>
+        <p:txBody>
+          <a:bodyPr/>
+          <a:p/>
+        </p:txBody>
       </p:sp>
       <p:sp>
         <p:nvSpPr>
@@ -2647,6 +2756,10 @@
             <a:prstDash val="solid"/>
           </a:ln>
         </p:spPr>
+        <p:txBody>
+          <a:bodyPr/>
+          <a:p/>
+        </p:txBody>
       </p:sp>
       <p:sp>
         <p:nvSpPr>
@@ -2728,6 +2841,10 @@
             <a:prstDash val="solid"/>
           </a:ln>
         </p:spPr>
+        <p:txBody>
+          <a:bodyPr/>
+          <a:p/>
+        </p:txBody>
       </p:sp>
       <p:sp>
         <p:nvSpPr>
@@ -2755,6 +2872,10 @@
             <a:prstDash val="solid"/>
           </a:ln>
         </p:spPr>
+        <p:txBody>
+          <a:bodyPr/>
+          <a:p/>
+        </p:txBody>
       </p:sp>
       <p:sp>
         <p:nvSpPr>
@@ -2845,7 +2966,7 @@
                 <a:ea typeface="Calibri" pitchFamily="34" charset="-122"/>
                 <a:cs typeface="Calibri" pitchFamily="34" charset="-120"/>
               </a:rPr>
-              <a:t>From the Group D design proposal (Assessment 1)</a:t>
+              <a:t>From the Group D design proposal (Group D, 2026)  -  full references in the README and the transcript</a:t>
             </a:r>
             <a:endParaRPr lang="en-US" sz="1100" dirty="0"/>
           </a:p>
@@ -2877,6 +2998,10 @@
             <a:prstDash val="solid"/>
           </a:ln>
         </p:spPr>
+        <p:txBody>
+          <a:bodyPr/>
+          <a:p/>
+        </p:txBody>
       </p:sp>
       <p:sp>
         <p:nvSpPr>
@@ -2954,7 +3079,7 @@
                 <a:ea typeface="Calibri" pitchFamily="34" charset="-122"/>
                 <a:cs typeface="Calibri" pitchFamily="34" charset="-120"/>
               </a:rPr>
-              <a:t>Three specialised agents and a deterministic coordinator</a:t>
+              <a:t>Three specialised agents and a deterministic coordinator (Hong et al., 2024; Kim et al., 2026)</a:t>
             </a:r>
             <a:endParaRPr lang="en-US" sz="1100" dirty="0"/>
           </a:p>
@@ -2975,7 +3100,7 @@
                 <a:ea typeface="Calibri" pitchFamily="34" charset="-122"/>
                 <a:cs typeface="Calibri" pitchFamily="34" charset="-120"/>
               </a:rPr>
-              <a:t>Two human review points: the plan, then the evidence</a:t>
+              <a:t>Two human review points: the plan, then the evidence (Zhu et al., 2026)</a:t>
             </a:r>
             <a:endParaRPr lang="en-US" sz="1100" dirty="0"/>
           </a:p>
@@ -2996,7 +3121,7 @@
                 <a:ea typeface="Calibri" pitchFamily="34" charset="-122"/>
                 <a:cs typeface="Calibri" pitchFamily="34" charset="-120"/>
               </a:rPr>
-              <a:t>Every DOI checked against Crossref before it can be cited</a:t>
+              <a:t>Every DOI checked against Crossref before it can be cited (Walters and Wilder, 2023)</a:t>
             </a:r>
             <a:endParaRPr lang="en-US" sz="1100" dirty="0"/>
           </a:p>
@@ -3070,6 +3195,10 @@
             <a:prstDash val="solid"/>
           </a:ln>
         </p:spPr>
+        <p:txBody>
+          <a:bodyPr/>
+          <a:p/>
+        </p:txBody>
       </p:sp>
       <p:sp>
         <p:nvSpPr>
@@ -3143,36 +3272,14 @@
                 <a:ea typeface="Calibri" pitchFamily="34" charset="-122"/>
                 <a:cs typeface="Calibri" pitchFamily="34" charset="-120"/>
               </a:rPr>
-              <a:t>A language model asked for literature will produce plausible papers that do not exist. </a:t>
-            </a:r>
-            <a:pPr indent="0" marL="0">
-              <a:buNone/>
-            </a:pPr>
-            <a:r>
-              <a:rPr lang="en-US" sz="1150" b="1" dirty="0">
-                <a:solidFill>
-                  <a:srgbClr val="1F3A3D"/>
-                </a:solidFill>
-                <a:latin typeface="Calibri" pitchFamily="34" charset="0"/>
-                <a:ea typeface="Calibri" pitchFamily="34" charset="-122"/>
-                <a:cs typeface="Calibri" pitchFamily="34" charset="-120"/>
-              </a:rPr>
-              <a:t>So the model never writes a reference: </a:t>
-            </a:r>
-            <a:pPr indent="0" marL="0">
-              <a:buNone/>
-            </a:pPr>
-            <a:r>
-              <a:rPr lang="en-US" sz="1150" dirty="0">
-                <a:solidFill>
-                  <a:srgbClr val="1F3A3D"/>
-                </a:solidFill>
-                <a:latin typeface="Calibri" pitchFamily="34" charset="0"/>
-                <a:ea typeface="Calibri" pitchFamily="34" charset="-122"/>
-                <a:cs typeface="Calibri" pitchFamily="34" charset="-120"/>
-              </a:rPr>
-              <a:t>it only decomposes, scores and summarises. Everything with an exact answer - de-duplication, DOI checks, the reference list - is ordinary code.</a:t>
-            </a:r>
+              <a:t>A language model asked for literature will produce plausible papers that do not exist. So the model never writes a reference: it only plans queries, scores and summarises. Everything with an exact answer - de-duplication, DOI checks, the reference list - is ordinary code.</a:t>
+            </a:r>
+            <a:pPr indent="0" marL="0">
+              <a:buNone/>
+            </a:pPr>
+            <a:pPr indent="0" marL="0">
+              <a:buNone/>
+            </a:pPr>
             <a:endParaRPr lang="en-US" sz="1150" dirty="0"/>
           </a:p>
         </p:txBody>
@@ -3210,7 +3317,7 @@
                 <a:ea typeface="Calibri" pitchFamily="34" charset="-122"/>
                 <a:cs typeface="Calibri" pitchFamily="34" charset="-120"/>
               </a:rPr>
-              <a:t>My task: build the proposed system on my own, test it, show it running - and, once the design was marked (29 Sept), act on its three points of feedback.</a:t>
+              <a:t>My task: build the proposed system on my own, test it, show it running - and, once the feedback on the design arrived (read 29 Sept), act on its three points.</a:t>
             </a:r>
             <a:endParaRPr lang="en-US" sz="1150" dirty="0"/>
           </a:p>
@@ -3345,6 +3452,10 @@
             <a:prstDash val="solid"/>
           </a:ln>
         </p:spPr>
+        <p:txBody>
+          <a:bodyPr/>
+          <a:p/>
+        </p:txBody>
       </p:sp>
       <p:sp>
         <p:nvSpPr>
@@ -3426,6 +3537,10 @@
             <a:prstDash val="solid"/>
           </a:ln>
         </p:spPr>
+        <p:txBody>
+          <a:bodyPr/>
+          <a:p/>
+        </p:txBody>
       </p:sp>
       <p:sp>
         <p:nvSpPr>
@@ -3453,6 +3568,10 @@
             <a:prstDash val="solid"/>
           </a:ln>
         </p:spPr>
+        <p:txBody>
+          <a:bodyPr/>
+          <a:p/>
+        </p:txBody>
       </p:sp>
       <p:sp>
         <p:nvSpPr>
@@ -3536,6 +3655,10 @@
             <a:prstDash val="solid"/>
           </a:ln>
         </p:spPr>
+        <p:txBody>
+          <a:bodyPr/>
+          <a:p/>
+        </p:txBody>
       </p:sp>
       <p:sp>
         <p:nvSpPr>
@@ -3619,6 +3742,10 @@
             <a:prstDash val="solid"/>
           </a:ln>
         </p:spPr>
+        <p:txBody>
+          <a:bodyPr/>
+          <a:p/>
+        </p:txBody>
       </p:sp>
       <p:sp>
         <p:nvSpPr>
@@ -3702,6 +3829,10 @@
             <a:prstDash val="solid"/>
           </a:ln>
         </p:spPr>
+        <p:txBody>
+          <a:bodyPr/>
+          <a:p/>
+        </p:txBody>
       </p:sp>
       <p:sp>
         <p:nvSpPr>
@@ -3781,6 +3912,10 @@
             <a:prstDash val="solid"/>
           </a:ln>
         </p:spPr>
+        <p:txBody>
+          <a:bodyPr/>
+          <a:p/>
+        </p:txBody>
       </p:sp>
       <p:sp>
         <p:nvSpPr>
@@ -3804,6 +3939,10 @@
             <a:prstDash val="solid"/>
           </a:ln>
         </p:spPr>
+        <p:txBody>
+          <a:bodyPr/>
+          <a:p/>
+        </p:txBody>
       </p:sp>
       <p:sp>
         <p:nvSpPr>
@@ -3827,6 +3966,10 @@
             <a:prstDash val="solid"/>
           </a:ln>
         </p:spPr>
+        <p:txBody>
+          <a:bodyPr/>
+          <a:p/>
+        </p:txBody>
       </p:sp>
       <p:sp>
         <p:nvSpPr>
@@ -3850,6 +3993,10 @@
             <a:prstDash val="solid"/>
           </a:ln>
         </p:spPr>
+        <p:txBody>
+          <a:bodyPr/>
+          <a:p/>
+        </p:txBody>
       </p:sp>
       <p:sp>
         <p:nvSpPr>
@@ -3873,6 +4020,10 @@
             <a:prstDash val="solid"/>
           </a:ln>
         </p:spPr>
+        <p:txBody>
+          <a:bodyPr/>
+          <a:p/>
+        </p:txBody>
       </p:sp>
       <p:sp>
         <p:nvSpPr>
@@ -4014,6 +4165,27 @@
                 <a:cs typeface="Calibri" pitchFamily="34" charset="-120"/>
               </a:rPr>
               <a:t>Limits, model name and the list of sources live in one configuration file</a:t>
+            </a:r>
+            <a:endParaRPr lang="en-US" sz="1100" dirty="0"/>
+          </a:p>
+          <a:p>
+            <a:pPr marL="342900" indent="-342900">
+              <a:spcAft>
+                <a:spcPts val="500"/>
+              </a:spcAft>
+              <a:buSzPct val="100000"/>
+              <a:buChar char="•"/>
+            </a:pPr>
+            <a:r>
+              <a:rPr lang="en-US" sz="1100" dirty="0">
+                <a:solidFill>
+                  <a:srgbClr val="1F3A3D"/>
+                </a:solidFill>
+                <a:latin typeface="Calibri" pitchFamily="34" charset="0"/>
+                <a:ea typeface="Calibri" pitchFamily="34" charset="-122"/>
+                <a:cs typeface="Calibri" pitchFamily="34" charset="-120"/>
+              </a:rPr>
+              <a:t>Agents by role, each with one goal (Wooldridge and Jennings, 1995; Wooldridge, Jennings and Kinny, 2000); one coordinator, because errors spread without central verification (Kim et al., 2026)</a:t>
             </a:r>
             <a:endParaRPr lang="en-US" sz="1100" dirty="0"/>
           </a:p>
@@ -4045,6 +4217,10 @@
             <a:prstDash val="solid"/>
           </a:ln>
         </p:spPr>
+        <p:txBody>
+          <a:bodyPr/>
+          <a:p/>
+        </p:txBody>
       </p:sp>
       <p:sp>
         <p:nvSpPr>
@@ -4487,6 +4663,10 @@
             <a:prstDash val="solid"/>
           </a:ln>
         </p:spPr>
+        <p:txBody>
+          <a:bodyPr/>
+          <a:p/>
+        </p:txBody>
       </p:sp>
       <p:sp>
         <p:nvSpPr>
@@ -4592,6 +4772,10 @@
             <a:prstDash val="solid"/>
           </a:ln>
         </p:spPr>
+        <p:txBody>
+          <a:bodyPr/>
+          <a:p/>
+        </p:txBody>
       </p:sp>
       <p:sp>
         <p:nvSpPr>
@@ -4697,6 +4881,10 @@
             <a:prstDash val="solid"/>
           </a:ln>
         </p:spPr>
+        <p:txBody>
+          <a:bodyPr/>
+          <a:p/>
+        </p:txBody>
       </p:sp>
       <p:sp>
         <p:nvSpPr>
@@ -4802,6 +4990,10 @@
             <a:prstDash val="solid"/>
           </a:ln>
         </p:spPr>
+        <p:txBody>
+          <a:bodyPr/>
+          <a:p/>
+        </p:txBody>
       </p:sp>
       <p:sp>
         <p:nvSpPr>
@@ -4907,6 +5099,10 @@
             <a:prstDash val="solid"/>
           </a:ln>
         </p:spPr>
+        <p:txBody>
+          <a:bodyPr/>
+          <a:p/>
+        </p:txBody>
       </p:sp>
       <p:sp>
         <p:nvSpPr>
@@ -5012,6 +5208,10 @@
             <a:prstDash val="solid"/>
           </a:ln>
         </p:spPr>
+        <p:txBody>
+          <a:bodyPr/>
+          <a:p/>
+        </p:txBody>
       </p:sp>
       <p:sp>
         <p:nvSpPr>
@@ -5117,6 +5317,10 @@
             <a:prstDash val="solid"/>
           </a:ln>
         </p:spPr>
+        <p:txBody>
+          <a:bodyPr/>
+          <a:p/>
+        </p:txBody>
       </p:sp>
       <p:sp>
         <p:nvSpPr>
@@ -5222,6 +5426,10 @@
             <a:prstDash val="solid"/>
           </a:ln>
         </p:spPr>
+        <p:txBody>
+          <a:bodyPr/>
+          <a:p/>
+        </p:txBody>
       </p:sp>
       <p:sp>
         <p:nvSpPr>
@@ -5299,7 +5507,7 @@
                 <a:ea typeface="Calibri" pitchFamily="34" charset="-122"/>
                 <a:cs typeface="Calibri" pitchFamily="34" charset="-120"/>
               </a:rPr>
-              <a:t>Fewer than 5 usable records, or fewer than 5 relevant after scoring: the Planning Agent rewrites the query once, with the rejection reasons - never twice</a:t>
+              <a:t>Fewer than 5 usable records, or fewer than 5 relevant after scoring: the Planning Agent rewrites the query once, told why the search fell short - never twice</a:t>
             </a:r>
             <a:endParaRPr lang="en-US" sz="1000" dirty="0"/>
           </a:p>
@@ -5352,6 +5560,10 @@
             <a:prstDash val="solid"/>
           </a:ln>
         </p:spPr>
+        <p:txBody>
+          <a:bodyPr/>
+          <a:p/>
+        </p:txBody>
       </p:sp>
       <p:sp>
         <p:nvSpPr>
@@ -5513,6 +5725,40 @@
               <a:t>4 / 10</a:t>
             </a:r>
             <a:endParaRPr lang="en-US" sz="900" dirty="0"/>
+          </a:p>
+        </p:txBody>
+      </p:sp>
+      <p:sp>
+        <p:nvSpPr>
+          <p:cNvPr id="31" name="Run command"/>
+          <p:cNvSpPr txBox="1"/>
+          <p:nvPr/>
+        </p:nvSpPr>
+        <p:spPr>
+          <a:xfrm>
+            <a:off x="457200" y="2578608"/>
+            <a:ext cx="8229600" cy="274320"/>
+          </a:xfrm>
+          <a:prstGeom prst="rect">
+            <a:avLst/>
+          </a:prstGeom>
+          <a:noFill/>
+        </p:spPr>
+        <p:txBody>
+          <a:bodyPr wrap="none">
+            <a:spAutoFit/>
+          </a:bodyPr>
+          <a:lstStyle/>
+          <a:p>
+            <a:r>
+              <a:rPr sz="860">
+                <a:solidFill>
+                  <a:srgbClr val="1F3A3D"/>
+                </a:solidFill>
+                <a:latin typeface="Courier New"/>
+              </a:rPr>
+              <a:t>One command starts it:   python main.py "What approaches reduce hallucination in LLM-based autonomous agents?"</a:t>
+            </a:r>
           </a:p>
         </p:txBody>
       </p:sp>
@@ -5582,14 +5828,14 @@
       </p:sp>
       <p:pic>
         <p:nvPicPr>
-          <p:cNvPr id="3" name="Image 0" descr="/sessions/kind-adoring-hypatia/mnt/outputs/deck/demo1_review1.png">    </p:cNvPr>
+          <p:cNvPr id="14" name="Picture 13" descr="slide5_review1_crop.png"/>
           <p:cNvPicPr>
             <a:picLocks noChangeAspect="1"/>
           </p:cNvPicPr>
           <p:nvPr/>
         </p:nvPicPr>
         <p:blipFill>
-          <a:blip r:embed="rId1"/>
+          <a:blip r:embed="rId4"/>
           <a:stretch>
             <a:fillRect/>
           </a:stretch>
@@ -5597,7 +5843,7 @@
         <p:spPr>
           <a:xfrm>
             <a:off x="457200" y="1097280"/>
-            <a:ext cx="8229600" cy="1805940"/>
+            <a:ext cx="8229600" cy="1753582"/>
           </a:xfrm>
           <a:prstGeom prst="rect">
             <a:avLst/>
@@ -5612,8 +5858,8 @@
         </p:nvSpPr>
         <p:spPr>
           <a:xfrm>
-            <a:off x="457200" y="3017520"/>
-            <a:ext cx="2560320" cy="1600200"/>
+            <a:off x="457200" y="3172968"/>
+            <a:ext cx="2560320" cy="1444752"/>
           </a:xfrm>
           <a:prstGeom prst="roundRect">
             <a:avLst>
@@ -5639,7 +5885,7 @@
         </p:nvSpPr>
         <p:spPr>
           <a:xfrm>
-            <a:off x="594360" y="3108960"/>
+            <a:off x="594360" y="3264408"/>
             <a:ext cx="2286000" cy="457200"/>
           </a:xfrm>
           <a:prstGeom prst="rect">
@@ -5664,7 +5910,7 @@
                 <a:ea typeface="Calibri" pitchFamily="34" charset="-122"/>
                 <a:cs typeface="Calibri" pitchFamily="34" charset="-120"/>
               </a:rPr>
-              <a:t>The plan is shown before anything is searched</a:t>
+              <a:t>The Lite model's plan</a:t>
             </a:r>
             <a:endParaRPr lang="en-US" sz="1150" dirty="0"/>
           </a:p>
@@ -5678,8 +5924,8 @@
         </p:nvSpPr>
         <p:spPr>
           <a:xfrm>
-            <a:off x="594360" y="3566160"/>
-            <a:ext cx="2286000" cy="1005840"/>
+            <a:off x="594360" y="3721608"/>
+            <a:ext cx="2286000" cy="850392"/>
           </a:xfrm>
           <a:prstGeom prst="rect">
             <a:avLst/>
@@ -5703,7 +5949,7 @@
                 <a:ea typeface="Calibri" pitchFamily="34" charset="-122"/>
                 <a:cs typeface="Calibri" pitchFamily="34" charset="-120"/>
               </a:rPr>
-              <a:t>Interpretation, four sub-questions, one query each - the researcher sees exactly what will be searched.</a:t>
+              <a:t>On the Lite model (23 Sept) the four sub-questions became: prompting and reasoning · retrieval and tools · self-correction and memory · evaluation. The 30 Sept run on the next two slides reused that plan.</a:t>
             </a:r>
             <a:endParaRPr lang="en-US" sz="1000" dirty="0"/>
           </a:p>
@@ -5717,8 +5963,8 @@
         </p:nvSpPr>
         <p:spPr>
           <a:xfrm>
-            <a:off x="3291840" y="3017520"/>
-            <a:ext cx="2560320" cy="1600200"/>
+            <a:off x="3291840" y="3172968"/>
+            <a:ext cx="2560320" cy="1444752"/>
           </a:xfrm>
           <a:prstGeom prst="roundRect">
             <a:avLst>
@@ -5744,7 +5990,7 @@
         </p:nvSpPr>
         <p:spPr>
           <a:xfrm>
-            <a:off x="3429000" y="3108960"/>
+            <a:off x="3429000" y="3264408"/>
             <a:ext cx="2286000" cy="457200"/>
           </a:xfrm>
           <a:prstGeom prst="rect">
@@ -5769,7 +6015,7 @@
                 <a:ea typeface="Calibri" pitchFamily="34" charset="-122"/>
                 <a:cs typeface="Calibri" pitchFamily="34" charset="-120"/>
               </a:rPr>
-              <a:t>Revision costs nothing</a:t>
+              <a:t>Shown before anything is searched</a:t>
             </a:r>
             <a:endParaRPr lang="en-US" sz="1150" dirty="0"/>
           </a:p>
@@ -5783,8 +6029,8 @@
         </p:nvSpPr>
         <p:spPr>
           <a:xfrm>
-            <a:off x="3429000" y="3566160"/>
-            <a:ext cx="2286000" cy="1005840"/>
+            <a:off x="3429000" y="3721608"/>
+            <a:ext cx="2286000" cy="850392"/>
           </a:xfrm>
           <a:prstGeom prst="rect">
             <a:avLst/>
@@ -5808,7 +6054,7 @@
                 <a:ea typeface="Calibri" pitchFamily="34" charset="-122"/>
                 <a:cs typeface="Calibri" pitchFamily="34" charset="-120"/>
               </a:rPr>
-              <a:t>At this point no quota has been spent, so the review loop is unlimited. Feedback in a sentence produces a new plan.</a:t>
+              <a:t>The researcher sees exactly what will be searched. Nothing has been searched yet, so the review loop is unlimited; each revision costs one model request and produces a new plan.</a:t>
             </a:r>
             <a:endParaRPr lang="en-US" sz="1000" dirty="0"/>
           </a:p>
@@ -5822,8 +6068,8 @@
         </p:nvSpPr>
         <p:spPr>
           <a:xfrm>
-            <a:off x="6126480" y="3017520"/>
-            <a:ext cx="2560320" cy="1600200"/>
+            <a:off x="6126480" y="3172968"/>
+            <a:ext cx="2560320" cy="1444752"/>
           </a:xfrm>
           <a:prstGeom prst="roundRect">
             <a:avLst>
@@ -5849,7 +6095,7 @@
         </p:nvSpPr>
         <p:spPr>
           <a:xfrm>
-            <a:off x="6263640" y="3108960"/>
+            <a:off x="6263640" y="3264408"/>
             <a:ext cx="2286000" cy="457200"/>
           </a:xfrm>
           <a:prstGeom prst="rect">
@@ -5874,7 +6120,7 @@
                 <a:ea typeface="Calibri" pitchFamily="34" charset="-122"/>
                 <a:cs typeface="Calibri" pitchFamily="34" charset="-120"/>
               </a:rPr>
-              <a:t>Constraints travel with every prompt</a:t>
+              <a:t>Read again on 1 Oct</a:t>
             </a:r>
             <a:endParaRPr lang="en-US" sz="1150" dirty="0"/>
           </a:p>
@@ -5888,8 +6134,8 @@
         </p:nvSpPr>
         <p:spPr>
           <a:xfrm>
-            <a:off x="6263640" y="3566160"/>
-            <a:ext cx="2286000" cy="1005840"/>
+            <a:off x="6263640" y="3721608"/>
+            <a:ext cx="2286000" cy="850392"/>
           </a:xfrm>
           <a:prstGeom prst="rect">
             <a:avLst/>
@@ -5913,7 +6159,7 @@
                 <a:ea typeface="Calibri" pitchFamily="34" charset="-122"/>
                 <a:cs typeface="Calibri" pitchFamily="34" charset="-120"/>
               </a:rPr>
-              <a:t>User constraints are re-applied on each call, not left in the model's memory - so they cannot be forgotten.</a:t>
+              <a:t>The revision prompt lacked the plan under review, so 'merge 3 and 4' just dropped the old third sub-question. Fixed: on 2 Oct (FT-12) 1 and 2 stayed word for word; 3 and 4 were combined, minus 'memory'.</a:t>
             </a:r>
             <a:endParaRPr lang="en-US" sz="1000" dirty="0"/>
           </a:p>
@@ -5955,6 +6201,45 @@
               <a:t>5 / 10</a:t>
             </a:r>
             <a:endParaRPr lang="en-US" sz="900" dirty="0"/>
+          </a:p>
+        </p:txBody>
+      </p:sp>
+      <p:sp>
+        <p:nvSpPr>
+          <p:cNvPr id="6" name="Text 3"/>
+          <p:cNvSpPr txBox="1"/>
+          <p:nvPr/>
+        </p:nvSpPr>
+        <p:spPr>
+          <a:xfrm>
+            <a:off x="457200" y="2935224"/>
+            <a:ext cx="8229600" cy="219456"/>
+          </a:xfrm>
+          <a:prstGeom prst="rect">
+            <a:avLst/>
+          </a:prstGeom>
+          <a:noFill/>
+          <a:ln/>
+        </p:spPr>
+        <p:txBody>
+          <a:bodyPr wrap="square" lIns="0" tIns="0" rIns="0" bIns="0" rtlCol="0" anchor="t"/>
+          <a:lstStyle/>
+          <a:p>
+            <a:pPr indent="0" marL="0">
+              <a:buNone/>
+            </a:pPr>
+            <a:r>
+              <a:rPr lang="en-US" sz="950" i="1" dirty="0">
+                <a:solidFill>
+                  <a:srgbClr val="5F6F70"/>
+                </a:solidFill>
+                <a:latin typeface="Calibri" pitchFamily="34" charset="0"/>
+                <a:ea typeface="Calibri" pitchFamily="34" charset="-122"/>
+                <a:cs typeface="Calibri" pitchFamily="34" charset="-120"/>
+              </a:rPr>
+              <a:t>Screenshot: Review 1 on 15 Sept, on gemini-3.6-flash. The Lite model later planned the same question differently (first box).</a:t>
+            </a:r>
+            <a:endParaRPr lang="en-US" sz="950" dirty="0"/>
           </a:p>
         </p:txBody>
       </p:sp>
@@ -6022,40 +6307,16 @@
           </a:p>
         </p:txBody>
       </p:sp>
-      <p:pic>
-        <p:nvPicPr>
-          <p:cNvPr id="3" name="Image 0" descr="/sessions/kind-adoring-hypatia/mnt/outputs/deck/demo2_scoring.png">    </p:cNvPr>
-          <p:cNvPicPr>
-            <a:picLocks noChangeAspect="1"/>
-          </p:cNvPicPr>
-          <p:nvPr/>
-        </p:nvPicPr>
-        <p:blipFill>
-          <a:blip r:embed="rId1"/>
-          <a:stretch>
-            <a:fillRect/>
-          </a:stretch>
-        </p:blipFill>
-        <p:spPr>
-          <a:xfrm>
-            <a:off x="457200" y="1097280"/>
-            <a:ext cx="5669280" cy="1616659"/>
-          </a:xfrm>
-          <a:prstGeom prst="rect">
-            <a:avLst/>
-          </a:prstGeom>
-        </p:spPr>
-      </p:pic>
-      <p:sp>
-        <p:nvSpPr>
-          <p:cNvPr id="4" name="Shape 1"/>
+      <p:sp>
+        <p:nvSpPr>
+          <p:cNvPr id="4" name="Code panel"/>
           <p:cNvSpPr/>
           <p:nvPr/>
         </p:nvSpPr>
         <p:spPr>
           <a:xfrm>
-            <a:off x="457200" y="2788920"/>
-            <a:ext cx="5669280" cy="1481328"/>
+            <a:off x="457200" y="1051560"/>
+            <a:ext cx="5669280" cy="1682496"/>
           </a:xfrm>
           <a:prstGeom prst="roundRect">
             <a:avLst>
@@ -6072,17 +6333,21 @@
             <a:prstDash val="solid"/>
           </a:ln>
         </p:spPr>
-      </p:sp>
-      <p:sp>
-        <p:nvSpPr>
-          <p:cNvPr id="5" name="Text 2"/>
-          <p:cNvSpPr txBox="1"/>
-          <p:nvPr/>
-        </p:nvSpPr>
-        <p:spPr>
-          <a:xfrm>
-            <a:off x="566928" y="2862072"/>
-            <a:ext cx="5449824" cy="1335024"/>
+        <p:txBody>
+          <a:bodyPr/>
+          <a:p/>
+        </p:txBody>
+      </p:sp>
+      <p:sp>
+        <p:nvSpPr>
+          <p:cNvPr id="5" name="Code text"/>
+          <p:cNvSpPr txBox="1"/>
+          <p:nvPr/>
+        </p:nvSpPr>
+        <p:spPr>
+          <a:xfrm>
+            <a:off x="566928" y="1106424"/>
+            <a:ext cx="5449824" cy="1572768"/>
           </a:xfrm>
           <a:prstGeom prst="rect">
             <a:avLst/>
@@ -6098,7 +6363,7 @@
               <a:buNone/>
             </a:pPr>
             <a:r>
-              <a:rPr lang="en-US" sz="720" dirty="0">
+              <a:rPr lang="en-US" sz="760" dirty="0">
                 <a:solidFill>
                   <a:srgbClr val="8FB3AE"/>
                 </a:solidFill>
@@ -6106,7 +6371,7 @@
                 <a:ea typeface="Courier New" pitchFamily="34" charset="-122"/>
                 <a:cs typeface="Courier New" pitchFamily="34" charset="-120"/>
               </a:rPr>
-              <a:t># run.log, 30 Sept 10:11-10:15 (abridged)</a:t>
+              <a:t># agents/orchestrator.py, _gather_evidence() - excerpt, comments as in the file</a:t>
             </a:r>
             <a:endParaRPr lang="en-US" sz="720" dirty="0"/>
           </a:p>
@@ -6115,15 +6380,15 @@
               <a:buNone/>
             </a:pPr>
             <a:r>
-              <a:rPr lang="en-US" sz="720" dirty="0">
-                <a:solidFill>
-                  <a:srgbClr val="E6EFEE"/>
+              <a:rPr lang="en-US" sz="760" dirty="0">
+                <a:solidFill>
+                  <a:srgbClr val="8FB3AE"/>
                 </a:solidFill>
                 <a:latin typeface="Courier New" pitchFamily="34" charset="0"/>
                 <a:ea typeface="Courier New" pitchFamily="34" charset="-122"/>
                 <a:cs typeface="Courier New" pitchFamily="34" charset="-120"/>
               </a:rPr>
-              <a:t>retrieval | retrieving | subquestion=1 | sources=openalex,semanticscholar</a:t>
+              <a:t># Trigger 1 - the Retrieval Agent's own goal check: enough usable records?</a:t>
             </a:r>
             <a:endParaRPr lang="en-US" sz="720" dirty="0"/>
           </a:p>
@@ -6132,7 +6397,7 @@
               <a:buNone/>
             </a:pPr>
             <a:r>
-              <a:rPr lang="en-US" sz="720" dirty="0">
+              <a:rPr lang="en-US" sz="760" dirty="0">
                 <a:solidFill>
                   <a:srgbClr val="E6EFEE"/>
                 </a:solidFill>
@@ -6140,7 +6405,7 @@
                 <a:ea typeface="Courier New" pitchFamily="34" charset="-122"/>
                 <a:cs typeface="Courier New" pitchFamily="34" charset="-120"/>
               </a:rPr>
-              <a:t>retrieval | retrieved  | subquestion=1 | source=openalex | records=20 | with_abstract=20</a:t>
+              <a:t>if not self.retriever.assess_threshold(found) and self._may_reformulate(sq):</a:t>
             </a:r>
             <a:endParaRPr lang="en-US" sz="720" dirty="0"/>
           </a:p>
@@ -6149,7 +6414,7 @@
               <a:buNone/>
             </a:pPr>
             <a:r>
-              <a:rPr lang="en-US" sz="720" dirty="0">
+              <a:rPr lang="en-US" sz="760" dirty="0">
                 <a:solidFill>
                   <a:srgbClr val="E6EFEE"/>
                 </a:solidFill>
@@ -6157,7 +6422,7 @@
                 <a:ea typeface="Courier New" pitchFamily="34" charset="-122"/>
                 <a:cs typeface="Courier New" pitchFamily="34" charset="-120"/>
               </a:rPr>
-              <a:t>http      | semanticscholar | HTTP 429 (transient) - retry 4/4 in 24s</a:t>
+              <a:t>    sq = self._reformulate(plan, idx, self.retriever.reformulation_reason(found), question)</a:t>
             </a:r>
             <a:endParaRPr lang="en-US" sz="720" dirty="0"/>
           </a:p>
@@ -6166,7 +6431,7 @@
               <a:buNone/>
             </a:pPr>
             <a:r>
-              <a:rPr lang="en-US" sz="720" dirty="0">
+              <a:rPr lang="en-US" sz="760" dirty="0">
                 <a:solidFill>
                   <a:srgbClr val="E6EFEE"/>
                 </a:solidFill>
@@ -6174,7 +6439,7 @@
                 <a:ea typeface="Courier New" pitchFamily="34" charset="-122"/>
                 <a:cs typeface="Courier New" pitchFamily="34" charset="-120"/>
               </a:rPr>
-              <a:t>retrieval | subquestion=1 | source=semanticscholar failed (... after 4 retries</a:t>
+              <a:t>    found += self.retriever.retrieve_evidence(sq)</a:t>
             </a:r>
             <a:endParaRPr lang="en-US" sz="720" dirty="0"/>
           </a:p>
@@ -6183,7 +6448,7 @@
               <a:buNone/>
             </a:pPr>
             <a:r>
-              <a:rPr lang="en-US" sz="720" dirty="0">
+              <a:rPr lang="en-US" sz="760" dirty="0">
                 <a:solidFill>
                   <a:srgbClr val="E6EFEE"/>
                 </a:solidFill>
@@ -6191,7 +6456,7 @@
                 <a:ea typeface="Courier New" pitchFamily="34" charset="-122"/>
                 <a:cs typeface="Courier New" pitchFamily="34" charset="-120"/>
               </a:rPr>
-              <a:t>            (last problem: HTTP 429)) - continuing with remaining sources</a:t>
+              <a:t>new = validation.validate_dois_and_metadata(self._novel(found, seen))</a:t>
             </a:r>
             <a:endParaRPr lang="en-US" sz="720" dirty="0"/>
           </a:p>
@@ -6200,7 +6465,7 @@
               <a:buNone/>
             </a:pPr>
             <a:r>
-              <a:rPr lang="en-US" sz="720" dirty="0">
+              <a:rPr lang="en-US" sz="760" dirty="0">
                 <a:solidFill>
                   <a:srgbClr val="E6EFEE"/>
                 </a:solidFill>
@@ -6208,7 +6473,7 @@
                 <a:ea typeface="Courier New" pitchFamily="34" charset="-122"/>
                 <a:cs typeface="Courier New" pitchFamily="34" charset="-120"/>
               </a:rPr>
-              <a:t>orchestr. | threshold | subquestion=4 | returned 8 records but only 2 were relevant</a:t>
+              <a:t>assessed = self.evaluator.evaluate_evidence(question, [sq], new)</a:t>
             </a:r>
             <a:endParaRPr lang="en-US" sz="720" dirty="0"/>
           </a:p>
@@ -6217,15 +6482,15 @@
               <a:buNone/>
             </a:pPr>
             <a:r>
-              <a:rPr lang="en-US" sz="720" dirty="0">
-                <a:solidFill>
-                  <a:srgbClr val="E6EFEE"/>
+              <a:rPr lang="en-US" sz="760" dirty="0">
+                <a:solidFill>
+                  <a:srgbClr val="8FB3AE"/>
                 </a:solidFill>
                 <a:latin typeface="Courier New" pitchFamily="34" charset="0"/>
                 <a:ea typeface="Courier New" pitchFamily="34" charset="-122"/>
                 <a:cs typeface="Courier New" pitchFamily="34" charset="-120"/>
               </a:rPr>
-              <a:t>            (minimum 5) | reformulating (1 of 1 allowed)</a:t>
+              <a:t># Trigger 2 - the orchestrator's check after screening: enough *relevant* records?</a:t>
             </a:r>
             <a:endParaRPr lang="en-US" sz="720" dirty="0"/>
           </a:p>
@@ -6234,15 +6499,15 @@
               <a:buNone/>
             </a:pPr>
             <a:r>
-              <a:rPr lang="en-US" sz="720" dirty="0">
-                <a:solidFill>
-                  <a:srgbClr val="E6EFEE"/>
+              <a:rPr lang="en-US" sz="760" dirty="0">
+                <a:solidFill>
+                  <a:srgbClr val="8FB3AE"/>
                 </a:solidFill>
                 <a:latin typeface="Courier New" pitchFamily="34" charset="0"/>
                 <a:ea typeface="Courier New" pitchFamily="34" charset="-122"/>
                 <a:cs typeface="Courier New" pitchFamily="34" charset="-120"/>
               </a:rPr>
-              <a:t>retrieval | retrieved | subquestion=4 | sources_answered=openalex,semanticscholar | records=40</a:t>
+              <a:t># Stage 4's live run showed why this matters: sub-question 4's search returned 20</a:t>
             </a:r>
             <a:endParaRPr lang="en-US" sz="720" dirty="0"/>
           </a:p>
@@ -6251,14 +6516,288 @@
               <a:buNone/>
             </a:pPr>
             <a:r>
-              <a:rPr lang="en-US" sz="720" dirty="0">
-                <a:solidFill>
-                  <a:srgbClr val="E6EFEE"/>
+              <a:rPr lang="en-US" sz="760" dirty="0">
+                <a:solidFill>
+                  <a:srgbClr val="8FB3AE"/>
                 </a:solidFill>
                 <a:latin typeface="Courier New" pitchFamily="34" charset="0"/>
                 <a:ea typeface="Courier New" pitchFamily="34" charset="-122"/>
                 <a:cs typeface="Courier New" pitchFamily="34" charset="-120"/>
               </a:rPr>
+              <a:t># abstracts, 12 of them new, and only one answered it. Same single-retry budget.</a:t>
+            </a:r>
+            <a:endParaRPr lang="en-US" sz="720" dirty="0"/>
+          </a:p>
+          <a:p>
+            <a:pPr indent="0" marL="0">
+              <a:buNone/>
+            </a:pPr>
+            <a:r>
+              <a:rPr lang="en-US" sz="760" dirty="0">
+                <a:solidFill>
+                  <a:srgbClr val="E6EFEE"/>
+                </a:solidFill>
+                <a:latin typeface="Courier New" pitchFamily="34" charset="0"/>
+                <a:ea typeface="Courier New" pitchFamily="34" charset="-122"/>
+                <a:cs typeface="Courier New" pitchFamily="34" charset="-120"/>
+              </a:rPr>
+              <a:t>relevant = sum(1 for a in assessed if a.selected)</a:t>
+            </a:r>
+            <a:endParaRPr lang="en-US" sz="720" dirty="0"/>
+          </a:p>
+          <a:p>
+            <a:pPr indent="0" marL="0">
+              <a:buNone/>
+            </a:pPr>
+            <a:r>
+              <a:rPr lang="en-US" sz="760" dirty="0">
+                <a:solidFill>
+                  <a:srgbClr val="E6EFEE"/>
+                </a:solidFill>
+                <a:latin typeface="Courier New" pitchFamily="34" charset="0"/>
+                <a:ea typeface="Courier New" pitchFamily="34" charset="-122"/>
+                <a:cs typeface="Courier New" pitchFamily="34" charset="-120"/>
+              </a:rPr>
+              <a:t>if relevant &lt; config.RETRIEVAL_THRESHOLD and self._may_reformulate(sq):</a:t>
+            </a:r>
+            <a:endParaRPr lang="en-US" sz="720" dirty="0"/>
+          </a:p>
+          <a:p>
+            <a:pPr indent="0" marL="0">
+              <a:buNone/>
+            </a:pPr>
+            <a:r>
+              <a:rPr lang="en-US" sz="760" dirty="0">
+                <a:solidFill>
+                  <a:srgbClr val="E6EFEE"/>
+                </a:solidFill>
+                <a:latin typeface="Courier New" pitchFamily="34" charset="0"/>
+                <a:ea typeface="Courier New" pitchFamily="34" charset="-122"/>
+                <a:cs typeface="Courier New" pitchFamily="34" charset="-120"/>
+              </a:rPr>
+              <a:t>    ...   # same rewrite, then search and score the new query</a:t>
+            </a:r>
+            <a:endParaRPr lang="en-US" sz="720" dirty="0"/>
+          </a:p>
+        </p:txBody>
+      </p:sp>
+      <p:sp>
+        <p:nvSpPr>
+          <p:cNvPr id="4" name="Shape 1"/>
+          <p:cNvSpPr/>
+          <p:nvPr/>
+        </p:nvSpPr>
+        <p:spPr>
+          <a:xfrm>
+            <a:off x="457200" y="2788920"/>
+            <a:ext cx="5669280" cy="1481328"/>
+          </a:xfrm>
+          <a:prstGeom prst="roundRect">
+            <a:avLst>
+              <a:gd name="adj" fmla="val 3704"/>
+            </a:avLst>
+          </a:prstGeom>
+          <a:solidFill>
+            <a:srgbClr val="17292B"/>
+          </a:solidFill>
+          <a:ln w="12700">
+            <a:solidFill>
+              <a:srgbClr val="17292B"/>
+            </a:solidFill>
+            <a:prstDash val="solid"/>
+          </a:ln>
+        </p:spPr>
+        <p:txBody>
+          <a:bodyPr/>
+          <a:p/>
+        </p:txBody>
+      </p:sp>
+      <p:sp>
+        <p:nvSpPr>
+          <p:cNvPr id="5" name="Text 2"/>
+          <p:cNvSpPr txBox="1"/>
+          <p:nvPr/>
+        </p:nvSpPr>
+        <p:spPr>
+          <a:xfrm>
+            <a:off x="566928" y="2862072"/>
+            <a:ext cx="5449824" cy="1335024"/>
+          </a:xfrm>
+          <a:prstGeom prst="rect">
+            <a:avLst/>
+          </a:prstGeom>
+          <a:noFill/>
+          <a:ln/>
+        </p:spPr>
+        <p:txBody>
+          <a:bodyPr wrap="square" lIns="0" tIns="0" rIns="0" bIns="0" rtlCol="0" anchor="t"/>
+          <a:lstStyle/>
+          <a:p>
+            <a:pPr indent="0" marL="0">
+              <a:buNone/>
+            </a:pPr>
+            <a:r>
+              <a:rPr lang="en-US" sz="720" dirty="0">
+                <a:solidFill>
+                  <a:srgbClr val="8FB3AE"/>
+                </a:solidFill>
+                <a:latin typeface="Courier New" pitchFamily="34" charset="0"/>
+                <a:ea typeface="Courier New" pitchFamily="34" charset="-122"/>
+                <a:cs typeface="Courier New" pitchFamily="34" charset="-120"/>
+              </a:rPr>
+              <a:t># run.log, 30 Sept 10:11-10:15 (abridged: no timestamps, ... marks a cut)</a:t>
+            </a:r>
+            <a:endParaRPr lang="en-US" sz="720" dirty="0"/>
+          </a:p>
+          <a:p>
+            <a:pPr indent="0" marL="0">
+              <a:buNone/>
+            </a:pPr>
+            <a:r>
+              <a:rPr lang="en-US" sz="720" dirty="0">
+                <a:solidFill>
+                  <a:srgbClr val="E6EFEE"/>
+                </a:solidFill>
+                <a:latin typeface="Courier New" pitchFamily="34" charset="0"/>
+                <a:ea typeface="Courier New" pitchFamily="34" charset="-122"/>
+                <a:cs typeface="Courier New" pitchFamily="34" charset="-120"/>
+              </a:rPr>
+              <a:t>retrieval | retrieving | subquestion=1 | ... | sources=openalex,semanticscholar</a:t>
+            </a:r>
+            <a:endParaRPr lang="en-US" sz="720" dirty="0"/>
+          </a:p>
+          <a:p>
+            <a:pPr indent="0" marL="0">
+              <a:buNone/>
+            </a:pPr>
+            <a:r>
+              <a:rPr lang="en-US" sz="720" dirty="0">
+                <a:solidFill>
+                  <a:srgbClr val="E6EFEE"/>
+                </a:solidFill>
+                <a:latin typeface="Courier New" pitchFamily="34" charset="0"/>
+                <a:ea typeface="Courier New" pitchFamily="34" charset="-122"/>
+                <a:cs typeface="Courier New" pitchFamily="34" charset="-120"/>
+              </a:rPr>
+              <a:t>retrieval | retrieved  | subquestion=1 | source=openalex | records=20 | with_abstract=20</a:t>
+            </a:r>
+            <a:endParaRPr lang="en-US" sz="720" dirty="0"/>
+          </a:p>
+          <a:p>
+            <a:pPr indent="0" marL="0">
+              <a:buNone/>
+            </a:pPr>
+            <a:r>
+              <a:rPr lang="en-US" sz="720" dirty="0">
+                <a:solidFill>
+                  <a:srgbClr val="E6EFEE"/>
+                </a:solidFill>
+                <a:latin typeface="Courier New" pitchFamily="34" charset="0"/>
+                <a:ea typeface="Courier New" pitchFamily="34" charset="-122"/>
+                <a:cs typeface="Courier New" pitchFamily="34" charset="-120"/>
+              </a:rPr>
+              <a:t>http      | semanticscholar | HTTP 429 (transient) - retry 4/4 in 24s</a:t>
+            </a:r>
+            <a:endParaRPr lang="en-US" sz="720" dirty="0"/>
+          </a:p>
+          <a:p>
+            <a:pPr indent="0" marL="0">
+              <a:buNone/>
+            </a:pPr>
+            <a:r>
+              <a:rPr lang="en-US" sz="720" dirty="0">
+                <a:solidFill>
+                  <a:srgbClr val="E6EFEE"/>
+                </a:solidFill>
+                <a:latin typeface="Courier New" pitchFamily="34" charset="0"/>
+                <a:ea typeface="Courier New" pitchFamily="34" charset="-122"/>
+                <a:cs typeface="Courier New" pitchFamily="34" charset="-120"/>
+              </a:rPr>
+              <a:t>retrieval | subquestion=1 | source=semanticscholar failed (... after 4 retries</a:t>
+            </a:r>
+            <a:endParaRPr lang="en-US" sz="720" dirty="0"/>
+          </a:p>
+          <a:p>
+            <a:pPr indent="0" marL="0">
+              <a:buNone/>
+            </a:pPr>
+            <a:r>
+              <a:rPr lang="en-US" sz="720" dirty="0">
+                <a:solidFill>
+                  <a:srgbClr val="E6EFEE"/>
+                </a:solidFill>
+                <a:latin typeface="Courier New" pitchFamily="34" charset="0"/>
+                <a:ea typeface="Courier New" pitchFamily="34" charset="-122"/>
+                <a:cs typeface="Courier New" pitchFamily="34" charset="-120"/>
+              </a:rPr>
+              <a:t>            (last problem: HTTP 429)) - continuing with remaining sources</a:t>
+            </a:r>
+            <a:endParaRPr lang="en-US" sz="720" dirty="0"/>
+          </a:p>
+          <a:p>
+            <a:pPr indent="0" marL="0">
+              <a:buNone/>
+            </a:pPr>
+            <a:r>
+              <a:rPr lang="en-US" sz="720" dirty="0">
+                <a:solidFill>
+                  <a:srgbClr val="E6EFEE"/>
+                </a:solidFill>
+                <a:latin typeface="Courier New" pitchFamily="34" charset="0"/>
+                <a:ea typeface="Courier New" pitchFamily="34" charset="-122"/>
+                <a:cs typeface="Courier New" pitchFamily="34" charset="-120"/>
+              </a:rPr>
+              <a:t>orchestr. | threshold | subquestion=4 | the query returned 8 records but only 2 were relevant</a:t>
+            </a:r>
+            <a:endParaRPr lang="en-US" sz="720" dirty="0"/>
+          </a:p>
+          <a:p>
+            <a:pPr indent="0" marL="0">
+              <a:buNone/>
+            </a:pPr>
+            <a:r>
+              <a:rPr lang="en-US" sz="720" dirty="0">
+                <a:solidFill>
+                  <a:srgbClr val="E6EFEE"/>
+                </a:solidFill>
+                <a:latin typeface="Courier New" pitchFamily="34" charset="0"/>
+                <a:ea typeface="Courier New" pitchFamily="34" charset="-122"/>
+                <a:cs typeface="Courier New" pitchFamily="34" charset="-120"/>
+              </a:rPr>
+              <a:t>            (minimum 5); ... | reformulating (1 of 1 allowed)</a:t>
+            </a:r>
+            <a:endParaRPr lang="en-US" sz="720" dirty="0"/>
+          </a:p>
+          <a:p>
+            <a:pPr indent="0" marL="0">
+              <a:buNone/>
+            </a:pPr>
+            <a:r>
+              <a:rPr lang="en-US" sz="720" dirty="0">
+                <a:solidFill>
+                  <a:srgbClr val="E6EFEE"/>
+                </a:solidFill>
+                <a:latin typeface="Courier New" pitchFamily="34" charset="0"/>
+                <a:ea typeface="Courier New" pitchFamily="34" charset="-122"/>
+                <a:cs typeface="Courier New" pitchFamily="34" charset="-120"/>
+              </a:rPr>
+              <a:t>retrieval | retrieved | subquestion=4 | sources_answered=openalex,semanticscholar | records=40 ...</a:t>
+            </a:r>
+            <a:endParaRPr lang="en-US" sz="720" dirty="0"/>
+          </a:p>
+          <a:p>
+            <a:pPr indent="0" marL="0">
+              <a:buNone/>
+            </a:pPr>
+            <a:r>
+              <a:rPr lang="en-US" sz="720" dirty="0">
+                <a:solidFill>
+                  <a:srgbClr val="E6EFEE"/>
+                </a:solidFill>
+                <a:latin typeface="Courier New" pitchFamily="34" charset="0"/>
+                <a:ea typeface="Courier New" pitchFamily="34" charset="-122"/>
+                <a:cs typeface="Courier New" pitchFamily="34" charset="-120"/>
+              </a:rPr>
               <a:t>orchestr. | threshold | subquestion=4 | after reformulation: 33 new records, 20 relevant</a:t>
             </a:r>
             <a:endParaRPr lang="en-US" sz="720" dirty="0"/>
@@ -6298,7 +6837,7 @@
                 <a:ea typeface="Calibri" pitchFamily="34" charset="-122"/>
                 <a:cs typeface="Calibri" pitchFamily="34" charset="-120"/>
               </a:rPr>
-              <a:t>Above: one score per paper with its reason.  Below: a source failing over, and the single automatic retry with both sources answering.</a:t>
+              <a:t>Above: the code that decides on the one query rewrite, as submitted.  Below: run.log, 30 Sept - a source failing over, and that rewrite with both sources answering.</a:t>
             </a:r>
             <a:endParaRPr lang="en-US" sz="950" dirty="0"/>
           </a:p>
@@ -6330,6 +6869,10 @@
             <a:prstDash val="solid"/>
           </a:ln>
         </p:spPr>
+        <p:txBody>
+          <a:bodyPr/>
+          <a:p/>
+        </p:txBody>
       </p:sp>
       <p:sp>
         <p:nvSpPr>
@@ -6481,7 +7024,7 @@
                 <a:ea typeface="Calibri" pitchFamily="34" charset="-122"/>
                 <a:cs typeface="Calibri" pitchFamily="34" charset="-120"/>
               </a:rPr>
-              <a:t>DOIs registered in Crossref; the rest flagged, never dropped</a:t>
+              <a:t>papers with a DOI verified in Crossref; the rest flagged, never dropped</a:t>
             </a:r>
             <a:endParaRPr lang="en-US" sz="950" dirty="0"/>
           </a:p>
@@ -6637,7 +7180,7 @@
                 <a:ea typeface="Calibri" pitchFamily="34" charset="-122"/>
                 <a:cs typeface="Calibri" pitchFamily="34" charset="-120"/>
               </a:rPr>
-              <a:t>relevant papers for sub-question 4 after the single retry (1 → 3 with one source)</a:t>
+              <a:t>relevant papers for sub-question 4 after the one retry (2 → 6 with one source)</a:t>
             </a:r>
             <a:endParaRPr lang="en-US" sz="950" dirty="0"/>
           </a:p>
@@ -6772,6 +7315,10 @@
             <a:prstDash val="solid"/>
           </a:ln>
         </p:spPr>
+        <p:txBody>
+          <a:bodyPr/>
+          <a:p/>
+        </p:txBody>
       </p:sp>
       <p:sp>
         <p:nvSpPr>
@@ -6800,13 +7347,13 @@
             <a:r>
               <a:rPr lang="en-US" sz="700" dirty="0">
                 <a:solidFill>
-                  <a:srgbClr val="E6EFEE"/>
+                  <a:srgbClr val="8FB3AE"/>
                 </a:solidFill>
                 <a:latin typeface="Courier New" pitchFamily="34" charset="0"/>
                 <a:ea typeface="Courier New" pitchFamily="34" charset="-122"/>
                 <a:cs typeface="Courier New" pitchFamily="34" charset="-120"/>
               </a:rPr>
-              <a:t>=== Review 2: selected evidence ===</a:t>
+              <a:t># terminal, 30 Sept 10:15-10:18 (abridged; ... marks a cut)</a:t>
             </a:r>
             <a:endParaRPr lang="en-US" sz="700" dirty="0"/>
           </a:p>
@@ -6823,7 +7370,7 @@
                 <a:ea typeface="Courier New" pitchFamily="34" charset="-122"/>
                 <a:cs typeface="Courier New" pitchFamily="34" charset="-120"/>
               </a:rPr>
-              <a:t>Sub-question 4: How are hallucination rates and factual accuracy evaluated</a:t>
+              <a:t>=== Review 2: selected evidence ===</a:t>
             </a:r>
             <a:endParaRPr lang="en-US" sz="700" dirty="0"/>
           </a:p>
@@ -6840,7 +7387,7 @@
                 <a:ea typeface="Courier New" pitchFamily="34" charset="-122"/>
                 <a:cs typeface="Courier New" pitchFamily="34" charset="-120"/>
               </a:rPr>
-              <a:t>  in multi-step agent workflows? (query reformulated once: ... )</a:t>
+              <a:t>Sub-question 4: How are hallucination rates and factual accuracy evaluated</a:t>
             </a:r>
             <a:endParaRPr lang="en-US" sz="700" dirty="0"/>
           </a:p>
@@ -6857,7 +7404,7 @@
                 <a:ea typeface="Courier New" pitchFamily="34" charset="-122"/>
                 <a:cs typeface="Courier New" pitchFamily="34" charset="-120"/>
               </a:rPr>
-              <a:t>  65. [5/5] AgentHallu: Benchmarking Automated Hallucination Attribution of</a:t>
+              <a:t>  in multi-step agent workflows? (query reformulated once: ... )</a:t>
             </a:r>
             <a:endParaRPr lang="en-US" sz="700" dirty="0"/>
           </a:p>
@@ -6874,7 +7421,7 @@
                 <a:ea typeface="Courier New" pitchFamily="34" charset="-122"/>
                 <a:cs typeface="Courier New" pitchFamily="34" charset="-120"/>
               </a:rPr>
-              <a:t>            LLM-based Agents (2026) - DOI UNVERIFIED</a:t>
+              <a:t>  65. [5/5] AgentHallu: Benchmarking Automated Hallucination Attribution of</a:t>
             </a:r>
             <a:endParaRPr lang="en-US" sz="700" dirty="0"/>
           </a:p>
@@ -6891,7 +7438,7 @@
                 <a:ea typeface="Courier New" pitchFamily="34" charset="-122"/>
                 <a:cs typeface="Courier New" pitchFamily="34" charset="-120"/>
               </a:rPr>
-              <a:t>  76. [5/5] From Output Errors to Workflow Harm: A Practitioner-Audit Method</a:t>
+              <a:t>            LLM-based Agents (2026) - DOI UNVERIFIED</a:t>
             </a:r>
             <a:endParaRPr lang="en-US" sz="700" dirty="0"/>
           </a:p>
@@ -6908,7 +7455,7 @@
                 <a:ea typeface="Courier New" pitchFamily="34" charset="-122"/>
                 <a:cs typeface="Courier New" pitchFamily="34" charset="-120"/>
               </a:rPr>
-              <a:t>            for LLM-Mediated Research (2026) - DOI verified</a:t>
+              <a:t>  76. [5/5] From Output Errors to Workflow Harm: A Practitioner-Audit Method</a:t>
             </a:r>
             <a:endParaRPr lang="en-US" sz="700" dirty="0"/>
           </a:p>
@@ -6925,7 +7472,7 @@
                 <a:ea typeface="Courier New" pitchFamily="34" charset="-122"/>
                 <a:cs typeface="Courier New" pitchFamily="34" charset="-120"/>
               </a:rPr>
-              <a:t>77 papers selected; 40 screened out (reasons are recorded in the brief).</a:t>
+              <a:t>            for LLM-Mediated Research (2026) - DOI verified</a:t>
             </a:r>
             <a:endParaRPr lang="en-US" sz="700" dirty="0"/>
           </a:p>
@@ -6942,7 +7489,7 @@
                 <a:ea typeface="Courier New" pitchFamily="34" charset="-122"/>
                 <a:cs typeface="Courier New" pitchFamily="34" charset="-120"/>
               </a:rPr>
-              <a:t>Type 'approve' to write the brief, or 'drop 3, 7' ..., or 'reject' ...</a:t>
+              <a:t>77 papers selected; 40 screened out (reasons are recorded in the brief).</a:t>
             </a:r>
             <a:endParaRPr lang="en-US" sz="700" dirty="0"/>
           </a:p>
@@ -6953,13 +7500,13 @@
             <a:r>
               <a:rPr lang="en-US" sz="700" dirty="0">
                 <a:solidFill>
-                  <a:srgbClr val="F2C572"/>
+                  <a:srgbClr val="E6EFEE"/>
                 </a:solidFill>
                 <a:latin typeface="Courier New" pitchFamily="34" charset="0"/>
                 <a:ea typeface="Courier New" pitchFamily="34" charset="-122"/>
                 <a:cs typeface="Courier New" pitchFamily="34" charset="-120"/>
               </a:rPr>
-              <a:t>&gt; approve</a:t>
+              <a:t>Type 'approve' to write the brief, or 'drop 3, 7' ..., or 'reject' ...</a:t>
             </a:r>
             <a:endParaRPr lang="en-US" sz="700" dirty="0"/>
           </a:p>
@@ -6970,13 +7517,13 @@
             <a:r>
               <a:rPr lang="en-US" sz="700" dirty="0">
                 <a:solidFill>
-                  <a:srgbClr val="E6EFEE"/>
+                  <a:srgbClr val="F2C572"/>
                 </a:solidFill>
                 <a:latin typeface="Courier New" pitchFamily="34" charset="0"/>
                 <a:ea typeface="Courier New" pitchFamily="34" charset="-122"/>
                 <a:cs typeface="Courier New" pitchFamily="34" charset="-120"/>
               </a:rPr>
-              <a:t>evaluation   | summarising | subquestion=4 | batch=1/3 | papers=10</a:t>
+              <a:t>&gt; approve</a:t>
             </a:r>
             <a:endParaRPr lang="en-US" sz="700" dirty="0"/>
           </a:p>
@@ -6993,7 +7540,7 @@
                 <a:ea typeface="Courier New" pitchFamily="34" charset="-122"/>
                 <a:cs typeface="Courier New" pitchFamily="34" charset="-120"/>
               </a:rPr>
-              <a:t>evaluation   | summarised | papers=77</a:t>
+              <a:t>evaluation   | summarising | subquestion=4 | batch=1/3 | papers=10</a:t>
             </a:r>
             <a:endParaRPr lang="en-US" sz="700" dirty="0"/>
           </a:p>
@@ -7010,7 +7557,7 @@
                 <a:ea typeface="Courier New" pitchFamily="34" charset="-122"/>
                 <a:cs typeface="Courier New" pitchFamily="34" charset="-120"/>
               </a:rPr>
-              <a:t>evaluation   | synthesised | themes=4 | gaps=3</a:t>
+              <a:t>evaluation   | summarised | papers=77</a:t>
             </a:r>
             <a:endParaRPr lang="en-US" sz="700" dirty="0"/>
           </a:p>
@@ -7027,7 +7574,7 @@
                 <a:ea typeface="Courier New" pitchFamily="34" charset="-122"/>
                 <a:cs typeface="Courier New" pitchFamily="34" charset="-120"/>
               </a:rPr>
-              <a:t>117 unique papers across 4 sub-questions | 78 DOIs verified</a:t>
+              <a:t>evaluation   | synthesised | themes=4 | gaps=3</a:t>
             </a:r>
             <a:endParaRPr lang="en-US" sz="700" dirty="0"/>
           </a:p>
@@ -7044,7 +7591,7 @@
                 <a:ea typeface="Courier New" pitchFamily="34" charset="-122"/>
                 <a:cs typeface="Courier New" pitchFamily="34" charset="-120"/>
               </a:rPr>
-              <a:t>  | 77 approved, 40 excluded | 4 themes, 3 gaps | reformulations: 1</a:t>
+              <a:t>117 unique papers across 4 sub-questions | 78 DOIs verified</a:t>
             </a:r>
             <a:endParaRPr lang="en-US" sz="700" dirty="0"/>
           </a:p>
@@ -7061,7 +7608,41 @@
                 <a:ea typeface="Courier New" pitchFamily="34" charset="-122"/>
                 <a:cs typeface="Courier New" pitchFamily="34" charset="-120"/>
               </a:rPr>
-              <a:t>Run complete - brief written.</a:t>
+              <a:t>  | 77 approved, 40 excluded | 4 themes, 3 gaps</a:t>
+            </a:r>
+            <a:endParaRPr lang="en-US" sz="700" dirty="0"/>
+          </a:p>
+          <a:p>
+            <a:pPr indent="0" marL="0">
+              <a:buNone/>
+            </a:pPr>
+            <a:r>
+              <a:rPr lang="en-US" sz="700" dirty="0">
+                <a:solidFill>
+                  <a:srgbClr val="E6EFEE"/>
+                </a:solidFill>
+                <a:latin typeface="Courier New" pitchFamily="34" charset="0"/>
+                <a:ea typeface="Courier New" pitchFamily="34" charset="-122"/>
+                <a:cs typeface="Courier New" pitchFamily="34" charset="-120"/>
+              </a:rPr>
+              <a:t>  | reformulations: 1, scope revisions: 0</a:t>
+            </a:r>
+            <a:endParaRPr lang="en-US" sz="700" dirty="0"/>
+          </a:p>
+          <a:p>
+            <a:pPr indent="0" marL="0">
+              <a:buNone/>
+            </a:pPr>
+            <a:r>
+              <a:rPr lang="en-US" sz="700" dirty="0">
+                <a:solidFill>
+                  <a:srgbClr val="E6EFEE"/>
+                </a:solidFill>
+                <a:latin typeface="Courier New" pitchFamily="34" charset="0"/>
+                <a:ea typeface="Courier New" pitchFamily="34" charset="-122"/>
+                <a:cs typeface="Courier New" pitchFamily="34" charset="-120"/>
+              </a:rPr>
+              <a:t>Saved: output/brief-20260930-101857-what-approaches-...md</a:t>
             </a:r>
             <a:endParaRPr lang="en-US" sz="700" dirty="0"/>
           </a:p>
@@ -7093,6 +7674,10 @@
             <a:prstDash val="solid"/>
           </a:ln>
         </p:spPr>
+        <p:txBody>
+          <a:bodyPr/>
+          <a:p/>
+        </p:txBody>
       </p:sp>
       <p:sp>
         <p:nvSpPr>
@@ -7127,7 +7712,7 @@
                 <a:ea typeface="Calibri" pitchFamily="34" charset="-122"/>
                 <a:cs typeface="Calibri" pitchFamily="34" charset="-120"/>
               </a:rPr>
-              <a:t>From the brief (30 Sept run, abridged)</a:t>
+              <a:t>From the brief of 30 Sept (... marks a cut)</a:t>
             </a:r>
             <a:endParaRPr lang="en-US" sz="1150" dirty="0"/>
           </a:p>
@@ -7180,7 +7765,7 @@
                 <a:ea typeface="Calibri" pitchFamily="34" charset="-122"/>
                 <a:cs typeface="Calibri" pitchFamily="34" charset="-120"/>
               </a:rPr>
-              <a:t>TRACE, a practitioner-audit framework, demonstrated on 45 documentation-positive incidents recorded by a clinician-informatician - the figure is in the paper's abstract. Found by Semantic Scholar only.</a:t>
+              <a:t>The paper presents TRACE, a practitioner-audit framework ... demonstrated through an empirical analysis of 45 documentation-positive incidents recorded by a clinician-informatician. ...</a:t>
             </a:r>
             <a:pPr indent="0" marL="0">
               <a:buNone/>
@@ -7191,12 +7776,35 @@
             <a:pPr indent="0" marL="0">
               <a:buNone/>
             </a:pPr>
+            <a:r>
+              <a:rPr lang="en-US" sz="900" dirty="0" i="1">
+                <a:solidFill>
+                  <a:srgbClr val="5F6F70"/>
+                </a:solidFill>
+                <a:latin typeface="Calibri" pitchFamily="34" charset="0"/>
+                <a:ea typeface="Calibri" pitchFamily="34" charset="-122"/>
+                <a:cs typeface="Calibri" pitchFamily="34" charset="-120"/>
+              </a:rPr>
+              <a:t>Checked: the figure 45 is in the paper's abstract. The paper came from Semantic Scholar only.</a:t>
+            </a:r>
+            <a:pPr indent="0" marL="0">
+              <a:buNone/>
+            </a:pPr>
+            <a:pPr indent="0" marL="0">
+              <a:buNone/>
+            </a:pPr>
             <a:endParaRPr lang="en-US" sz="900" dirty="0"/>
           </a:p>
           <a:p>
             <a:pPr indent="0" marL="0">
               <a:buNone/>
             </a:pPr>
+            <a:endParaRPr lang="en-US" sz="900" dirty="0"/>
+          </a:p>
+          <a:p>
+            <a:pPr indent="0" marL="0">
+              <a:buNone/>
+            </a:pPr>
             <a:r>
               <a:rPr lang="en-US" sz="900" b="1" dirty="0">
                 <a:solidFill>
@@ -7223,7 +7831,7 @@
                 <a:ea typeface="Calibri" pitchFamily="34" charset="-122"/>
                 <a:cs typeface="Calibri" pitchFamily="34" charset="-120"/>
               </a:rPr>
-              <a:t>Evaluation of multi-step agent workflows involves specialised benchmarks, automated hallucination attribution frameworks, multi-agent audits and domain-aware metrics. [63, 64, 65, 67, 73, 74, 76, 77]</a:t>
+              <a:t>Evaluation of multi-step agent workflows involves specialized benchmarks, automated hallucination attribution frameworks, multi-agent audits, and domain-aware metrics to track trajectory-level and cross-source errors. [63, 64, 65, 67, 73, 74, 76, 77]</a:t>
             </a:r>
             <a:pPr indent="0" marL="0">
               <a:buNone/>
@@ -7266,7 +7874,7 @@
                 <a:ea typeface="Calibri" pitchFamily="34" charset="-122"/>
                 <a:cs typeface="Calibri" pitchFamily="34" charset="-120"/>
               </a:rPr>
-              <a:t>Few papers address the computational overhead and latency of continuous self-correction loops.</a:t>
+              <a:t>Few papers address the computational overhead and latency introduced by continuous self-correction loops ...</a:t>
             </a:r>
             <a:pPr indent="0" marL="0">
               <a:buNone/>
@@ -7309,7 +7917,7 @@
                 <a:ea typeface="Calibri" pitchFamily="34" charset="-122"/>
                 <a:cs typeface="Calibri" pitchFamily="34" charset="-120"/>
               </a:rPr>
-              <a:t>openalex: 5 of 5 searches answered, 100 records; semanticscholar: 2 of 5, 40 records. Automatic failover was used: semanticscholar failed for 3 search(es).</a:t>
+              <a:t>... semanticscholar: 2 of 5 searches answered, 40 records. ... Automatic failover was used: semanticscholar failed for 3 search(es) ...</a:t>
             </a:r>
             <a:endParaRPr lang="en-US" sz="900" dirty="0"/>
           </a:p>
@@ -7348,7 +7956,7 @@
                 <a:ea typeface="Calibri" pitchFamily="34" charset="-122"/>
                 <a:cs typeface="Calibri" pitchFamily="34" charset="-120"/>
               </a:rPr>
-              <a:t>The reference list is built from the records' own metadata - the model never writes a citation.</a:t>
+              <a:t>The reference list is built from the records' own metadata - the model cites papers by number and never writes a reference.</a:t>
             </a:r>
             <a:endParaRPr lang="en-US" sz="1100" dirty="0"/>
           </a:p>
@@ -7517,7 +8125,7 @@
                 <a:ea typeface="Cambria" pitchFamily="34" charset="-122"/>
                 <a:cs typeface="Cambria" pitchFamily="34" charset="-120"/>
               </a:rPr>
-              <a:t>68</a:t>
+              <a:t>113</a:t>
             </a:r>
             <a:endParaRPr lang="en-US" sz="4400" dirty="0"/>
           </a:p>
@@ -7595,7 +8203,7 @@
                 <a:ea typeface="Calibri" pitchFamily="34" charset="-122"/>
                 <a:cs typeface="Calibri" pitchFamily="34" charset="-120"/>
               </a:rPr>
-              <a:t>pytest, no network. Recorded API replies in tests/fixtures. Data models, abstract reconstruction, de-duplication and DOI checks, the 3-5 rule, schema validation and repair, review loops, threshold and retry caps, cut-off, batching, themes citing non-existent papers, retry policies, brief layout; the second source, merging and failover.</a:t>
+              <a:t>pytest, no network. Recorded API replies in tests/fixtures. Data models, abstract reconstruction, de-duplication and DOI checks, the 3-5 rule, schema validation and repair, review loops, threshold and retry caps, cut-off, batching, themes citing non-existent papers, retry policies, brief layout; the second source and failover; the cache, logging, error messages and how a run ends.</a:t>
             </a:r>
             <a:endParaRPr lang="en-US" sz="950" dirty="0"/>
           </a:p>
@@ -7661,7 +8269,7 @@
                 <a:ea typeface="Cambria" pitchFamily="34" charset="-122"/>
                 <a:cs typeface="Cambria" pitchFamily="34" charset="-120"/>
               </a:rPr>
-              <a:t>11</a:t>
+              <a:t>16</a:t>
             </a:r>
             <a:endParaRPr lang="en-US" sz="4400" dirty="0"/>
           </a:p>
@@ -7739,7 +8347,7 @@
                 <a:ea typeface="Calibri" pitchFamily="34" charset="-122"/>
                 <a:cs typeface="Calibri" pitchFamily="34" charset="-120"/>
               </a:rPr>
-              <a:t>Live, against the real services, each with command, expected and observed result. Missing key; drop; revise; reject scope once then refused; full run; threshold retry; transient errors; daily quota stop; malformed-JSON repair; two-source run with real failover; non-transient failure not retried. All pass.</a:t>
+              <a:t>Live, against the real services, with steps, expected and observed result. FT-01 to FT-11, 17-30 Sept: missing key, drop, revise, reject scope, full run, threshold retry, transient errors, quota stop, JSON repair, two sources with failover. FT-12 to FT-16, 2 Oct, on the submitted code: revise with the fix, three other questions, stop messages. All pass, two with a qualification (FT-03, FT-14). Plus an offline replay of the 30 Sept run.</a:t>
             </a:r>
             <a:endParaRPr lang="en-US" sz="950" dirty="0"/>
           </a:p>
@@ -7805,7 +8413,7 @@
                 <a:ea typeface="Cambria" pitchFamily="34" charset="-122"/>
                 <a:cs typeface="Cambria" pitchFamily="34" charset="-120"/>
               </a:rPr>
-              <a:t>11</a:t>
+              <a:t>21</a:t>
             </a:r>
             <a:endParaRPr lang="en-US" sz="4400" dirty="0"/>
           </a:p>
@@ -7883,7 +8491,7 @@
                 <a:ea typeface="Calibri" pitchFamily="34" charset="-122"/>
                 <a:cs typeface="Calibri" pitchFamily="34" charset="-120"/>
               </a:rPr>
-              <a:t>Every problem met during development, its cause, the change made, and how the fix was verified - the model retirement, 503s, timeouts, quotas, OpenAlex's policy change, a typo that re-planned.</a:t>
+              <a:t>Every problem met during development, its cause, the change made, and how the fix was verified - the model retirement, 503s, timeouts, quotas, OpenAlex's policy change, a typo that re-planned; and ten found on 1 Oct by reading the code and the documents against each other.</a:t>
             </a:r>
             <a:endParaRPr lang="en-US" sz="950" dirty="0"/>
           </a:p>
@@ -7949,7 +8557,7 @@
                 <a:ea typeface="Courier New" pitchFamily="34" charset="-122"/>
                 <a:cs typeface="Courier New" pitchFamily="34" charset="-120"/>
               </a:rPr>
-              <a:t>$ pytest -q</a:t>
+              <a:t>pytest -&gt; 113 passed     (full output: evidence/pytest_113_passed.txt)</a:t>
             </a:r>
             <a:endParaRPr lang="en-US" sz="800" dirty="0"/>
           </a:p>
@@ -7966,7 +8574,7 @@
                 <a:ea typeface="Courier New" pitchFamily="34" charset="-122"/>
                 <a:cs typeface="Courier New" pitchFamily="34" charset="-120"/>
               </a:rPr>
-              <a:t>collected 68 items   (evaluation 13 . http 5 . models 5 . planning 6 . retrieval 7 . s2_client 5 . search_client 4 . stage5 8 . storage 1 . synthesis 9 . validation 5)</a:t>
+              <a:t>per file:  cache 6 · evaluation 13 · http 9 · llm_client 5 · logging_setup 2 · main 12 · models 5 · planning 10 · retrieval 7 · s2_client 5 · search_client 6 · stage5 14 · storage 2 · synthesis 9 · validation 8</a:t>
             </a:r>
             <a:endParaRPr lang="en-US" sz="800" dirty="0"/>
           </a:p>
@@ -7983,7 +8591,7 @@
                 <a:ea typeface="Courier New" pitchFamily="34" charset="-122"/>
                 <a:cs typeface="Courier New" pitchFamily="34" charset="-120"/>
               </a:rPr>
-              <a:t>68 passed in 0.32s</a:t>
+              <a:t>second model on FT-13 -&gt; would keep 27 of 35 kept (clear answers) · κ 0.65 · agreement, not precision  (evidence/model_judge_*)</a:t>
             </a:r>
             <a:endParaRPr lang="en-US" sz="800" dirty="0"/>
           </a:p>
@@ -8218,7 +8826,7 @@
         <p:spPr>
           <a:xfrm>
             <a:off x="457200" y="1463040"/>
-            <a:ext cx="8229600" cy="603504"/>
+            <a:ext cx="8229600" cy="548640"/>
           </a:xfrm>
           <a:prstGeom prst="rect">
             <a:avLst/>
@@ -8242,8 +8850,8 @@
         </p:nvSpPr>
         <p:spPr>
           <a:xfrm>
-            <a:off x="502920" y="1508760"/>
-            <a:ext cx="914400" cy="512064"/>
+            <a:off x="502920" y="1490472"/>
+            <a:ext cx="914400" cy="493776"/>
           </a:xfrm>
           <a:prstGeom prst="rect">
             <a:avLst/>
@@ -8281,8 +8889,8 @@
         </p:nvSpPr>
         <p:spPr>
           <a:xfrm>
-            <a:off x="1417320" y="1508760"/>
-            <a:ext cx="3566160" cy="512064"/>
+            <a:off x="1417320" y="1490472"/>
+            <a:ext cx="3566160" cy="493776"/>
           </a:xfrm>
           <a:prstGeom prst="rect">
             <a:avLst/>
@@ -8306,7 +8914,7 @@
                 <a:ea typeface="Calibri" pitchFamily="34" charset="-122"/>
                 <a:cs typeface="Calibri" pitchFamily="34" charset="-120"/>
               </a:rPr>
-              <a:t>First Gemini call: HTTP 404 - the model chosen at design time had been retired by the provider</a:t>
+              <a:t>First Gemini call: HTTP 404 - the model the build was first configured for had been retired by the provider</a:t>
             </a:r>
             <a:endParaRPr lang="en-US" sz="1000" dirty="0"/>
           </a:p>
@@ -8320,8 +8928,8 @@
         </p:nvSpPr>
         <p:spPr>
           <a:xfrm>
-            <a:off x="5120640" y="1508760"/>
-            <a:ext cx="3520440" cy="512064"/>
+            <a:off x="5120640" y="1490472"/>
+            <a:ext cx="3520440" cy="493776"/>
           </a:xfrm>
           <a:prstGeom prst="rect">
             <a:avLst/>
@@ -8345,7 +8953,7 @@
                 <a:ea typeface="Calibri" pitchFamily="34" charset="-122"/>
                 <a:cs typeface="Calibri" pitchFamily="34" charset="-120"/>
               </a:rPr>
-              <a:t>Model name was already in configuration: one line in .env</a:t>
+              <a:t>Model name was already in configuration: a change of setting, no change to the logic</a:t>
             </a:r>
             <a:endParaRPr lang="en-US" sz="1000" dirty="0"/>
           </a:p>
@@ -8359,8 +8967,8 @@
         </p:nvSpPr>
         <p:spPr>
           <a:xfrm>
-            <a:off x="502920" y="2112264"/>
-            <a:ext cx="914400" cy="512064"/>
+            <a:off x="502920" y="2039112"/>
+            <a:ext cx="914400" cy="493776"/>
           </a:xfrm>
           <a:prstGeom prst="rect">
             <a:avLst/>
@@ -8398,8 +9006,8 @@
         </p:nvSpPr>
         <p:spPr>
           <a:xfrm>
-            <a:off x="1417320" y="2112264"/>
-            <a:ext cx="3566160" cy="512064"/>
+            <a:off x="1417320" y="2039112"/>
+            <a:ext cx="3566160" cy="493776"/>
           </a:xfrm>
           <a:prstGeom prst="rect">
             <a:avLst/>
@@ -8437,8 +9045,8 @@
         </p:nvSpPr>
         <p:spPr>
           <a:xfrm>
-            <a:off x="5120640" y="2112264"/>
-            <a:ext cx="3520440" cy="512064"/>
+            <a:off x="5120640" y="2039112"/>
+            <a:ext cx="3520440" cy="493776"/>
           </a:xfrm>
           <a:prstGeom prst="rect">
             <a:avLst/>
@@ -8476,8 +9084,8 @@
         </p:nvSpPr>
         <p:spPr>
           <a:xfrm>
-            <a:off x="457200" y="2670048"/>
-            <a:ext cx="8229600" cy="603504"/>
+            <a:off x="457200" y="2560320"/>
+            <a:ext cx="8229600" cy="548640"/>
           </a:xfrm>
           <a:prstGeom prst="rect">
             <a:avLst/>
@@ -8501,8 +9109,8 @@
         </p:nvSpPr>
         <p:spPr>
           <a:xfrm>
-            <a:off x="502920" y="2715768"/>
-            <a:ext cx="914400" cy="512064"/>
+            <a:off x="502920" y="2587752"/>
+            <a:ext cx="914400" cy="493776"/>
           </a:xfrm>
           <a:prstGeom prst="rect">
             <a:avLst/>
@@ -8540,8 +9148,8 @@
         </p:nvSpPr>
         <p:spPr>
           <a:xfrm>
-            <a:off x="1417320" y="2715768"/>
-            <a:ext cx="3566160" cy="512064"/>
+            <a:off x="1417320" y="2587752"/>
+            <a:ext cx="3566160" cy="493776"/>
           </a:xfrm>
           <a:prstGeom prst="rect">
             <a:avLst/>
@@ -8579,8 +9187,8 @@
         </p:nvSpPr>
         <p:spPr>
           <a:xfrm>
-            <a:off x="5120640" y="2715768"/>
-            <a:ext cx="3520440" cy="512064"/>
+            <a:off x="5120640" y="2587752"/>
+            <a:ext cx="3520440" cy="493776"/>
           </a:xfrm>
           <a:prstGeom prst="rect">
             <a:avLst/>
@@ -8618,8 +9226,8 @@
         </p:nvSpPr>
         <p:spPr>
           <a:xfrm>
-            <a:off x="502920" y="3319272"/>
-            <a:ext cx="914400" cy="512064"/>
+            <a:off x="502920" y="3136392"/>
+            <a:ext cx="914400" cy="493776"/>
           </a:xfrm>
           <a:prstGeom prst="rect">
             <a:avLst/>
@@ -8657,8 +9265,8 @@
         </p:nvSpPr>
         <p:spPr>
           <a:xfrm>
-            <a:off x="1417320" y="3319272"/>
-            <a:ext cx="3566160" cy="512064"/>
+            <a:off x="1417320" y="3136392"/>
+            <a:ext cx="3566160" cy="493776"/>
           </a:xfrm>
           <a:prstGeom prst="rect">
             <a:avLst/>
@@ -8696,8 +9304,8 @@
         </p:nvSpPr>
         <p:spPr>
           <a:xfrm>
-            <a:off x="5120640" y="3319272"/>
-            <a:ext cx="3520440" cy="512064"/>
+            <a:off x="5120640" y="3136392"/>
+            <a:ext cx="3520440" cy="493776"/>
           </a:xfrm>
           <a:prstGeom prst="rect">
             <a:avLst/>
@@ -8735,8 +9343,8 @@
         </p:nvSpPr>
         <p:spPr>
           <a:xfrm>
-            <a:off x="457200" y="3877056"/>
-            <a:ext cx="8229600" cy="603504"/>
+            <a:off x="457200" y="3657600"/>
+            <a:ext cx="8229600" cy="548640"/>
           </a:xfrm>
           <a:prstGeom prst="rect">
             <a:avLst/>
@@ -8760,8 +9368,8 @@
         </p:nvSpPr>
         <p:spPr>
           <a:xfrm>
-            <a:off x="502920" y="3922776"/>
-            <a:ext cx="914400" cy="512064"/>
+            <a:off x="502920" y="3685032"/>
+            <a:ext cx="914400" cy="493776"/>
           </a:xfrm>
           <a:prstGeom prst="rect">
             <a:avLst/>
@@ -8799,8 +9407,8 @@
         </p:nvSpPr>
         <p:spPr>
           <a:xfrm>
-            <a:off x="1417320" y="3922776"/>
-            <a:ext cx="3566160" cy="512064"/>
+            <a:off x="1417320" y="3685032"/>
+            <a:ext cx="3566160" cy="493776"/>
           </a:xfrm>
           <a:prstGeom prst="rect">
             <a:avLst/>
@@ -8838,8 +9446,8 @@
         </p:nvSpPr>
         <p:spPr>
           <a:xfrm>
-            <a:off x="5120640" y="3922776"/>
-            <a:ext cx="3520440" cy="512064"/>
+            <a:off x="5120640" y="3685032"/>
+            <a:ext cx="3520440" cy="493776"/>
           </a:xfrm>
           <a:prstGeom prst="rect">
             <a:avLst/>
@@ -8877,7 +9485,7 @@
         </p:nvSpPr>
         <p:spPr>
           <a:xfrm>
-            <a:off x="457200" y="4315968"/>
+            <a:off x="457200" y="4279392"/>
             <a:ext cx="8229600" cy="457200"/>
           </a:xfrm>
           <a:prstGeom prst="rect">
@@ -8902,7 +9510,7 @@
                 <a:ea typeface="Calibri" pitchFamily="34" charset="-122"/>
                 <a:cs typeface="Calibri" pitchFamily="34" charset="-120"/>
               </a:rPr>
-              <a:t>None of these needed a rewrite. Keeping every tunable in one configuration module, and every external call behind one small client, is what made each fix a line or two - and adding a second source one new module. Commits run from 9 to 30 September, roughly one per stage.</a:t>
+              <a:t>None of these needed a rewrite: settings in one module and each service behind one small client kept the fixes small, and the second source was one new module. Commits start on 9 Sept, about one per stage, the tests growing from 5 to 68; a read-through on 1 Oct added ten more entries (remediation log #12-#21) and took the tests to 113; five live tests on 2 Oct ran the corrected code.</a:t>
             </a:r>
             <a:endParaRPr lang="en-US" sz="1050" dirty="0"/>
           </a:p>

</xml_diff>